<commit_message>
Update the section 3.1 of the MQTT comm lib.
</commit_message>
<xml_diff>
--- a/MQTT_RTU_Simulator/doc/designDoc.pptx
+++ b/MQTT_RTU_Simulator/doc/designDoc.pptx
@@ -6,6 +6,7 @@
   </p:sldMasterIdLst>
   <p:sldIdLst>
     <p:sldId id="256" r:id="rId2"/>
+    <p:sldId id="257" r:id="rId3"/>
   </p:sldIdLst>
   <p:sldSz cx="12192000" cy="6858000"/>
   <p:notesSz cx="6858000" cy="9144000"/>
@@ -5597,6 +5598,36 @@
     <p:extLst>
       <p:ext uri="{BB962C8B-B14F-4D97-AF65-F5344CB8AC3E}">
         <p14:creationId xmlns:p14="http://schemas.microsoft.com/office/powerpoint/2010/main" val="3696190865"/>
+      </p:ext>
+    </p:extLst>
+  </p:cSld>
+  <p:clrMapOvr>
+    <a:masterClrMapping/>
+  </p:clrMapOvr>
+</p:sld>
+</file>
+
+<file path=ppt/slides/slide2.xml><?xml version="1.0" encoding="utf-8"?>
+<p:sld xmlns:a="http://schemas.openxmlformats.org/drawingml/2006/main" xmlns:r="http://schemas.openxmlformats.org/officeDocument/2006/relationships" xmlns:p="http://schemas.openxmlformats.org/presentationml/2006/main">
+  <p:cSld>
+    <p:spTree>
+      <p:nvGrpSpPr>
+        <p:cNvPr id="1" name=""/>
+        <p:cNvGrpSpPr/>
+        <p:nvPr/>
+      </p:nvGrpSpPr>
+      <p:grpSpPr>
+        <a:xfrm>
+          <a:off x="0" y="0"/>
+          <a:ext cx="0" cy="0"/>
+          <a:chOff x="0" y="0"/>
+          <a:chExt cx="0" cy="0"/>
+        </a:xfrm>
+      </p:grpSpPr>
+    </p:spTree>
+    <p:extLst>
+      <p:ext uri="{BB962C8B-B14F-4D97-AF65-F5344CB8AC3E}">
+        <p14:creationId xmlns:p14="http://schemas.microsoft.com/office/powerpoint/2010/main" val="4116987690"/>
       </p:ext>
     </p:extLst>
   </p:cSld>

</xml_diff>

<commit_message>
Update the MQTT module design section.
</commit_message>
<xml_diff>
--- a/MQTT_RTU_Simulator/doc/designDoc.pptx
+++ b/MQTT_RTU_Simulator/doc/designDoc.pptx
@@ -4,9 +4,13 @@
   <p:sldMasterIdLst>
     <p:sldMasterId id="2147483648" r:id="rId1"/>
   </p:sldMasterIdLst>
+  <p:notesMasterIdLst>
+    <p:notesMasterId r:id="rId5"/>
+  </p:notesMasterIdLst>
   <p:sldIdLst>
     <p:sldId id="256" r:id="rId2"/>
     <p:sldId id="257" r:id="rId3"/>
+    <p:sldId id="259" r:id="rId4"/>
   </p:sldIdLst>
   <p:sldSz cx="12192000" cy="6858000"/>
   <p:notesSz cx="6858000" cy="9144000"/>
@@ -105,7 +109,446 @@
       </a:defRPr>
     </a:lvl9pPr>
   </p:defaultTextStyle>
+  <p:extLst>
+    <p:ext uri="{EFAFB233-063F-42B5-8137-9DF3F51BA10A}">
+      <p15:sldGuideLst xmlns:p15="http://schemas.microsoft.com/office/powerpoint/2012/main"/>
+    </p:ext>
+  </p:extLst>
 </p:presentation>
+</file>
+
+<file path=ppt/notesMasters/notesMaster1.xml><?xml version="1.0" encoding="utf-8"?>
+<p:notesMaster xmlns:a="http://schemas.openxmlformats.org/drawingml/2006/main" xmlns:r="http://schemas.openxmlformats.org/officeDocument/2006/relationships" xmlns:p="http://schemas.openxmlformats.org/presentationml/2006/main">
+  <p:cSld>
+    <p:bg>
+      <p:bgRef idx="1001">
+        <a:schemeClr val="bg1"/>
+      </p:bgRef>
+    </p:bg>
+    <p:spTree>
+      <p:nvGrpSpPr>
+        <p:cNvPr id="1" name=""/>
+        <p:cNvGrpSpPr/>
+        <p:nvPr/>
+      </p:nvGrpSpPr>
+      <p:grpSpPr>
+        <a:xfrm>
+          <a:off x="0" y="0"/>
+          <a:ext cx="0" cy="0"/>
+          <a:chOff x="0" y="0"/>
+          <a:chExt cx="0" cy="0"/>
+        </a:xfrm>
+      </p:grpSpPr>
+      <p:sp>
+        <p:nvSpPr>
+          <p:cNvPr id="2" name="Header Placeholder 1"/>
+          <p:cNvSpPr>
+            <a:spLocks noGrp="1"/>
+          </p:cNvSpPr>
+          <p:nvPr>
+            <p:ph type="hdr" sz="quarter"/>
+          </p:nvPr>
+        </p:nvSpPr>
+        <p:spPr>
+          <a:xfrm>
+            <a:off x="0" y="0"/>
+            <a:ext cx="2971800" cy="458788"/>
+          </a:xfrm>
+          <a:prstGeom prst="rect">
+            <a:avLst/>
+          </a:prstGeom>
+        </p:spPr>
+        <p:txBody>
+          <a:bodyPr vert="horz" lIns="91440" tIns="45720" rIns="91440" bIns="45720" rtlCol="0"/>
+          <a:lstStyle>
+            <a:lvl1pPr algn="l">
+              <a:defRPr sz="1200"/>
+            </a:lvl1pPr>
+          </a:lstStyle>
+          <a:p>
+            <a:endParaRPr lang="en-SG"/>
+          </a:p>
+        </p:txBody>
+      </p:sp>
+      <p:sp>
+        <p:nvSpPr>
+          <p:cNvPr id="3" name="Date Placeholder 2"/>
+          <p:cNvSpPr>
+            <a:spLocks noGrp="1"/>
+          </p:cNvSpPr>
+          <p:nvPr>
+            <p:ph type="dt" idx="1"/>
+          </p:nvPr>
+        </p:nvSpPr>
+        <p:spPr>
+          <a:xfrm>
+            <a:off x="3884613" y="0"/>
+            <a:ext cx="2971800" cy="458788"/>
+          </a:xfrm>
+          <a:prstGeom prst="rect">
+            <a:avLst/>
+          </a:prstGeom>
+        </p:spPr>
+        <p:txBody>
+          <a:bodyPr vert="horz" lIns="91440" tIns="45720" rIns="91440" bIns="45720" rtlCol="0"/>
+          <a:lstStyle>
+            <a:lvl1pPr algn="r">
+              <a:defRPr sz="1200"/>
+            </a:lvl1pPr>
+          </a:lstStyle>
+          <a:p>
+            <a:fld id="{8AE52297-66E0-4839-ACCC-742E4BD155E6}" type="datetimeFigureOut">
+              <a:rPr lang="en-SG" smtClean="0"/>
+              <a:t>5/6/2026</a:t>
+            </a:fld>
+            <a:endParaRPr lang="en-SG"/>
+          </a:p>
+        </p:txBody>
+      </p:sp>
+      <p:sp>
+        <p:nvSpPr>
+          <p:cNvPr id="4" name="Slide Image Placeholder 3"/>
+          <p:cNvSpPr>
+            <a:spLocks noGrp="1" noRot="1" noChangeAspect="1"/>
+          </p:cNvSpPr>
+          <p:nvPr>
+            <p:ph type="sldImg" idx="2"/>
+          </p:nvPr>
+        </p:nvSpPr>
+        <p:spPr>
+          <a:xfrm>
+            <a:off x="685800" y="1143000"/>
+            <a:ext cx="5486400" cy="3086100"/>
+          </a:xfrm>
+          <a:prstGeom prst="rect">
+            <a:avLst/>
+          </a:prstGeom>
+          <a:noFill/>
+          <a:ln w="12700">
+            <a:solidFill>
+              <a:prstClr val="black"/>
+            </a:solidFill>
+          </a:ln>
+        </p:spPr>
+        <p:txBody>
+          <a:bodyPr vert="horz" lIns="91440" tIns="45720" rIns="91440" bIns="45720" rtlCol="0" anchor="ctr"/>
+          <a:lstStyle/>
+          <a:p>
+            <a:endParaRPr lang="en-SG"/>
+          </a:p>
+        </p:txBody>
+      </p:sp>
+      <p:sp>
+        <p:nvSpPr>
+          <p:cNvPr id="5" name="Notes Placeholder 4"/>
+          <p:cNvSpPr>
+            <a:spLocks noGrp="1"/>
+          </p:cNvSpPr>
+          <p:nvPr>
+            <p:ph type="body" sz="quarter" idx="3"/>
+          </p:nvPr>
+        </p:nvSpPr>
+        <p:spPr>
+          <a:xfrm>
+            <a:off x="685800" y="4400550"/>
+            <a:ext cx="5486400" cy="3600450"/>
+          </a:xfrm>
+          <a:prstGeom prst="rect">
+            <a:avLst/>
+          </a:prstGeom>
+        </p:spPr>
+        <p:txBody>
+          <a:bodyPr vert="horz" lIns="91440" tIns="45720" rIns="91440" bIns="45720" rtlCol="0"/>
+          <a:lstStyle/>
+          <a:p>
+            <a:pPr lvl="0"/>
+            <a:r>
+              <a:rPr lang="en-US"/>
+              <a:t>Click to edit Master text styles</a:t>
+            </a:r>
+          </a:p>
+          <a:p>
+            <a:pPr lvl="1"/>
+            <a:r>
+              <a:rPr lang="en-US"/>
+              <a:t>Second level</a:t>
+            </a:r>
+          </a:p>
+          <a:p>
+            <a:pPr lvl="2"/>
+            <a:r>
+              <a:rPr lang="en-US"/>
+              <a:t>Third level</a:t>
+            </a:r>
+          </a:p>
+          <a:p>
+            <a:pPr lvl="3"/>
+            <a:r>
+              <a:rPr lang="en-US"/>
+              <a:t>Fourth level</a:t>
+            </a:r>
+          </a:p>
+          <a:p>
+            <a:pPr lvl="4"/>
+            <a:r>
+              <a:rPr lang="en-US"/>
+              <a:t>Fifth level</a:t>
+            </a:r>
+            <a:endParaRPr lang="en-SG"/>
+          </a:p>
+        </p:txBody>
+      </p:sp>
+      <p:sp>
+        <p:nvSpPr>
+          <p:cNvPr id="6" name="Footer Placeholder 5"/>
+          <p:cNvSpPr>
+            <a:spLocks noGrp="1"/>
+          </p:cNvSpPr>
+          <p:nvPr>
+            <p:ph type="ftr" sz="quarter" idx="4"/>
+          </p:nvPr>
+        </p:nvSpPr>
+        <p:spPr>
+          <a:xfrm>
+            <a:off x="0" y="8685213"/>
+            <a:ext cx="2971800" cy="458787"/>
+          </a:xfrm>
+          <a:prstGeom prst="rect">
+            <a:avLst/>
+          </a:prstGeom>
+        </p:spPr>
+        <p:txBody>
+          <a:bodyPr vert="horz" lIns="91440" tIns="45720" rIns="91440" bIns="45720" rtlCol="0" anchor="b"/>
+          <a:lstStyle>
+            <a:lvl1pPr algn="l">
+              <a:defRPr sz="1200"/>
+            </a:lvl1pPr>
+          </a:lstStyle>
+          <a:p>
+            <a:endParaRPr lang="en-SG"/>
+          </a:p>
+        </p:txBody>
+      </p:sp>
+      <p:sp>
+        <p:nvSpPr>
+          <p:cNvPr id="7" name="Slide Number Placeholder 6"/>
+          <p:cNvSpPr>
+            <a:spLocks noGrp="1"/>
+          </p:cNvSpPr>
+          <p:nvPr>
+            <p:ph type="sldNum" sz="quarter" idx="5"/>
+          </p:nvPr>
+        </p:nvSpPr>
+        <p:spPr>
+          <a:xfrm>
+            <a:off x="3884613" y="8685213"/>
+            <a:ext cx="2971800" cy="458787"/>
+          </a:xfrm>
+          <a:prstGeom prst="rect">
+            <a:avLst/>
+          </a:prstGeom>
+        </p:spPr>
+        <p:txBody>
+          <a:bodyPr vert="horz" lIns="91440" tIns="45720" rIns="91440" bIns="45720" rtlCol="0" anchor="b"/>
+          <a:lstStyle>
+            <a:lvl1pPr algn="r">
+              <a:defRPr sz="1200"/>
+            </a:lvl1pPr>
+          </a:lstStyle>
+          <a:p>
+            <a:fld id="{EBF6B7D6-7851-49B5-BE5D-D00B7BAA4937}" type="slidenum">
+              <a:rPr lang="en-SG" smtClean="0"/>
+              <a:t>‹#›</a:t>
+            </a:fld>
+            <a:endParaRPr lang="en-SG"/>
+          </a:p>
+        </p:txBody>
+      </p:sp>
+    </p:spTree>
+    <p:extLst>
+      <p:ext uri="{BB962C8B-B14F-4D97-AF65-F5344CB8AC3E}">
+        <p14:creationId xmlns:p14="http://schemas.microsoft.com/office/powerpoint/2010/main" val="2517954128"/>
+      </p:ext>
+    </p:extLst>
+  </p:cSld>
+  <p:clrMap bg1="lt1" tx1="dk1" bg2="lt2" tx2="dk2" accent1="accent1" accent2="accent2" accent3="accent3" accent4="accent4" accent5="accent5" accent6="accent6" hlink="hlink" folHlink="folHlink"/>
+  <p:notesStyle>
+    <a:lvl1pPr marL="0" algn="l" defTabSz="914400" rtl="0" eaLnBrk="1" latinLnBrk="0" hangingPunct="1">
+      <a:defRPr sz="1200" kern="1200">
+        <a:solidFill>
+          <a:schemeClr val="tx1"/>
+        </a:solidFill>
+        <a:latin typeface="+mn-lt"/>
+        <a:ea typeface="+mn-ea"/>
+        <a:cs typeface="+mn-cs"/>
+      </a:defRPr>
+    </a:lvl1pPr>
+    <a:lvl2pPr marL="457200" algn="l" defTabSz="914400" rtl="0" eaLnBrk="1" latinLnBrk="0" hangingPunct="1">
+      <a:defRPr sz="1200" kern="1200">
+        <a:solidFill>
+          <a:schemeClr val="tx1"/>
+        </a:solidFill>
+        <a:latin typeface="+mn-lt"/>
+        <a:ea typeface="+mn-ea"/>
+        <a:cs typeface="+mn-cs"/>
+      </a:defRPr>
+    </a:lvl2pPr>
+    <a:lvl3pPr marL="914400" algn="l" defTabSz="914400" rtl="0" eaLnBrk="1" latinLnBrk="0" hangingPunct="1">
+      <a:defRPr sz="1200" kern="1200">
+        <a:solidFill>
+          <a:schemeClr val="tx1"/>
+        </a:solidFill>
+        <a:latin typeface="+mn-lt"/>
+        <a:ea typeface="+mn-ea"/>
+        <a:cs typeface="+mn-cs"/>
+      </a:defRPr>
+    </a:lvl3pPr>
+    <a:lvl4pPr marL="1371600" algn="l" defTabSz="914400" rtl="0" eaLnBrk="1" latinLnBrk="0" hangingPunct="1">
+      <a:defRPr sz="1200" kern="1200">
+        <a:solidFill>
+          <a:schemeClr val="tx1"/>
+        </a:solidFill>
+        <a:latin typeface="+mn-lt"/>
+        <a:ea typeface="+mn-ea"/>
+        <a:cs typeface="+mn-cs"/>
+      </a:defRPr>
+    </a:lvl4pPr>
+    <a:lvl5pPr marL="1828800" algn="l" defTabSz="914400" rtl="0" eaLnBrk="1" latinLnBrk="0" hangingPunct="1">
+      <a:defRPr sz="1200" kern="1200">
+        <a:solidFill>
+          <a:schemeClr val="tx1"/>
+        </a:solidFill>
+        <a:latin typeface="+mn-lt"/>
+        <a:ea typeface="+mn-ea"/>
+        <a:cs typeface="+mn-cs"/>
+      </a:defRPr>
+    </a:lvl5pPr>
+    <a:lvl6pPr marL="2286000" algn="l" defTabSz="914400" rtl="0" eaLnBrk="1" latinLnBrk="0" hangingPunct="1">
+      <a:defRPr sz="1200" kern="1200">
+        <a:solidFill>
+          <a:schemeClr val="tx1"/>
+        </a:solidFill>
+        <a:latin typeface="+mn-lt"/>
+        <a:ea typeface="+mn-ea"/>
+        <a:cs typeface="+mn-cs"/>
+      </a:defRPr>
+    </a:lvl6pPr>
+    <a:lvl7pPr marL="2743200" algn="l" defTabSz="914400" rtl="0" eaLnBrk="1" latinLnBrk="0" hangingPunct="1">
+      <a:defRPr sz="1200" kern="1200">
+        <a:solidFill>
+          <a:schemeClr val="tx1"/>
+        </a:solidFill>
+        <a:latin typeface="+mn-lt"/>
+        <a:ea typeface="+mn-ea"/>
+        <a:cs typeface="+mn-cs"/>
+      </a:defRPr>
+    </a:lvl7pPr>
+    <a:lvl8pPr marL="3200400" algn="l" defTabSz="914400" rtl="0" eaLnBrk="1" latinLnBrk="0" hangingPunct="1">
+      <a:defRPr sz="1200" kern="1200">
+        <a:solidFill>
+          <a:schemeClr val="tx1"/>
+        </a:solidFill>
+        <a:latin typeface="+mn-lt"/>
+        <a:ea typeface="+mn-ea"/>
+        <a:cs typeface="+mn-cs"/>
+      </a:defRPr>
+    </a:lvl8pPr>
+    <a:lvl9pPr marL="3657600" algn="l" defTabSz="914400" rtl="0" eaLnBrk="1" latinLnBrk="0" hangingPunct="1">
+      <a:defRPr sz="1200" kern="1200">
+        <a:solidFill>
+          <a:schemeClr val="tx1"/>
+        </a:solidFill>
+        <a:latin typeface="+mn-lt"/>
+        <a:ea typeface="+mn-ea"/>
+        <a:cs typeface="+mn-cs"/>
+      </a:defRPr>
+    </a:lvl9pPr>
+  </p:notesStyle>
+</p:notesMaster>
+</file>
+
+<file path=ppt/notesSlides/notesSlide1.xml><?xml version="1.0" encoding="utf-8"?>
+<p:notes xmlns:a="http://schemas.openxmlformats.org/drawingml/2006/main" xmlns:r="http://schemas.openxmlformats.org/officeDocument/2006/relationships" xmlns:p="http://schemas.openxmlformats.org/presentationml/2006/main">
+  <p:cSld>
+    <p:spTree>
+      <p:nvGrpSpPr>
+        <p:cNvPr id="1" name=""/>
+        <p:cNvGrpSpPr/>
+        <p:nvPr/>
+      </p:nvGrpSpPr>
+      <p:grpSpPr>
+        <a:xfrm>
+          <a:off x="0" y="0"/>
+          <a:ext cx="0" cy="0"/>
+          <a:chOff x="0" y="0"/>
+          <a:chExt cx="0" cy="0"/>
+        </a:xfrm>
+      </p:grpSpPr>
+      <p:sp>
+        <p:nvSpPr>
+          <p:cNvPr id="2" name="Slide Image Placeholder 1"/>
+          <p:cNvSpPr>
+            <a:spLocks noGrp="1" noRot="1" noChangeAspect="1"/>
+          </p:cNvSpPr>
+          <p:nvPr>
+            <p:ph type="sldImg"/>
+          </p:nvPr>
+        </p:nvSpPr>
+        <p:spPr/>
+      </p:sp>
+      <p:sp>
+        <p:nvSpPr>
+          <p:cNvPr id="3" name="Notes Placeholder 2"/>
+          <p:cNvSpPr>
+            <a:spLocks noGrp="1"/>
+          </p:cNvSpPr>
+          <p:nvPr>
+            <p:ph type="body" idx="1"/>
+          </p:nvPr>
+        </p:nvSpPr>
+        <p:spPr/>
+        <p:txBody>
+          <a:bodyPr/>
+          <a:lstStyle/>
+          <a:p>
+            <a:endParaRPr lang="en-SG"/>
+          </a:p>
+        </p:txBody>
+      </p:sp>
+      <p:sp>
+        <p:nvSpPr>
+          <p:cNvPr id="4" name="Slide Number Placeholder 3"/>
+          <p:cNvSpPr>
+            <a:spLocks noGrp="1"/>
+          </p:cNvSpPr>
+          <p:nvPr>
+            <p:ph type="sldNum" sz="quarter" idx="5"/>
+          </p:nvPr>
+        </p:nvSpPr>
+        <p:spPr/>
+        <p:txBody>
+          <a:bodyPr/>
+          <a:lstStyle/>
+          <a:p>
+            <a:fld id="{EBF6B7D6-7851-49B5-BE5D-D00B7BAA4937}" type="slidenum">
+              <a:rPr lang="en-SG" smtClean="0"/>
+              <a:t>3</a:t>
+            </a:fld>
+            <a:endParaRPr lang="en-SG"/>
+          </a:p>
+        </p:txBody>
+      </p:sp>
+    </p:spTree>
+    <p:extLst>
+      <p:ext uri="{BB962C8B-B14F-4D97-AF65-F5344CB8AC3E}">
+        <p14:creationId xmlns:p14="http://schemas.microsoft.com/office/powerpoint/2010/main" val="3907934090"/>
+      </p:ext>
+    </p:extLst>
+  </p:cSld>
+  <p:clrMapOvr>
+    <a:masterClrMapping/>
+  </p:clrMapOvr>
+</p:notes>
 </file>
 
 <file path=ppt/slideLayouts/slideLayout1.xml><?xml version="1.0" encoding="utf-8"?>
@@ -257,7 +700,7 @@
           <a:p>
             <a:fld id="{605C4233-9FD4-48E0-99C1-555DE8AF0C0C}" type="datetimeFigureOut">
               <a:rPr lang="en-SG" smtClean="0"/>
-              <a:t>3/6/2026</a:t>
+              <a:t>5/6/2026</a:t>
             </a:fld>
             <a:endParaRPr lang="en-SG"/>
           </a:p>
@@ -457,7 +900,7 @@
           <a:p>
             <a:fld id="{605C4233-9FD4-48E0-99C1-555DE8AF0C0C}" type="datetimeFigureOut">
               <a:rPr lang="en-SG" smtClean="0"/>
-              <a:t>3/6/2026</a:t>
+              <a:t>5/6/2026</a:t>
             </a:fld>
             <a:endParaRPr lang="en-SG"/>
           </a:p>
@@ -667,7 +1110,7 @@
           <a:p>
             <a:fld id="{605C4233-9FD4-48E0-99C1-555DE8AF0C0C}" type="datetimeFigureOut">
               <a:rPr lang="en-SG" smtClean="0"/>
-              <a:t>3/6/2026</a:t>
+              <a:t>5/6/2026</a:t>
             </a:fld>
             <a:endParaRPr lang="en-SG"/>
           </a:p>
@@ -867,7 +1310,7 @@
           <a:p>
             <a:fld id="{605C4233-9FD4-48E0-99C1-555DE8AF0C0C}" type="datetimeFigureOut">
               <a:rPr lang="en-SG" smtClean="0"/>
-              <a:t>3/6/2026</a:t>
+              <a:t>5/6/2026</a:t>
             </a:fld>
             <a:endParaRPr lang="en-SG"/>
           </a:p>
@@ -1143,7 +1586,7 @@
           <a:p>
             <a:fld id="{605C4233-9FD4-48E0-99C1-555DE8AF0C0C}" type="datetimeFigureOut">
               <a:rPr lang="en-SG" smtClean="0"/>
-              <a:t>3/6/2026</a:t>
+              <a:t>5/6/2026</a:t>
             </a:fld>
             <a:endParaRPr lang="en-SG"/>
           </a:p>
@@ -1411,7 +1854,7 @@
           <a:p>
             <a:fld id="{605C4233-9FD4-48E0-99C1-555DE8AF0C0C}" type="datetimeFigureOut">
               <a:rPr lang="en-SG" smtClean="0"/>
-              <a:t>3/6/2026</a:t>
+              <a:t>5/6/2026</a:t>
             </a:fld>
             <a:endParaRPr lang="en-SG"/>
           </a:p>
@@ -1826,7 +2269,7 @@
           <a:p>
             <a:fld id="{605C4233-9FD4-48E0-99C1-555DE8AF0C0C}" type="datetimeFigureOut">
               <a:rPr lang="en-SG" smtClean="0"/>
-              <a:t>3/6/2026</a:t>
+              <a:t>5/6/2026</a:t>
             </a:fld>
             <a:endParaRPr lang="en-SG"/>
           </a:p>
@@ -1968,7 +2411,7 @@
           <a:p>
             <a:fld id="{605C4233-9FD4-48E0-99C1-555DE8AF0C0C}" type="datetimeFigureOut">
               <a:rPr lang="en-SG" smtClean="0"/>
-              <a:t>3/6/2026</a:t>
+              <a:t>5/6/2026</a:t>
             </a:fld>
             <a:endParaRPr lang="en-SG"/>
           </a:p>
@@ -2081,7 +2524,7 @@
           <a:p>
             <a:fld id="{605C4233-9FD4-48E0-99C1-555DE8AF0C0C}" type="datetimeFigureOut">
               <a:rPr lang="en-SG" smtClean="0"/>
-              <a:t>3/6/2026</a:t>
+              <a:t>5/6/2026</a:t>
             </a:fld>
             <a:endParaRPr lang="en-SG"/>
           </a:p>
@@ -2394,7 +2837,7 @@
           <a:p>
             <a:fld id="{605C4233-9FD4-48E0-99C1-555DE8AF0C0C}" type="datetimeFigureOut">
               <a:rPr lang="en-SG" smtClean="0"/>
-              <a:t>3/6/2026</a:t>
+              <a:t>5/6/2026</a:t>
             </a:fld>
             <a:endParaRPr lang="en-SG"/>
           </a:p>
@@ -2683,7 +3126,7 @@
           <a:p>
             <a:fld id="{605C4233-9FD4-48E0-99C1-555DE8AF0C0C}" type="datetimeFigureOut">
               <a:rPr lang="en-SG" smtClean="0"/>
-              <a:t>3/6/2026</a:t>
+              <a:t>5/6/2026</a:t>
             </a:fld>
             <a:endParaRPr lang="en-SG"/>
           </a:p>
@@ -2926,7 +3369,7 @@
           <a:p>
             <a:fld id="{605C4233-9FD4-48E0-99C1-555DE8AF0C0C}" type="datetimeFigureOut">
               <a:rPr lang="en-SG" smtClean="0"/>
-              <a:t>3/6/2026</a:t>
+              <a:t>5/6/2026</a:t>
             </a:fld>
             <a:endParaRPr lang="en-SG"/>
           </a:p>
@@ -5628,6 +6071,2869 @@
     <p:extLst>
       <p:ext uri="{BB962C8B-B14F-4D97-AF65-F5344CB8AC3E}">
         <p14:creationId xmlns:p14="http://schemas.microsoft.com/office/powerpoint/2010/main" val="4116987690"/>
+      </p:ext>
+    </p:extLst>
+  </p:cSld>
+  <p:clrMapOvr>
+    <a:masterClrMapping/>
+  </p:clrMapOvr>
+</p:sld>
+</file>
+
+<file path=ppt/slides/slide3.xml><?xml version="1.0" encoding="utf-8"?>
+<p:sld xmlns:a="http://schemas.openxmlformats.org/drawingml/2006/main" xmlns:r="http://schemas.openxmlformats.org/officeDocument/2006/relationships" xmlns:p="http://schemas.openxmlformats.org/presentationml/2006/main">
+  <p:cSld>
+    <p:spTree>
+      <p:nvGrpSpPr>
+        <p:cNvPr id="1" name=""/>
+        <p:cNvGrpSpPr/>
+        <p:nvPr/>
+      </p:nvGrpSpPr>
+      <p:grpSpPr>
+        <a:xfrm>
+          <a:off x="0" y="0"/>
+          <a:ext cx="0" cy="0"/>
+          <a:chOff x="0" y="0"/>
+          <a:chExt cx="0" cy="0"/>
+        </a:xfrm>
+      </p:grpSpPr>
+      <p:sp>
+        <p:nvSpPr>
+          <p:cNvPr id="78" name="Rectangle 77">
+            <a:extLst>
+              <a:ext uri="{FF2B5EF4-FFF2-40B4-BE49-F238E27FC236}">
+                <a16:creationId xmlns:a16="http://schemas.microsoft.com/office/drawing/2014/main" id="{A153CD48-D451-ADB0-EF08-EB3856D4FCCA}"/>
+              </a:ext>
+            </a:extLst>
+          </p:cNvPr>
+          <p:cNvSpPr/>
+          <p:nvPr/>
+        </p:nvSpPr>
+        <p:spPr>
+          <a:xfrm>
+            <a:off x="4530382" y="1304591"/>
+            <a:ext cx="2111994" cy="842526"/>
+          </a:xfrm>
+          <a:prstGeom prst="rect">
+            <a:avLst/>
+          </a:prstGeom>
+          <a:solidFill>
+            <a:schemeClr val="accent6">
+              <a:lumMod val="20000"/>
+              <a:lumOff val="80000"/>
+            </a:schemeClr>
+          </a:solidFill>
+        </p:spPr>
+        <p:style>
+          <a:lnRef idx="2">
+            <a:schemeClr val="accent1">
+              <a:shade val="15000"/>
+            </a:schemeClr>
+          </a:lnRef>
+          <a:fillRef idx="1">
+            <a:schemeClr val="accent1"/>
+          </a:fillRef>
+          <a:effectRef idx="0">
+            <a:schemeClr val="accent1"/>
+          </a:effectRef>
+          <a:fontRef idx="minor">
+            <a:schemeClr val="lt1"/>
+          </a:fontRef>
+        </p:style>
+        <p:txBody>
+          <a:bodyPr rtlCol="0" anchor="ctr"/>
+          <a:lstStyle/>
+          <a:p>
+            <a:pPr algn="ctr"/>
+            <a:endParaRPr lang="en-SG" dirty="0"/>
+          </a:p>
+        </p:txBody>
+      </p:sp>
+      <p:sp>
+        <p:nvSpPr>
+          <p:cNvPr id="169" name="Rectangle 168">
+            <a:extLst>
+              <a:ext uri="{FF2B5EF4-FFF2-40B4-BE49-F238E27FC236}">
+                <a16:creationId xmlns:a16="http://schemas.microsoft.com/office/drawing/2014/main" id="{AD62D43B-87AF-8B47-C09B-D66D20BC37BD}"/>
+              </a:ext>
+            </a:extLst>
+          </p:cNvPr>
+          <p:cNvSpPr/>
+          <p:nvPr/>
+        </p:nvSpPr>
+        <p:spPr>
+          <a:xfrm>
+            <a:off x="8178872" y="3614553"/>
+            <a:ext cx="2931492" cy="1846356"/>
+          </a:xfrm>
+          <a:prstGeom prst="rect">
+            <a:avLst/>
+          </a:prstGeom>
+          <a:solidFill>
+            <a:schemeClr val="accent5">
+              <a:lumMod val="20000"/>
+              <a:lumOff val="80000"/>
+            </a:schemeClr>
+          </a:solidFill>
+        </p:spPr>
+        <p:style>
+          <a:lnRef idx="2">
+            <a:schemeClr val="accent1">
+              <a:shade val="15000"/>
+            </a:schemeClr>
+          </a:lnRef>
+          <a:fillRef idx="1">
+            <a:schemeClr val="accent1"/>
+          </a:fillRef>
+          <a:effectRef idx="0">
+            <a:schemeClr val="accent1"/>
+          </a:effectRef>
+          <a:fontRef idx="minor">
+            <a:schemeClr val="lt1"/>
+          </a:fontRef>
+        </p:style>
+        <p:txBody>
+          <a:bodyPr rtlCol="0" anchor="ctr"/>
+          <a:lstStyle/>
+          <a:p>
+            <a:pPr algn="ctr"/>
+            <a:endParaRPr lang="en-SG" dirty="0"/>
+          </a:p>
+        </p:txBody>
+      </p:sp>
+      <p:sp>
+        <p:nvSpPr>
+          <p:cNvPr id="66" name="Rectangle 65">
+            <a:extLst>
+              <a:ext uri="{FF2B5EF4-FFF2-40B4-BE49-F238E27FC236}">
+                <a16:creationId xmlns:a16="http://schemas.microsoft.com/office/drawing/2014/main" id="{837A8677-8040-C491-6D80-73149652E6CE}"/>
+              </a:ext>
+            </a:extLst>
+          </p:cNvPr>
+          <p:cNvSpPr/>
+          <p:nvPr/>
+        </p:nvSpPr>
+        <p:spPr>
+          <a:xfrm>
+            <a:off x="4543840" y="2419754"/>
+            <a:ext cx="2489871" cy="2995813"/>
+          </a:xfrm>
+          <a:prstGeom prst="rect">
+            <a:avLst/>
+          </a:prstGeom>
+          <a:solidFill>
+            <a:schemeClr val="accent6">
+              <a:lumMod val="20000"/>
+              <a:lumOff val="80000"/>
+            </a:schemeClr>
+          </a:solidFill>
+        </p:spPr>
+        <p:style>
+          <a:lnRef idx="2">
+            <a:schemeClr val="accent1">
+              <a:shade val="15000"/>
+            </a:schemeClr>
+          </a:lnRef>
+          <a:fillRef idx="1">
+            <a:schemeClr val="accent1"/>
+          </a:fillRef>
+          <a:effectRef idx="0">
+            <a:schemeClr val="accent1"/>
+          </a:effectRef>
+          <a:fontRef idx="minor">
+            <a:schemeClr val="lt1"/>
+          </a:fontRef>
+        </p:style>
+        <p:txBody>
+          <a:bodyPr rtlCol="0" anchor="ctr"/>
+          <a:lstStyle/>
+          <a:p>
+            <a:pPr algn="ctr"/>
+            <a:endParaRPr lang="en-SG" dirty="0"/>
+          </a:p>
+        </p:txBody>
+      </p:sp>
+      <p:sp>
+        <p:nvSpPr>
+          <p:cNvPr id="4" name="Rectangle 3">
+            <a:extLst>
+              <a:ext uri="{FF2B5EF4-FFF2-40B4-BE49-F238E27FC236}">
+                <a16:creationId xmlns:a16="http://schemas.microsoft.com/office/drawing/2014/main" id="{ED7DD3D4-6B5E-7CB5-E003-2C037546352E}"/>
+              </a:ext>
+            </a:extLst>
+          </p:cNvPr>
+          <p:cNvSpPr/>
+          <p:nvPr/>
+        </p:nvSpPr>
+        <p:spPr>
+          <a:xfrm>
+            <a:off x="548582" y="851571"/>
+            <a:ext cx="3413179" cy="4609338"/>
+          </a:xfrm>
+          <a:prstGeom prst="rect">
+            <a:avLst/>
+          </a:prstGeom>
+          <a:solidFill>
+            <a:schemeClr val="accent1">
+              <a:lumMod val="20000"/>
+              <a:lumOff val="80000"/>
+            </a:schemeClr>
+          </a:solidFill>
+        </p:spPr>
+        <p:style>
+          <a:lnRef idx="2">
+            <a:schemeClr val="accent1">
+              <a:shade val="15000"/>
+            </a:schemeClr>
+          </a:lnRef>
+          <a:fillRef idx="1">
+            <a:schemeClr val="accent1"/>
+          </a:fillRef>
+          <a:effectRef idx="0">
+            <a:schemeClr val="accent1"/>
+          </a:effectRef>
+          <a:fontRef idx="minor">
+            <a:schemeClr val="lt1"/>
+          </a:fontRef>
+        </p:style>
+        <p:txBody>
+          <a:bodyPr rtlCol="0" anchor="ctr"/>
+          <a:lstStyle/>
+          <a:p>
+            <a:pPr algn="ctr"/>
+            <a:endParaRPr lang="en-SG" dirty="0"/>
+          </a:p>
+        </p:txBody>
+      </p:sp>
+      <p:sp>
+        <p:nvSpPr>
+          <p:cNvPr id="5" name="TextBox 4">
+            <a:extLst>
+              <a:ext uri="{FF2B5EF4-FFF2-40B4-BE49-F238E27FC236}">
+                <a16:creationId xmlns:a16="http://schemas.microsoft.com/office/drawing/2014/main" id="{31BC18DF-ABBF-4D82-87B5-E051CFF1E5E0}"/>
+              </a:ext>
+            </a:extLst>
+          </p:cNvPr>
+          <p:cNvSpPr txBox="1"/>
+          <p:nvPr/>
+        </p:nvSpPr>
+        <p:spPr>
+          <a:xfrm>
+            <a:off x="583270" y="850523"/>
+            <a:ext cx="3060849" cy="307777"/>
+          </a:xfrm>
+          <a:prstGeom prst="rect">
+            <a:avLst/>
+          </a:prstGeom>
+          <a:noFill/>
+        </p:spPr>
+        <p:txBody>
+          <a:bodyPr wrap="square" rtlCol="0">
+            <a:spAutoFit/>
+          </a:bodyPr>
+          <a:lstStyle/>
+          <a:p>
+            <a:r>
+              <a:rPr lang="en-SG" sz="1400" b="1" dirty="0" err="1">
+                <a:solidFill>
+                  <a:schemeClr val="tx2">
+                    <a:lumMod val="75000"/>
+                    <a:lumOff val="25000"/>
+                  </a:schemeClr>
+                </a:solidFill>
+              </a:rPr>
+              <a:t>IIoT</a:t>
+            </a:r>
+            <a:r>
+              <a:rPr lang="en-SG" sz="1400" b="1" dirty="0">
+                <a:solidFill>
+                  <a:schemeClr val="tx2">
+                    <a:lumMod val="75000"/>
+                    <a:lumOff val="25000"/>
+                  </a:schemeClr>
+                </a:solidFill>
+              </a:rPr>
+              <a:t> Drone Simulator program </a:t>
+            </a:r>
+          </a:p>
+        </p:txBody>
+      </p:sp>
+      <p:sp>
+        <p:nvSpPr>
+          <p:cNvPr id="67" name="TextBox 66">
+            <a:extLst>
+              <a:ext uri="{FF2B5EF4-FFF2-40B4-BE49-F238E27FC236}">
+                <a16:creationId xmlns:a16="http://schemas.microsoft.com/office/drawing/2014/main" id="{E83D0994-FFC7-B371-BE19-4F804F4F3BC3}"/>
+              </a:ext>
+            </a:extLst>
+          </p:cNvPr>
+          <p:cNvSpPr txBox="1"/>
+          <p:nvPr/>
+        </p:nvSpPr>
+        <p:spPr>
+          <a:xfrm>
+            <a:off x="4530381" y="2511947"/>
+            <a:ext cx="2732878" cy="523220"/>
+          </a:xfrm>
+          <a:prstGeom prst="rect">
+            <a:avLst/>
+          </a:prstGeom>
+          <a:noFill/>
+        </p:spPr>
+        <p:txBody>
+          <a:bodyPr wrap="square" rtlCol="0">
+            <a:spAutoFit/>
+          </a:bodyPr>
+          <a:lstStyle/>
+          <a:p>
+            <a:r>
+              <a:rPr lang="en-US" sz="1400" b="1" dirty="0">
+                <a:solidFill>
+                  <a:schemeClr val="accent6">
+                    <a:lumMod val="50000"/>
+                  </a:schemeClr>
+                </a:solidFill>
+              </a:rPr>
+              <a:t>Air Vacuum System Control RTU Simulation Framework</a:t>
+            </a:r>
+            <a:endParaRPr lang="en-SG" sz="1400" b="1" dirty="0">
+              <a:solidFill>
+                <a:schemeClr val="accent6">
+                  <a:lumMod val="50000"/>
+                </a:schemeClr>
+              </a:solidFill>
+            </a:endParaRPr>
+          </a:p>
+        </p:txBody>
+      </p:sp>
+      <p:sp>
+        <p:nvSpPr>
+          <p:cNvPr id="68" name="TextBox 67">
+            <a:extLst>
+              <a:ext uri="{FF2B5EF4-FFF2-40B4-BE49-F238E27FC236}">
+                <a16:creationId xmlns:a16="http://schemas.microsoft.com/office/drawing/2014/main" id="{785B9271-91E4-96A0-FFD7-67E7E3B97AB1}"/>
+              </a:ext>
+            </a:extLst>
+          </p:cNvPr>
+          <p:cNvSpPr txBox="1"/>
+          <p:nvPr/>
+        </p:nvSpPr>
+        <p:spPr>
+          <a:xfrm>
+            <a:off x="4355376" y="955243"/>
+            <a:ext cx="2884604" cy="307777"/>
+          </a:xfrm>
+          <a:prstGeom prst="rect">
+            <a:avLst/>
+          </a:prstGeom>
+          <a:noFill/>
+        </p:spPr>
+        <p:txBody>
+          <a:bodyPr wrap="square" rtlCol="0">
+            <a:spAutoFit/>
+          </a:bodyPr>
+          <a:lstStyle/>
+          <a:p>
+            <a:r>
+              <a:rPr lang="en-US" sz="1400" b="1" dirty="0"/>
+              <a:t>Level1 OT Controller Devices </a:t>
+            </a:r>
+            <a:endParaRPr lang="en-SG" sz="1400" b="1" dirty="0"/>
+          </a:p>
+        </p:txBody>
+      </p:sp>
+      <p:sp>
+        <p:nvSpPr>
+          <p:cNvPr id="80" name="Rectangle 79">
+            <a:extLst>
+              <a:ext uri="{FF2B5EF4-FFF2-40B4-BE49-F238E27FC236}">
+                <a16:creationId xmlns:a16="http://schemas.microsoft.com/office/drawing/2014/main" id="{410193F1-FCF7-0996-4AFD-5FEB7922A1DC}"/>
+              </a:ext>
+            </a:extLst>
+          </p:cNvPr>
+          <p:cNvSpPr/>
+          <p:nvPr/>
+        </p:nvSpPr>
+        <p:spPr>
+          <a:xfrm>
+            <a:off x="5219105" y="3292531"/>
+            <a:ext cx="1494965" cy="295727"/>
+          </a:xfrm>
+          <a:prstGeom prst="rect">
+            <a:avLst/>
+          </a:prstGeom>
+          <a:solidFill>
+            <a:schemeClr val="accent6">
+              <a:lumMod val="75000"/>
+            </a:schemeClr>
+          </a:solidFill>
+          <a:ln>
+            <a:solidFill>
+              <a:schemeClr val="tx1"/>
+            </a:solidFill>
+          </a:ln>
+        </p:spPr>
+        <p:style>
+          <a:lnRef idx="2">
+            <a:schemeClr val="accent1">
+              <a:shade val="50000"/>
+            </a:schemeClr>
+          </a:lnRef>
+          <a:fillRef idx="1">
+            <a:schemeClr val="accent1"/>
+          </a:fillRef>
+          <a:effectRef idx="0">
+            <a:schemeClr val="accent1"/>
+          </a:effectRef>
+          <a:fontRef idx="minor">
+            <a:schemeClr val="lt1"/>
+          </a:fontRef>
+        </p:style>
+        <p:txBody>
+          <a:bodyPr rtlCol="0" anchor="ctr"/>
+          <a:lstStyle/>
+          <a:p>
+            <a:pPr algn="ctr"/>
+            <a:r>
+              <a:rPr lang="en-US" sz="1050" b="1" dirty="0"/>
+              <a:t>Input Parameter </a:t>
+            </a:r>
+            <a:r>
+              <a:rPr lang="en-US" sz="1050" b="1" dirty="0" err="1"/>
+              <a:t>Dict</a:t>
+            </a:r>
+            <a:endParaRPr lang="en-SG" sz="1050" b="1" dirty="0"/>
+          </a:p>
+        </p:txBody>
+      </p:sp>
+      <p:pic>
+        <p:nvPicPr>
+          <p:cNvPr id="82" name="Picture 81">
+            <a:extLst>
+              <a:ext uri="{FF2B5EF4-FFF2-40B4-BE49-F238E27FC236}">
+                <a16:creationId xmlns:a16="http://schemas.microsoft.com/office/drawing/2014/main" id="{0C4944A4-AC6E-C358-AD9C-F8CDE9B6C9A5}"/>
+              </a:ext>
+            </a:extLst>
+          </p:cNvPr>
+          <p:cNvPicPr>
+            <a:picLocks noChangeAspect="1"/>
+          </p:cNvPicPr>
+          <p:nvPr/>
+        </p:nvPicPr>
+        <p:blipFill>
+          <a:blip r:embed="rId3"/>
+          <a:stretch>
+            <a:fillRect/>
+          </a:stretch>
+        </p:blipFill>
+        <p:spPr>
+          <a:xfrm>
+            <a:off x="5415143" y="3874018"/>
+            <a:ext cx="762864" cy="663898"/>
+          </a:xfrm>
+          <a:prstGeom prst="rect">
+            <a:avLst/>
+          </a:prstGeom>
+          <a:ln w="19050">
+            <a:solidFill>
+              <a:schemeClr val="tx1"/>
+            </a:solidFill>
+          </a:ln>
+        </p:spPr>
+      </p:pic>
+      <p:cxnSp>
+        <p:nvCxnSpPr>
+          <p:cNvPr id="84" name="Straight Arrow Connector 83">
+            <a:extLst>
+              <a:ext uri="{FF2B5EF4-FFF2-40B4-BE49-F238E27FC236}">
+                <a16:creationId xmlns:a16="http://schemas.microsoft.com/office/drawing/2014/main" id="{4D271E74-DEAC-DBC5-E155-98AC307DE59C}"/>
+              </a:ext>
+            </a:extLst>
+          </p:cNvPr>
+          <p:cNvCxnSpPr>
+            <a:cxnSpLocks/>
+          </p:cNvCxnSpPr>
+          <p:nvPr/>
+        </p:nvCxnSpPr>
+        <p:spPr>
+          <a:xfrm>
+            <a:off x="5796575" y="3580043"/>
+            <a:ext cx="0" cy="245081"/>
+          </a:xfrm>
+          <a:prstGeom prst="straightConnector1">
+            <a:avLst/>
+          </a:prstGeom>
+          <a:ln>
+            <a:prstDash val="sysDash"/>
+            <a:tailEnd type="triangle"/>
+          </a:ln>
+        </p:spPr>
+        <p:style>
+          <a:lnRef idx="2">
+            <a:schemeClr val="dk1"/>
+          </a:lnRef>
+          <a:fillRef idx="0">
+            <a:schemeClr val="dk1"/>
+          </a:fillRef>
+          <a:effectRef idx="1">
+            <a:schemeClr val="dk1"/>
+          </a:effectRef>
+          <a:fontRef idx="minor">
+            <a:schemeClr val="tx1"/>
+          </a:fontRef>
+        </p:style>
+      </p:cxnSp>
+      <p:sp>
+        <p:nvSpPr>
+          <p:cNvPr id="125" name="TextBox 124">
+            <a:extLst>
+              <a:ext uri="{FF2B5EF4-FFF2-40B4-BE49-F238E27FC236}">
+                <a16:creationId xmlns:a16="http://schemas.microsoft.com/office/drawing/2014/main" id="{587F13EF-BB40-8784-CA1E-3F7F9B4EDF0E}"/>
+              </a:ext>
+            </a:extLst>
+          </p:cNvPr>
+          <p:cNvSpPr txBox="1"/>
+          <p:nvPr/>
+        </p:nvSpPr>
+        <p:spPr>
+          <a:xfrm>
+            <a:off x="508106" y="458841"/>
+            <a:ext cx="3211175" cy="307777"/>
+          </a:xfrm>
+          <a:prstGeom prst="rect">
+            <a:avLst/>
+          </a:prstGeom>
+          <a:noFill/>
+        </p:spPr>
+        <p:txBody>
+          <a:bodyPr wrap="square" rtlCol="0">
+            <a:spAutoFit/>
+          </a:bodyPr>
+          <a:lstStyle/>
+          <a:p>
+            <a:r>
+              <a:rPr lang="en-US" sz="1400" b="1" dirty="0"/>
+              <a:t>Level0 OT Physical Field I/O Devices </a:t>
+            </a:r>
+            <a:endParaRPr lang="en-SG" sz="1400" b="1" dirty="0"/>
+          </a:p>
+        </p:txBody>
+      </p:sp>
+      <p:sp>
+        <p:nvSpPr>
+          <p:cNvPr id="148" name="TextBox 147">
+            <a:extLst>
+              <a:ext uri="{FF2B5EF4-FFF2-40B4-BE49-F238E27FC236}">
+                <a16:creationId xmlns:a16="http://schemas.microsoft.com/office/drawing/2014/main" id="{C0089D7C-7E8D-AD1C-D162-A3C3BE67C8FF}"/>
+              </a:ext>
+            </a:extLst>
+          </p:cNvPr>
+          <p:cNvSpPr txBox="1"/>
+          <p:nvPr/>
+        </p:nvSpPr>
+        <p:spPr>
+          <a:xfrm>
+            <a:off x="4733726" y="3852704"/>
+            <a:ext cx="875441" cy="646331"/>
+          </a:xfrm>
+          <a:prstGeom prst="rect">
+            <a:avLst/>
+          </a:prstGeom>
+          <a:noFill/>
+        </p:spPr>
+        <p:txBody>
+          <a:bodyPr wrap="square" rtlCol="0">
+            <a:spAutoFit/>
+          </a:bodyPr>
+          <a:lstStyle/>
+          <a:p>
+            <a:r>
+              <a:rPr lang="en-US" sz="1200" b="1" dirty="0"/>
+              <a:t>Auto</a:t>
+            </a:r>
+          </a:p>
+          <a:p>
+            <a:r>
+              <a:rPr lang="en-US" sz="1200" b="1" dirty="0"/>
+              <a:t>Control </a:t>
+            </a:r>
+          </a:p>
+          <a:p>
+            <a:r>
+              <a:rPr lang="en-US" sz="1200" b="1" dirty="0"/>
+              <a:t>Logic</a:t>
+            </a:r>
+            <a:endParaRPr lang="en-SG" sz="1200" b="1" dirty="0"/>
+          </a:p>
+        </p:txBody>
+      </p:sp>
+      <p:sp>
+        <p:nvSpPr>
+          <p:cNvPr id="161" name="Rectangle 160">
+            <a:extLst>
+              <a:ext uri="{FF2B5EF4-FFF2-40B4-BE49-F238E27FC236}">
+                <a16:creationId xmlns:a16="http://schemas.microsoft.com/office/drawing/2014/main" id="{32ADACBF-6CD1-7C6A-393E-8FDE39B7951F}"/>
+              </a:ext>
+            </a:extLst>
+          </p:cNvPr>
+          <p:cNvSpPr/>
+          <p:nvPr/>
+        </p:nvSpPr>
+        <p:spPr>
+          <a:xfrm>
+            <a:off x="8178871" y="821977"/>
+            <a:ext cx="2884605" cy="2362589"/>
+          </a:xfrm>
+          <a:prstGeom prst="rect">
+            <a:avLst/>
+          </a:prstGeom>
+          <a:solidFill>
+            <a:schemeClr val="accent2">
+              <a:lumMod val="20000"/>
+              <a:lumOff val="80000"/>
+            </a:schemeClr>
+          </a:solidFill>
+        </p:spPr>
+        <p:style>
+          <a:lnRef idx="2">
+            <a:schemeClr val="accent1">
+              <a:shade val="15000"/>
+            </a:schemeClr>
+          </a:lnRef>
+          <a:fillRef idx="1">
+            <a:schemeClr val="accent1"/>
+          </a:fillRef>
+          <a:effectRef idx="0">
+            <a:schemeClr val="accent1"/>
+          </a:effectRef>
+          <a:fontRef idx="minor">
+            <a:schemeClr val="lt1"/>
+          </a:fontRef>
+        </p:style>
+        <p:txBody>
+          <a:bodyPr rtlCol="0" anchor="ctr"/>
+          <a:lstStyle/>
+          <a:p>
+            <a:pPr algn="ctr"/>
+            <a:endParaRPr lang="en-SG" dirty="0"/>
+          </a:p>
+        </p:txBody>
+      </p:sp>
+      <p:sp>
+        <p:nvSpPr>
+          <p:cNvPr id="162" name="TextBox 161">
+            <a:extLst>
+              <a:ext uri="{FF2B5EF4-FFF2-40B4-BE49-F238E27FC236}">
+                <a16:creationId xmlns:a16="http://schemas.microsoft.com/office/drawing/2014/main" id="{5089A106-CF1F-EBEA-140F-03132C4ED2DD}"/>
+              </a:ext>
+            </a:extLst>
+          </p:cNvPr>
+          <p:cNvSpPr txBox="1"/>
+          <p:nvPr/>
+        </p:nvSpPr>
+        <p:spPr>
+          <a:xfrm>
+            <a:off x="8211674" y="476259"/>
+            <a:ext cx="3211175" cy="307777"/>
+          </a:xfrm>
+          <a:prstGeom prst="rect">
+            <a:avLst/>
+          </a:prstGeom>
+          <a:noFill/>
+        </p:spPr>
+        <p:txBody>
+          <a:bodyPr wrap="square" rtlCol="0">
+            <a:spAutoFit/>
+          </a:bodyPr>
+          <a:lstStyle/>
+          <a:p>
+            <a:r>
+              <a:rPr lang="en-US" sz="1400" b="1" dirty="0"/>
+              <a:t>Level2 OT Control Console/HMI/</a:t>
+            </a:r>
+            <a:endParaRPr lang="en-SG" sz="1400" b="1" dirty="0"/>
+          </a:p>
+        </p:txBody>
+      </p:sp>
+      <p:sp>
+        <p:nvSpPr>
+          <p:cNvPr id="165" name="TextBox 164">
+            <a:extLst>
+              <a:ext uri="{FF2B5EF4-FFF2-40B4-BE49-F238E27FC236}">
+                <a16:creationId xmlns:a16="http://schemas.microsoft.com/office/drawing/2014/main" id="{5D28B1DA-AD16-4DCE-5DEA-6030DDF090AC}"/>
+              </a:ext>
+            </a:extLst>
+          </p:cNvPr>
+          <p:cNvSpPr txBox="1"/>
+          <p:nvPr/>
+        </p:nvSpPr>
+        <p:spPr>
+          <a:xfrm>
+            <a:off x="8211674" y="913468"/>
+            <a:ext cx="2732878" cy="307777"/>
+          </a:xfrm>
+          <a:prstGeom prst="rect">
+            <a:avLst/>
+          </a:prstGeom>
+          <a:noFill/>
+        </p:spPr>
+        <p:txBody>
+          <a:bodyPr wrap="square" rtlCol="0">
+            <a:spAutoFit/>
+          </a:bodyPr>
+          <a:lstStyle/>
+          <a:p>
+            <a:r>
+              <a:rPr lang="en-SG" sz="1400" b="1" dirty="0">
+                <a:solidFill>
+                  <a:schemeClr val="accent2">
+                    <a:lumMod val="50000"/>
+                  </a:schemeClr>
+                </a:solidFill>
+              </a:rPr>
+              <a:t> </a:t>
+            </a:r>
+          </a:p>
+        </p:txBody>
+      </p:sp>
+      <p:pic>
+        <p:nvPicPr>
+          <p:cNvPr id="167" name="Picture 166">
+            <a:extLst>
+              <a:ext uri="{FF2B5EF4-FFF2-40B4-BE49-F238E27FC236}">
+                <a16:creationId xmlns:a16="http://schemas.microsoft.com/office/drawing/2014/main" id="{C3CC61CC-D108-C376-D0C3-7B49D5F871F8}"/>
+              </a:ext>
+            </a:extLst>
+          </p:cNvPr>
+          <p:cNvPicPr>
+            <a:picLocks noChangeAspect="1"/>
+          </p:cNvPicPr>
+          <p:nvPr/>
+        </p:nvPicPr>
+        <p:blipFill>
+          <a:blip r:embed="rId4"/>
+          <a:stretch>
+            <a:fillRect/>
+          </a:stretch>
+        </p:blipFill>
+        <p:spPr>
+          <a:xfrm>
+            <a:off x="8394788" y="4041852"/>
+            <a:ext cx="2602019" cy="1235491"/>
+          </a:xfrm>
+          <a:prstGeom prst="rect">
+            <a:avLst/>
+          </a:prstGeom>
+        </p:spPr>
+      </p:pic>
+      <p:sp>
+        <p:nvSpPr>
+          <p:cNvPr id="83" name="Rectangle 82">
+            <a:extLst>
+              <a:ext uri="{FF2B5EF4-FFF2-40B4-BE49-F238E27FC236}">
+                <a16:creationId xmlns:a16="http://schemas.microsoft.com/office/drawing/2014/main" id="{A2733834-1F35-5EC2-2694-CCCF1592DCF7}"/>
+              </a:ext>
+            </a:extLst>
+          </p:cNvPr>
+          <p:cNvSpPr/>
+          <p:nvPr/>
+        </p:nvSpPr>
+        <p:spPr>
+          <a:xfrm>
+            <a:off x="5247599" y="4856375"/>
+            <a:ext cx="1573581" cy="295727"/>
+          </a:xfrm>
+          <a:prstGeom prst="rect">
+            <a:avLst/>
+          </a:prstGeom>
+          <a:solidFill>
+            <a:schemeClr val="accent6">
+              <a:lumMod val="75000"/>
+            </a:schemeClr>
+          </a:solidFill>
+          <a:ln>
+            <a:solidFill>
+              <a:schemeClr val="tx1"/>
+            </a:solidFill>
+          </a:ln>
+        </p:spPr>
+        <p:style>
+          <a:lnRef idx="2">
+            <a:schemeClr val="accent1">
+              <a:shade val="50000"/>
+            </a:schemeClr>
+          </a:lnRef>
+          <a:fillRef idx="1">
+            <a:schemeClr val="accent1"/>
+          </a:fillRef>
+          <a:effectRef idx="0">
+            <a:schemeClr val="accent1"/>
+          </a:effectRef>
+          <a:fontRef idx="minor">
+            <a:schemeClr val="lt1"/>
+          </a:fontRef>
+        </p:style>
+        <p:txBody>
+          <a:bodyPr rtlCol="0" anchor="ctr"/>
+          <a:lstStyle/>
+          <a:p>
+            <a:pPr algn="ctr"/>
+            <a:r>
+              <a:rPr lang="en-US" sz="1050" b="1" dirty="0"/>
+              <a:t>Output Parameter </a:t>
+            </a:r>
+            <a:r>
+              <a:rPr lang="en-US" sz="1050" b="1" dirty="0" err="1"/>
+              <a:t>Dict</a:t>
+            </a:r>
+            <a:endParaRPr lang="en-SG" sz="1050" b="1" dirty="0"/>
+          </a:p>
+        </p:txBody>
+      </p:sp>
+      <p:pic>
+        <p:nvPicPr>
+          <p:cNvPr id="3" name="Picture 2">
+            <a:extLst>
+              <a:ext uri="{FF2B5EF4-FFF2-40B4-BE49-F238E27FC236}">
+                <a16:creationId xmlns:a16="http://schemas.microsoft.com/office/drawing/2014/main" id="{A5316139-D413-E03A-7795-59544C5DA31E}"/>
+              </a:ext>
+            </a:extLst>
+          </p:cNvPr>
+          <p:cNvPicPr>
+            <a:picLocks noChangeAspect="1"/>
+          </p:cNvPicPr>
+          <p:nvPr/>
+        </p:nvPicPr>
+        <p:blipFill>
+          <a:blip r:embed="rId5"/>
+          <a:stretch>
+            <a:fillRect/>
+          </a:stretch>
+        </p:blipFill>
+        <p:spPr>
+          <a:xfrm>
+            <a:off x="659875" y="1193579"/>
+            <a:ext cx="3195221" cy="1645539"/>
+          </a:xfrm>
+          <a:prstGeom prst="rect">
+            <a:avLst/>
+          </a:prstGeom>
+          <a:ln w="12700">
+            <a:solidFill>
+              <a:schemeClr val="tx1"/>
+            </a:solidFill>
+          </a:ln>
+        </p:spPr>
+      </p:pic>
+      <p:pic>
+        <p:nvPicPr>
+          <p:cNvPr id="9" name="Picture 8">
+            <a:extLst>
+              <a:ext uri="{FF2B5EF4-FFF2-40B4-BE49-F238E27FC236}">
+                <a16:creationId xmlns:a16="http://schemas.microsoft.com/office/drawing/2014/main" id="{3505429E-59FE-6C8F-86F0-98366BE4370E}"/>
+              </a:ext>
+            </a:extLst>
+          </p:cNvPr>
+          <p:cNvPicPr>
+            <a:picLocks noChangeAspect="1"/>
+          </p:cNvPicPr>
+          <p:nvPr/>
+        </p:nvPicPr>
+        <p:blipFill>
+          <a:blip r:embed="rId6"/>
+          <a:stretch>
+            <a:fillRect/>
+          </a:stretch>
+        </p:blipFill>
+        <p:spPr>
+          <a:xfrm>
+            <a:off x="671388" y="3184566"/>
+            <a:ext cx="1378905" cy="807385"/>
+          </a:xfrm>
+          <a:prstGeom prst="rect">
+            <a:avLst/>
+          </a:prstGeom>
+          <a:ln w="12700">
+            <a:solidFill>
+              <a:schemeClr val="tx1"/>
+            </a:solidFill>
+          </a:ln>
+        </p:spPr>
+      </p:pic>
+      <p:pic>
+        <p:nvPicPr>
+          <p:cNvPr id="15" name="Picture 14">
+            <a:extLst>
+              <a:ext uri="{FF2B5EF4-FFF2-40B4-BE49-F238E27FC236}">
+                <a16:creationId xmlns:a16="http://schemas.microsoft.com/office/drawing/2014/main" id="{EFF835FB-3881-90C8-17FF-E09678F7E380}"/>
+              </a:ext>
+            </a:extLst>
+          </p:cNvPr>
+          <p:cNvPicPr>
+            <a:picLocks noChangeAspect="1"/>
+          </p:cNvPicPr>
+          <p:nvPr/>
+        </p:nvPicPr>
+        <p:blipFill>
+          <a:blip r:embed="rId7"/>
+          <a:stretch>
+            <a:fillRect/>
+          </a:stretch>
+        </p:blipFill>
+        <p:spPr>
+          <a:xfrm>
+            <a:off x="668422" y="4509865"/>
+            <a:ext cx="1368021" cy="778550"/>
+          </a:xfrm>
+          <a:prstGeom prst="rect">
+            <a:avLst/>
+          </a:prstGeom>
+          <a:ln w="12700">
+            <a:solidFill>
+              <a:schemeClr val="tx1"/>
+            </a:solidFill>
+          </a:ln>
+        </p:spPr>
+      </p:pic>
+      <p:pic>
+        <p:nvPicPr>
+          <p:cNvPr id="19" name="Picture 18">
+            <a:extLst>
+              <a:ext uri="{FF2B5EF4-FFF2-40B4-BE49-F238E27FC236}">
+                <a16:creationId xmlns:a16="http://schemas.microsoft.com/office/drawing/2014/main" id="{1A9BD622-1155-5A44-68E9-4C19318C14BA}"/>
+              </a:ext>
+            </a:extLst>
+          </p:cNvPr>
+          <p:cNvPicPr>
+            <a:picLocks noChangeAspect="1"/>
+          </p:cNvPicPr>
+          <p:nvPr/>
+        </p:nvPicPr>
+        <p:blipFill>
+          <a:blip r:embed="rId8"/>
+          <a:stretch>
+            <a:fillRect/>
+          </a:stretch>
+        </p:blipFill>
+        <p:spPr>
+          <a:xfrm>
+            <a:off x="2253086" y="3174801"/>
+            <a:ext cx="1295102" cy="810484"/>
+          </a:xfrm>
+          <a:prstGeom prst="rect">
+            <a:avLst/>
+          </a:prstGeom>
+          <a:ln w="12700">
+            <a:solidFill>
+              <a:schemeClr val="tx1"/>
+            </a:solidFill>
+          </a:ln>
+        </p:spPr>
+      </p:pic>
+      <p:pic>
+        <p:nvPicPr>
+          <p:cNvPr id="23" name="Picture 22">
+            <a:extLst>
+              <a:ext uri="{FF2B5EF4-FFF2-40B4-BE49-F238E27FC236}">
+                <a16:creationId xmlns:a16="http://schemas.microsoft.com/office/drawing/2014/main" id="{2989998C-941A-09A8-EF26-B190A08EE952}"/>
+              </a:ext>
+            </a:extLst>
+          </p:cNvPr>
+          <p:cNvPicPr>
+            <a:picLocks noChangeAspect="1"/>
+          </p:cNvPicPr>
+          <p:nvPr/>
+        </p:nvPicPr>
+        <p:blipFill>
+          <a:blip r:embed="rId9"/>
+          <a:stretch>
+            <a:fillRect/>
+          </a:stretch>
+        </p:blipFill>
+        <p:spPr>
+          <a:xfrm>
+            <a:off x="2239235" y="4537731"/>
+            <a:ext cx="1260611" cy="777199"/>
+          </a:xfrm>
+          <a:prstGeom prst="rect">
+            <a:avLst/>
+          </a:prstGeom>
+          <a:ln w="12700">
+            <a:solidFill>
+              <a:schemeClr val="tx1"/>
+            </a:solidFill>
+          </a:ln>
+        </p:spPr>
+      </p:pic>
+      <p:sp>
+        <p:nvSpPr>
+          <p:cNvPr id="47" name="Rectangle 46">
+            <a:extLst>
+              <a:ext uri="{FF2B5EF4-FFF2-40B4-BE49-F238E27FC236}">
+                <a16:creationId xmlns:a16="http://schemas.microsoft.com/office/drawing/2014/main" id="{28EDFDA0-9300-F494-EA4F-D0EDE6581CDA}"/>
+              </a:ext>
+            </a:extLst>
+          </p:cNvPr>
+          <p:cNvSpPr/>
+          <p:nvPr/>
+        </p:nvSpPr>
+        <p:spPr>
+          <a:xfrm>
+            <a:off x="3604731" y="1587600"/>
+            <a:ext cx="965256" cy="340962"/>
+          </a:xfrm>
+          <a:prstGeom prst="rect">
+            <a:avLst/>
+          </a:prstGeom>
+          <a:solidFill>
+            <a:schemeClr val="accent2"/>
+          </a:solidFill>
+        </p:spPr>
+        <p:style>
+          <a:lnRef idx="2">
+            <a:schemeClr val="accent1">
+              <a:shade val="50000"/>
+            </a:schemeClr>
+          </a:lnRef>
+          <a:fillRef idx="1">
+            <a:schemeClr val="accent1"/>
+          </a:fillRef>
+          <a:effectRef idx="0">
+            <a:schemeClr val="accent1"/>
+          </a:effectRef>
+          <a:fontRef idx="minor">
+            <a:schemeClr val="lt1"/>
+          </a:fontRef>
+        </p:style>
+        <p:txBody>
+          <a:bodyPr rtlCol="0" anchor="ctr"/>
+          <a:lstStyle/>
+          <a:p>
+            <a:r>
+              <a:rPr lang="en-SG" sz="1050" b="1" dirty="0"/>
+              <a:t>MQTT Client</a:t>
+            </a:r>
+          </a:p>
+        </p:txBody>
+      </p:sp>
+      <p:sp>
+        <p:nvSpPr>
+          <p:cNvPr id="33" name="TextBox 32">
+            <a:extLst>
+              <a:ext uri="{FF2B5EF4-FFF2-40B4-BE49-F238E27FC236}">
+                <a16:creationId xmlns:a16="http://schemas.microsoft.com/office/drawing/2014/main" id="{EB7A6124-5EF6-9569-BE59-D9B805FAD6B1}"/>
+              </a:ext>
+            </a:extLst>
+          </p:cNvPr>
+          <p:cNvSpPr txBox="1"/>
+          <p:nvPr/>
+        </p:nvSpPr>
+        <p:spPr>
+          <a:xfrm>
+            <a:off x="631531" y="2869214"/>
+            <a:ext cx="2947966" cy="307777"/>
+          </a:xfrm>
+          <a:prstGeom prst="rect">
+            <a:avLst/>
+          </a:prstGeom>
+          <a:noFill/>
+        </p:spPr>
+        <p:txBody>
+          <a:bodyPr wrap="square" rtlCol="0">
+            <a:spAutoFit/>
+          </a:bodyPr>
+          <a:lstStyle/>
+          <a:p>
+            <a:r>
+              <a:rPr lang="en-SG" sz="1400" b="1" dirty="0">
+                <a:solidFill>
+                  <a:schemeClr val="tx2">
+                    <a:lumMod val="75000"/>
+                    <a:lumOff val="25000"/>
+                  </a:schemeClr>
+                </a:solidFill>
+              </a:rPr>
+              <a:t>Smart Factory Air Vacuum System </a:t>
+            </a:r>
+          </a:p>
+        </p:txBody>
+      </p:sp>
+      <p:cxnSp>
+        <p:nvCxnSpPr>
+          <p:cNvPr id="37" name="Connector: Elbow 36">
+            <a:extLst>
+              <a:ext uri="{FF2B5EF4-FFF2-40B4-BE49-F238E27FC236}">
+                <a16:creationId xmlns:a16="http://schemas.microsoft.com/office/drawing/2014/main" id="{F1CC832F-4496-C581-AC79-8A19EA84AD65}"/>
+              </a:ext>
+            </a:extLst>
+          </p:cNvPr>
+          <p:cNvCxnSpPr>
+            <a:cxnSpLocks/>
+            <a:stCxn id="9" idx="2"/>
+            <a:endCxn id="32" idx="1"/>
+          </p:cNvCxnSpPr>
+          <p:nvPr/>
+        </p:nvCxnSpPr>
+        <p:spPr>
+          <a:xfrm rot="5400000" flipH="1" flipV="1">
+            <a:off x="2304298" y="2564037"/>
+            <a:ext cx="484457" cy="2371372"/>
+          </a:xfrm>
+          <a:prstGeom prst="bentConnector4">
+            <a:avLst>
+              <a:gd name="adj1" fmla="val -36402"/>
+              <a:gd name="adj2" fmla="val 103097"/>
+            </a:avLst>
+          </a:prstGeom>
+        </p:spPr>
+        <p:style>
+          <a:lnRef idx="2">
+            <a:schemeClr val="dk1"/>
+          </a:lnRef>
+          <a:fillRef idx="0">
+            <a:schemeClr val="dk1"/>
+          </a:fillRef>
+          <a:effectRef idx="1">
+            <a:schemeClr val="dk1"/>
+          </a:effectRef>
+          <a:fontRef idx="minor">
+            <a:schemeClr val="tx1"/>
+          </a:fontRef>
+        </p:style>
+      </p:cxnSp>
+      <p:sp>
+        <p:nvSpPr>
+          <p:cNvPr id="32" name="Rectangle 31">
+            <a:extLst>
+              <a:ext uri="{FF2B5EF4-FFF2-40B4-BE49-F238E27FC236}">
+                <a16:creationId xmlns:a16="http://schemas.microsoft.com/office/drawing/2014/main" id="{7813263F-1648-5749-94E7-C1F6266E379E}"/>
+              </a:ext>
+            </a:extLst>
+          </p:cNvPr>
+          <p:cNvSpPr/>
+          <p:nvPr/>
+        </p:nvSpPr>
+        <p:spPr>
+          <a:xfrm>
+            <a:off x="3732213" y="3227914"/>
+            <a:ext cx="1183100" cy="559160"/>
+          </a:xfrm>
+          <a:prstGeom prst="rect">
+            <a:avLst/>
+          </a:prstGeom>
+          <a:solidFill>
+            <a:schemeClr val="accent2"/>
+          </a:solidFill>
+        </p:spPr>
+        <p:style>
+          <a:lnRef idx="2">
+            <a:schemeClr val="accent1">
+              <a:shade val="50000"/>
+            </a:schemeClr>
+          </a:lnRef>
+          <a:fillRef idx="1">
+            <a:schemeClr val="accent1"/>
+          </a:fillRef>
+          <a:effectRef idx="0">
+            <a:schemeClr val="accent1"/>
+          </a:effectRef>
+          <a:fontRef idx="minor">
+            <a:schemeClr val="lt1"/>
+          </a:fontRef>
+        </p:style>
+        <p:txBody>
+          <a:bodyPr rtlCol="0" anchor="ctr"/>
+          <a:lstStyle/>
+          <a:p>
+            <a:r>
+              <a:rPr lang="en-US" sz="1050" b="1" dirty="0"/>
+              <a:t>UDP Simulated  Electrical Signal RTU Input</a:t>
+            </a:r>
+            <a:endParaRPr lang="en-SG" sz="1050" b="1" dirty="0"/>
+          </a:p>
+        </p:txBody>
+      </p:sp>
+      <p:cxnSp>
+        <p:nvCxnSpPr>
+          <p:cNvPr id="46" name="Straight Connector 45">
+            <a:extLst>
+              <a:ext uri="{FF2B5EF4-FFF2-40B4-BE49-F238E27FC236}">
+                <a16:creationId xmlns:a16="http://schemas.microsoft.com/office/drawing/2014/main" id="{25655442-0192-8A82-26EF-0A9B76BA555F}"/>
+              </a:ext>
+            </a:extLst>
+          </p:cNvPr>
+          <p:cNvCxnSpPr>
+            <a:stCxn id="19" idx="2"/>
+          </p:cNvCxnSpPr>
+          <p:nvPr/>
+        </p:nvCxnSpPr>
+        <p:spPr>
+          <a:xfrm>
+            <a:off x="2900637" y="3985285"/>
+            <a:ext cx="0" cy="180054"/>
+          </a:xfrm>
+          <a:prstGeom prst="line">
+            <a:avLst/>
+          </a:prstGeom>
+        </p:spPr>
+        <p:style>
+          <a:lnRef idx="2">
+            <a:schemeClr val="dk1"/>
+          </a:lnRef>
+          <a:fillRef idx="0">
+            <a:schemeClr val="dk1"/>
+          </a:fillRef>
+          <a:effectRef idx="1">
+            <a:schemeClr val="dk1"/>
+          </a:effectRef>
+          <a:fontRef idx="minor">
+            <a:schemeClr val="tx1"/>
+          </a:fontRef>
+        </p:style>
+      </p:cxnSp>
+      <p:cxnSp>
+        <p:nvCxnSpPr>
+          <p:cNvPr id="49" name="Connector: Elbow 48">
+            <a:extLst>
+              <a:ext uri="{FF2B5EF4-FFF2-40B4-BE49-F238E27FC236}">
+                <a16:creationId xmlns:a16="http://schemas.microsoft.com/office/drawing/2014/main" id="{55A01305-FBD5-C0D0-292B-60B780D0DE3B}"/>
+              </a:ext>
+            </a:extLst>
+          </p:cNvPr>
+          <p:cNvCxnSpPr>
+            <a:cxnSpLocks/>
+            <a:stCxn id="15" idx="0"/>
+            <a:endCxn id="35" idx="1"/>
+          </p:cNvCxnSpPr>
+          <p:nvPr/>
+        </p:nvCxnSpPr>
+        <p:spPr>
+          <a:xfrm rot="16200000" flipH="1">
+            <a:off x="2333626" y="3528672"/>
+            <a:ext cx="395820" cy="2358206"/>
+          </a:xfrm>
+          <a:prstGeom prst="bentConnector4">
+            <a:avLst>
+              <a:gd name="adj1" fmla="val -44553"/>
+              <a:gd name="adj2" fmla="val 103278"/>
+            </a:avLst>
+          </a:prstGeom>
+        </p:spPr>
+        <p:style>
+          <a:lnRef idx="2">
+            <a:schemeClr val="dk1"/>
+          </a:lnRef>
+          <a:fillRef idx="0">
+            <a:schemeClr val="dk1"/>
+          </a:fillRef>
+          <a:effectRef idx="1">
+            <a:schemeClr val="dk1"/>
+          </a:effectRef>
+          <a:fontRef idx="minor">
+            <a:schemeClr val="tx1"/>
+          </a:fontRef>
+        </p:style>
+      </p:cxnSp>
+      <p:sp>
+        <p:nvSpPr>
+          <p:cNvPr id="35" name="Rectangle 34">
+            <a:extLst>
+              <a:ext uri="{FF2B5EF4-FFF2-40B4-BE49-F238E27FC236}">
+                <a16:creationId xmlns:a16="http://schemas.microsoft.com/office/drawing/2014/main" id="{6CE8F210-3F43-6E6B-8F0E-548004A1C5B5}"/>
+              </a:ext>
+            </a:extLst>
+          </p:cNvPr>
+          <p:cNvSpPr/>
+          <p:nvPr/>
+        </p:nvSpPr>
+        <p:spPr>
+          <a:xfrm>
+            <a:off x="3710639" y="4626105"/>
+            <a:ext cx="1183100" cy="559160"/>
+          </a:xfrm>
+          <a:prstGeom prst="rect">
+            <a:avLst/>
+          </a:prstGeom>
+          <a:solidFill>
+            <a:schemeClr val="accent2"/>
+          </a:solidFill>
+        </p:spPr>
+        <p:style>
+          <a:lnRef idx="2">
+            <a:schemeClr val="accent1">
+              <a:shade val="50000"/>
+            </a:schemeClr>
+          </a:lnRef>
+          <a:fillRef idx="1">
+            <a:schemeClr val="accent1"/>
+          </a:fillRef>
+          <a:effectRef idx="0">
+            <a:schemeClr val="accent1"/>
+          </a:effectRef>
+          <a:fontRef idx="minor">
+            <a:schemeClr val="lt1"/>
+          </a:fontRef>
+        </p:style>
+        <p:txBody>
+          <a:bodyPr rtlCol="0" anchor="ctr"/>
+          <a:lstStyle/>
+          <a:p>
+            <a:r>
+              <a:rPr lang="en-US" sz="1050" b="1" dirty="0"/>
+              <a:t>UDP Simulated  Electrical Signal RTU Output</a:t>
+            </a:r>
+            <a:endParaRPr lang="en-SG" sz="1050" b="1" dirty="0"/>
+          </a:p>
+        </p:txBody>
+      </p:sp>
+      <p:cxnSp>
+        <p:nvCxnSpPr>
+          <p:cNvPr id="60" name="Straight Connector 59">
+            <a:extLst>
+              <a:ext uri="{FF2B5EF4-FFF2-40B4-BE49-F238E27FC236}">
+                <a16:creationId xmlns:a16="http://schemas.microsoft.com/office/drawing/2014/main" id="{FDBE4AB7-62DC-043F-E78A-42DE33965FDB}"/>
+              </a:ext>
+            </a:extLst>
+          </p:cNvPr>
+          <p:cNvCxnSpPr>
+            <a:cxnSpLocks/>
+            <a:endCxn id="23" idx="0"/>
+          </p:cNvCxnSpPr>
+          <p:nvPr/>
+        </p:nvCxnSpPr>
+        <p:spPr>
+          <a:xfrm>
+            <a:off x="2869540" y="4329811"/>
+            <a:ext cx="1" cy="207920"/>
+          </a:xfrm>
+          <a:prstGeom prst="line">
+            <a:avLst/>
+          </a:prstGeom>
+        </p:spPr>
+        <p:style>
+          <a:lnRef idx="2">
+            <a:schemeClr val="dk1"/>
+          </a:lnRef>
+          <a:fillRef idx="0">
+            <a:schemeClr val="dk1"/>
+          </a:fillRef>
+          <a:effectRef idx="1">
+            <a:schemeClr val="dk1"/>
+          </a:effectRef>
+          <a:fontRef idx="minor">
+            <a:schemeClr val="tx1"/>
+          </a:fontRef>
+        </p:style>
+      </p:cxnSp>
+      <p:cxnSp>
+        <p:nvCxnSpPr>
+          <p:cNvPr id="65" name="Straight Arrow Connector 64">
+            <a:extLst>
+              <a:ext uri="{FF2B5EF4-FFF2-40B4-BE49-F238E27FC236}">
+                <a16:creationId xmlns:a16="http://schemas.microsoft.com/office/drawing/2014/main" id="{D81C8210-C0E7-B3E4-859C-1F4918518F21}"/>
+              </a:ext>
+            </a:extLst>
+          </p:cNvPr>
+          <p:cNvCxnSpPr>
+            <a:cxnSpLocks/>
+          </p:cNvCxnSpPr>
+          <p:nvPr/>
+        </p:nvCxnSpPr>
+        <p:spPr>
+          <a:xfrm>
+            <a:off x="5780178" y="4527070"/>
+            <a:ext cx="0" cy="329305"/>
+          </a:xfrm>
+          <a:prstGeom prst="straightConnector1">
+            <a:avLst/>
+          </a:prstGeom>
+          <a:ln>
+            <a:prstDash val="sysDash"/>
+            <a:tailEnd type="triangle"/>
+          </a:ln>
+        </p:spPr>
+        <p:style>
+          <a:lnRef idx="2">
+            <a:schemeClr val="dk1"/>
+          </a:lnRef>
+          <a:fillRef idx="0">
+            <a:schemeClr val="dk1"/>
+          </a:fillRef>
+          <a:effectRef idx="1">
+            <a:schemeClr val="dk1"/>
+          </a:effectRef>
+          <a:fontRef idx="minor">
+            <a:schemeClr val="tx1"/>
+          </a:fontRef>
+        </p:style>
+      </p:cxnSp>
+      <p:cxnSp>
+        <p:nvCxnSpPr>
+          <p:cNvPr id="72" name="Straight Arrow Connector 71">
+            <a:extLst>
+              <a:ext uri="{FF2B5EF4-FFF2-40B4-BE49-F238E27FC236}">
+                <a16:creationId xmlns:a16="http://schemas.microsoft.com/office/drawing/2014/main" id="{58B4CEA2-012D-1E0A-676D-15BF8BE1A4D0}"/>
+              </a:ext>
+            </a:extLst>
+          </p:cNvPr>
+          <p:cNvCxnSpPr>
+            <a:cxnSpLocks/>
+            <a:endCxn id="80" idx="1"/>
+          </p:cNvCxnSpPr>
+          <p:nvPr/>
+        </p:nvCxnSpPr>
+        <p:spPr>
+          <a:xfrm>
+            <a:off x="4915313" y="3429000"/>
+            <a:ext cx="303792" cy="0"/>
+          </a:xfrm>
+          <a:prstGeom prst="straightConnector1">
+            <a:avLst/>
+          </a:prstGeom>
+          <a:ln>
+            <a:prstDash val="sysDash"/>
+            <a:tailEnd type="triangle"/>
+          </a:ln>
+        </p:spPr>
+        <p:style>
+          <a:lnRef idx="2">
+            <a:schemeClr val="dk1"/>
+          </a:lnRef>
+          <a:fillRef idx="0">
+            <a:schemeClr val="dk1"/>
+          </a:fillRef>
+          <a:effectRef idx="1">
+            <a:schemeClr val="dk1"/>
+          </a:effectRef>
+          <a:fontRef idx="minor">
+            <a:schemeClr val="tx1"/>
+          </a:fontRef>
+        </p:style>
+      </p:cxnSp>
+      <p:cxnSp>
+        <p:nvCxnSpPr>
+          <p:cNvPr id="75" name="Straight Arrow Connector 74">
+            <a:extLst>
+              <a:ext uri="{FF2B5EF4-FFF2-40B4-BE49-F238E27FC236}">
+                <a16:creationId xmlns:a16="http://schemas.microsoft.com/office/drawing/2014/main" id="{6D4977DE-76D9-A860-79E2-C07C7F2576C6}"/>
+              </a:ext>
+            </a:extLst>
+          </p:cNvPr>
+          <p:cNvCxnSpPr>
+            <a:cxnSpLocks/>
+          </p:cNvCxnSpPr>
+          <p:nvPr/>
+        </p:nvCxnSpPr>
+        <p:spPr>
+          <a:xfrm flipH="1" flipV="1">
+            <a:off x="4872774" y="4982870"/>
+            <a:ext cx="353860" cy="0"/>
+          </a:xfrm>
+          <a:prstGeom prst="straightConnector1">
+            <a:avLst/>
+          </a:prstGeom>
+          <a:ln>
+            <a:prstDash val="sysDash"/>
+            <a:tailEnd type="triangle"/>
+          </a:ln>
+        </p:spPr>
+        <p:style>
+          <a:lnRef idx="2">
+            <a:schemeClr val="dk1"/>
+          </a:lnRef>
+          <a:fillRef idx="0">
+            <a:schemeClr val="dk1"/>
+          </a:fillRef>
+          <a:effectRef idx="1">
+            <a:schemeClr val="dk1"/>
+          </a:effectRef>
+          <a:fontRef idx="minor">
+            <a:schemeClr val="tx1"/>
+          </a:fontRef>
+        </p:style>
+      </p:cxnSp>
+      <p:sp>
+        <p:nvSpPr>
+          <p:cNvPr id="79" name="TextBox 78">
+            <a:extLst>
+              <a:ext uri="{FF2B5EF4-FFF2-40B4-BE49-F238E27FC236}">
+                <a16:creationId xmlns:a16="http://schemas.microsoft.com/office/drawing/2014/main" id="{AFAAA84E-DCD0-D7B7-9C0E-9E1FF741C098}"/>
+              </a:ext>
+            </a:extLst>
+          </p:cNvPr>
+          <p:cNvSpPr txBox="1"/>
+          <p:nvPr/>
+        </p:nvSpPr>
+        <p:spPr>
+          <a:xfrm>
+            <a:off x="4627293" y="1293661"/>
+            <a:ext cx="1741925" cy="307777"/>
+          </a:xfrm>
+          <a:prstGeom prst="rect">
+            <a:avLst/>
+          </a:prstGeom>
+          <a:noFill/>
+        </p:spPr>
+        <p:txBody>
+          <a:bodyPr wrap="square" rtlCol="0">
+            <a:spAutoFit/>
+          </a:bodyPr>
+          <a:lstStyle/>
+          <a:p>
+            <a:r>
+              <a:rPr lang="en-SG" sz="1400" b="1" dirty="0">
+                <a:solidFill>
+                  <a:schemeClr val="accent6">
+                    <a:lumMod val="50000"/>
+                  </a:schemeClr>
+                </a:solidFill>
+              </a:rPr>
+              <a:t>IoT 5G Antenna </a:t>
+            </a:r>
+          </a:p>
+        </p:txBody>
+      </p:sp>
+      <p:sp>
+        <p:nvSpPr>
+          <p:cNvPr id="81" name="Rectangle 80">
+            <a:extLst>
+              <a:ext uri="{FF2B5EF4-FFF2-40B4-BE49-F238E27FC236}">
+                <a16:creationId xmlns:a16="http://schemas.microsoft.com/office/drawing/2014/main" id="{AEA0A740-926A-31A2-62D0-5B65F5211AC2}"/>
+              </a:ext>
+            </a:extLst>
+          </p:cNvPr>
+          <p:cNvSpPr/>
+          <p:nvPr/>
+        </p:nvSpPr>
+        <p:spPr>
+          <a:xfrm>
+            <a:off x="6509352" y="3855691"/>
+            <a:ext cx="965256" cy="340962"/>
+          </a:xfrm>
+          <a:prstGeom prst="rect">
+            <a:avLst/>
+          </a:prstGeom>
+          <a:solidFill>
+            <a:schemeClr val="accent2"/>
+          </a:solidFill>
+        </p:spPr>
+        <p:style>
+          <a:lnRef idx="2">
+            <a:schemeClr val="accent1">
+              <a:shade val="50000"/>
+            </a:schemeClr>
+          </a:lnRef>
+          <a:fillRef idx="1">
+            <a:schemeClr val="accent1"/>
+          </a:fillRef>
+          <a:effectRef idx="0">
+            <a:schemeClr val="accent1"/>
+          </a:effectRef>
+          <a:fontRef idx="minor">
+            <a:schemeClr val="lt1"/>
+          </a:fontRef>
+        </p:style>
+        <p:txBody>
+          <a:bodyPr rtlCol="0" anchor="ctr"/>
+          <a:lstStyle/>
+          <a:p>
+            <a:r>
+              <a:rPr lang="en-SG" sz="1050" b="1" dirty="0"/>
+              <a:t>MQTT Client</a:t>
+            </a:r>
+          </a:p>
+        </p:txBody>
+      </p:sp>
+      <p:cxnSp>
+        <p:nvCxnSpPr>
+          <p:cNvPr id="87" name="Straight Connector 86">
+            <a:extLst>
+              <a:ext uri="{FF2B5EF4-FFF2-40B4-BE49-F238E27FC236}">
+                <a16:creationId xmlns:a16="http://schemas.microsoft.com/office/drawing/2014/main" id="{525058C5-A339-2CFC-1C58-5CE6271AD8F4}"/>
+              </a:ext>
+            </a:extLst>
+          </p:cNvPr>
+          <p:cNvCxnSpPr>
+            <a:cxnSpLocks/>
+          </p:cNvCxnSpPr>
+          <p:nvPr/>
+        </p:nvCxnSpPr>
+        <p:spPr>
+          <a:xfrm>
+            <a:off x="6566585" y="3594022"/>
+            <a:ext cx="0" cy="258682"/>
+          </a:xfrm>
+          <a:prstGeom prst="line">
+            <a:avLst/>
+          </a:prstGeom>
+        </p:spPr>
+        <p:style>
+          <a:lnRef idx="2">
+            <a:schemeClr val="dk1"/>
+          </a:lnRef>
+          <a:fillRef idx="0">
+            <a:schemeClr val="dk1"/>
+          </a:fillRef>
+          <a:effectRef idx="1">
+            <a:schemeClr val="dk1"/>
+          </a:effectRef>
+          <a:fontRef idx="minor">
+            <a:schemeClr val="tx1"/>
+          </a:fontRef>
+        </p:style>
+      </p:cxnSp>
+      <p:cxnSp>
+        <p:nvCxnSpPr>
+          <p:cNvPr id="89" name="Straight Connector 88">
+            <a:extLst>
+              <a:ext uri="{FF2B5EF4-FFF2-40B4-BE49-F238E27FC236}">
+                <a16:creationId xmlns:a16="http://schemas.microsoft.com/office/drawing/2014/main" id="{1F028600-722A-7E17-3136-F930C49E08B3}"/>
+              </a:ext>
+            </a:extLst>
+          </p:cNvPr>
+          <p:cNvCxnSpPr>
+            <a:cxnSpLocks/>
+          </p:cNvCxnSpPr>
+          <p:nvPr/>
+        </p:nvCxnSpPr>
+        <p:spPr>
+          <a:xfrm>
+            <a:off x="6632678" y="4626105"/>
+            <a:ext cx="0" cy="230270"/>
+          </a:xfrm>
+          <a:prstGeom prst="line">
+            <a:avLst/>
+          </a:prstGeom>
+        </p:spPr>
+        <p:style>
+          <a:lnRef idx="2">
+            <a:schemeClr val="dk1"/>
+          </a:lnRef>
+          <a:fillRef idx="0">
+            <a:schemeClr val="dk1"/>
+          </a:fillRef>
+          <a:effectRef idx="1">
+            <a:schemeClr val="dk1"/>
+          </a:effectRef>
+          <a:fontRef idx="minor">
+            <a:schemeClr val="tx1"/>
+          </a:fontRef>
+        </p:style>
+      </p:cxnSp>
+      <p:sp>
+        <p:nvSpPr>
+          <p:cNvPr id="92" name="Rectangle 91">
+            <a:extLst>
+              <a:ext uri="{FF2B5EF4-FFF2-40B4-BE49-F238E27FC236}">
+                <a16:creationId xmlns:a16="http://schemas.microsoft.com/office/drawing/2014/main" id="{3155ECCE-090A-F076-DC4C-7AB4AD745293}"/>
+              </a:ext>
+            </a:extLst>
+          </p:cNvPr>
+          <p:cNvSpPr/>
+          <p:nvPr/>
+        </p:nvSpPr>
+        <p:spPr>
+          <a:xfrm>
+            <a:off x="7896759" y="1587600"/>
+            <a:ext cx="996059" cy="281016"/>
+          </a:xfrm>
+          <a:prstGeom prst="rect">
+            <a:avLst/>
+          </a:prstGeom>
+          <a:solidFill>
+            <a:schemeClr val="accent2"/>
+          </a:solidFill>
+        </p:spPr>
+        <p:style>
+          <a:lnRef idx="2">
+            <a:schemeClr val="accent1">
+              <a:shade val="50000"/>
+            </a:schemeClr>
+          </a:lnRef>
+          <a:fillRef idx="1">
+            <a:schemeClr val="accent1"/>
+          </a:fillRef>
+          <a:effectRef idx="0">
+            <a:schemeClr val="accent1"/>
+          </a:effectRef>
+          <a:fontRef idx="minor">
+            <a:schemeClr val="lt1"/>
+          </a:fontRef>
+        </p:style>
+        <p:txBody>
+          <a:bodyPr rtlCol="0" anchor="ctr"/>
+          <a:lstStyle/>
+          <a:p>
+            <a:r>
+              <a:rPr lang="en-SG" sz="1050" b="1" dirty="0"/>
+              <a:t>MQTT Broker </a:t>
+            </a:r>
+          </a:p>
+        </p:txBody>
+      </p:sp>
+      <p:pic>
+        <p:nvPicPr>
+          <p:cNvPr id="93" name="Picture 92">
+            <a:extLst>
+              <a:ext uri="{FF2B5EF4-FFF2-40B4-BE49-F238E27FC236}">
+                <a16:creationId xmlns:a16="http://schemas.microsoft.com/office/drawing/2014/main" id="{C596B7E7-3865-25F7-EF6C-DD2655093B4B}"/>
+              </a:ext>
+            </a:extLst>
+          </p:cNvPr>
+          <p:cNvPicPr>
+            <a:picLocks noChangeAspect="1"/>
+          </p:cNvPicPr>
+          <p:nvPr/>
+        </p:nvPicPr>
+        <p:blipFill>
+          <a:blip r:embed="rId3"/>
+          <a:stretch>
+            <a:fillRect/>
+          </a:stretch>
+        </p:blipFill>
+        <p:spPr>
+          <a:xfrm>
+            <a:off x="8266051" y="913468"/>
+            <a:ext cx="621263" cy="540667"/>
+          </a:xfrm>
+          <a:prstGeom prst="rect">
+            <a:avLst/>
+          </a:prstGeom>
+          <a:ln w="19050">
+            <a:solidFill>
+              <a:schemeClr val="tx1"/>
+            </a:solidFill>
+          </a:ln>
+        </p:spPr>
+      </p:pic>
+      <p:sp>
+        <p:nvSpPr>
+          <p:cNvPr id="94" name="TextBox 93">
+            <a:extLst>
+              <a:ext uri="{FF2B5EF4-FFF2-40B4-BE49-F238E27FC236}">
+                <a16:creationId xmlns:a16="http://schemas.microsoft.com/office/drawing/2014/main" id="{AC55AA68-DB1C-9B26-2599-520B03655BB5}"/>
+              </a:ext>
+            </a:extLst>
+          </p:cNvPr>
+          <p:cNvSpPr txBox="1"/>
+          <p:nvPr/>
+        </p:nvSpPr>
+        <p:spPr>
+          <a:xfrm>
+            <a:off x="8982531" y="870413"/>
+            <a:ext cx="801928" cy="646331"/>
+          </a:xfrm>
+          <a:prstGeom prst="rect">
+            <a:avLst/>
+          </a:prstGeom>
+          <a:noFill/>
+        </p:spPr>
+        <p:txBody>
+          <a:bodyPr wrap="square" rtlCol="0">
+            <a:spAutoFit/>
+          </a:bodyPr>
+          <a:lstStyle/>
+          <a:p>
+            <a:r>
+              <a:rPr lang="en-SG" sz="1200" b="1" dirty="0"/>
+              <a:t>Data Process Logic</a:t>
+            </a:r>
+          </a:p>
+        </p:txBody>
+      </p:sp>
+      <p:cxnSp>
+        <p:nvCxnSpPr>
+          <p:cNvPr id="98" name="Straight Arrow Connector 97">
+            <a:extLst>
+              <a:ext uri="{FF2B5EF4-FFF2-40B4-BE49-F238E27FC236}">
+                <a16:creationId xmlns:a16="http://schemas.microsoft.com/office/drawing/2014/main" id="{B5E7F4B0-DED2-7A1B-F640-5CE78714CAD8}"/>
+              </a:ext>
+            </a:extLst>
+          </p:cNvPr>
+          <p:cNvCxnSpPr>
+            <a:cxnSpLocks/>
+            <a:stCxn id="47" idx="3"/>
+            <a:endCxn id="92" idx="1"/>
+          </p:cNvCxnSpPr>
+          <p:nvPr/>
+        </p:nvCxnSpPr>
+        <p:spPr>
+          <a:xfrm flipV="1">
+            <a:off x="4569987" y="1728108"/>
+            <a:ext cx="3326772" cy="0"/>
+          </a:xfrm>
+          <a:prstGeom prst="straightConnector1">
+            <a:avLst/>
+          </a:prstGeom>
+          <a:ln>
+            <a:solidFill>
+              <a:schemeClr val="accent2">
+                <a:lumMod val="75000"/>
+              </a:schemeClr>
+            </a:solidFill>
+            <a:prstDash val="sysDash"/>
+            <a:tailEnd type="triangle"/>
+          </a:ln>
+        </p:spPr>
+        <p:style>
+          <a:lnRef idx="2">
+            <a:schemeClr val="dk1"/>
+          </a:lnRef>
+          <a:fillRef idx="0">
+            <a:schemeClr val="dk1"/>
+          </a:fillRef>
+          <a:effectRef idx="1">
+            <a:schemeClr val="dk1"/>
+          </a:effectRef>
+          <a:fontRef idx="minor">
+            <a:schemeClr val="tx1"/>
+          </a:fontRef>
+        </p:style>
+      </p:cxnSp>
+      <p:sp>
+        <p:nvSpPr>
+          <p:cNvPr id="101" name="TextBox 100">
+            <a:extLst>
+              <a:ext uri="{FF2B5EF4-FFF2-40B4-BE49-F238E27FC236}">
+                <a16:creationId xmlns:a16="http://schemas.microsoft.com/office/drawing/2014/main" id="{C89FBE41-3283-2925-4DAA-C08C2D5F28AA}"/>
+              </a:ext>
+            </a:extLst>
+          </p:cNvPr>
+          <p:cNvSpPr txBox="1"/>
+          <p:nvPr/>
+        </p:nvSpPr>
+        <p:spPr>
+          <a:xfrm>
+            <a:off x="4664451" y="1712759"/>
+            <a:ext cx="2130235" cy="261610"/>
+          </a:xfrm>
+          <a:prstGeom prst="rect">
+            <a:avLst/>
+          </a:prstGeom>
+          <a:noFill/>
+        </p:spPr>
+        <p:txBody>
+          <a:bodyPr wrap="square" rtlCol="0">
+            <a:spAutoFit/>
+          </a:bodyPr>
+          <a:lstStyle/>
+          <a:p>
+            <a:r>
+              <a:rPr lang="en-SG" sz="1100" b="1" dirty="0">
+                <a:solidFill>
+                  <a:schemeClr val="accent2">
+                    <a:lumMod val="50000"/>
+                  </a:schemeClr>
+                </a:solidFill>
+              </a:rPr>
+              <a:t>Data Publish (Drone fly data</a:t>
+            </a:r>
+            <a:r>
+              <a:rPr lang="en-SG" sz="1100" b="1" dirty="0">
+                <a:solidFill>
+                  <a:schemeClr val="accent6">
+                    <a:lumMod val="50000"/>
+                  </a:schemeClr>
+                </a:solidFill>
+              </a:rPr>
+              <a:t>)</a:t>
+            </a:r>
+          </a:p>
+        </p:txBody>
+      </p:sp>
+      <p:cxnSp>
+        <p:nvCxnSpPr>
+          <p:cNvPr id="103" name="Connector: Elbow 102">
+            <a:extLst>
+              <a:ext uri="{FF2B5EF4-FFF2-40B4-BE49-F238E27FC236}">
+                <a16:creationId xmlns:a16="http://schemas.microsoft.com/office/drawing/2014/main" id="{5932A095-9191-172B-C9FE-AC4425BA43D9}"/>
+              </a:ext>
+            </a:extLst>
+          </p:cNvPr>
+          <p:cNvCxnSpPr/>
+          <p:nvPr/>
+        </p:nvCxnSpPr>
+        <p:spPr>
+          <a:xfrm rot="5400000" flipH="1" flipV="1">
+            <a:off x="6509149" y="2597675"/>
+            <a:ext cx="2141721" cy="633500"/>
+          </a:xfrm>
+          <a:prstGeom prst="bentConnector3">
+            <a:avLst>
+              <a:gd name="adj1" fmla="val 99607"/>
+            </a:avLst>
+          </a:prstGeom>
+          <a:ln>
+            <a:solidFill>
+              <a:schemeClr val="accent2">
+                <a:lumMod val="75000"/>
+              </a:schemeClr>
+            </a:solidFill>
+            <a:prstDash val="sysDash"/>
+            <a:tailEnd type="triangle"/>
+          </a:ln>
+        </p:spPr>
+        <p:style>
+          <a:lnRef idx="2">
+            <a:schemeClr val="dk1"/>
+          </a:lnRef>
+          <a:fillRef idx="0">
+            <a:schemeClr val="dk1"/>
+          </a:fillRef>
+          <a:effectRef idx="1">
+            <a:schemeClr val="dk1"/>
+          </a:effectRef>
+          <a:fontRef idx="minor">
+            <a:schemeClr val="tx1"/>
+          </a:fontRef>
+        </p:style>
+      </p:cxnSp>
+      <p:sp>
+        <p:nvSpPr>
+          <p:cNvPr id="105" name="TextBox 104">
+            <a:extLst>
+              <a:ext uri="{FF2B5EF4-FFF2-40B4-BE49-F238E27FC236}">
+                <a16:creationId xmlns:a16="http://schemas.microsoft.com/office/drawing/2014/main" id="{5F31E912-988C-98F9-A0F3-408D966AC1D7}"/>
+              </a:ext>
+            </a:extLst>
+          </p:cNvPr>
+          <p:cNvSpPr txBox="1"/>
+          <p:nvPr/>
+        </p:nvSpPr>
+        <p:spPr>
+          <a:xfrm>
+            <a:off x="6682734" y="2935383"/>
+            <a:ext cx="1133810" cy="600164"/>
+          </a:xfrm>
+          <a:prstGeom prst="rect">
+            <a:avLst/>
+          </a:prstGeom>
+          <a:noFill/>
+        </p:spPr>
+        <p:txBody>
+          <a:bodyPr wrap="square" rtlCol="0">
+            <a:spAutoFit/>
+          </a:bodyPr>
+          <a:lstStyle/>
+          <a:p>
+            <a:r>
+              <a:rPr lang="en-SG" sz="1100" b="1" dirty="0">
+                <a:solidFill>
+                  <a:schemeClr val="accent2">
+                    <a:lumMod val="50000"/>
+                  </a:schemeClr>
+                </a:solidFill>
+              </a:rPr>
+              <a:t>Data Publish ( temp and fan-speed data</a:t>
+            </a:r>
+            <a:r>
+              <a:rPr lang="en-SG" sz="1100" b="1" dirty="0">
+                <a:solidFill>
+                  <a:schemeClr val="accent6">
+                    <a:lumMod val="50000"/>
+                  </a:schemeClr>
+                </a:solidFill>
+              </a:rPr>
+              <a:t>)</a:t>
+            </a:r>
+          </a:p>
+        </p:txBody>
+      </p:sp>
+      <p:cxnSp>
+        <p:nvCxnSpPr>
+          <p:cNvPr id="107" name="Connector: Elbow 106">
+            <a:extLst>
+              <a:ext uri="{FF2B5EF4-FFF2-40B4-BE49-F238E27FC236}">
+                <a16:creationId xmlns:a16="http://schemas.microsoft.com/office/drawing/2014/main" id="{174AD778-74FB-B924-27B5-FFD874A5F6DD}"/>
+              </a:ext>
+            </a:extLst>
+          </p:cNvPr>
+          <p:cNvCxnSpPr>
+            <a:endCxn id="81" idx="3"/>
+          </p:cNvCxnSpPr>
+          <p:nvPr/>
+        </p:nvCxnSpPr>
+        <p:spPr>
+          <a:xfrm rot="5400000">
+            <a:off x="6599961" y="2604096"/>
+            <a:ext cx="2296723" cy="547428"/>
+          </a:xfrm>
+          <a:prstGeom prst="bentConnector2">
+            <a:avLst/>
+          </a:prstGeom>
+          <a:ln>
+            <a:solidFill>
+              <a:schemeClr val="accent6">
+                <a:lumMod val="75000"/>
+              </a:schemeClr>
+            </a:solidFill>
+            <a:prstDash val="sysDash"/>
+            <a:tailEnd type="triangle"/>
+          </a:ln>
+        </p:spPr>
+        <p:style>
+          <a:lnRef idx="2">
+            <a:schemeClr val="accent6"/>
+          </a:lnRef>
+          <a:fillRef idx="0">
+            <a:schemeClr val="accent6"/>
+          </a:fillRef>
+          <a:effectRef idx="1">
+            <a:schemeClr val="accent6"/>
+          </a:effectRef>
+          <a:fontRef idx="minor">
+            <a:schemeClr val="tx1"/>
+          </a:fontRef>
+        </p:style>
+      </p:cxnSp>
+      <p:sp>
+        <p:nvSpPr>
+          <p:cNvPr id="108" name="TextBox 107">
+            <a:extLst>
+              <a:ext uri="{FF2B5EF4-FFF2-40B4-BE49-F238E27FC236}">
+                <a16:creationId xmlns:a16="http://schemas.microsoft.com/office/drawing/2014/main" id="{AC12CB8B-131A-A916-DF61-8F8109989FF5}"/>
+              </a:ext>
+            </a:extLst>
+          </p:cNvPr>
+          <p:cNvSpPr txBox="1"/>
+          <p:nvPr/>
+        </p:nvSpPr>
+        <p:spPr>
+          <a:xfrm>
+            <a:off x="7379947" y="2034495"/>
+            <a:ext cx="1259347" cy="769441"/>
+          </a:xfrm>
+          <a:prstGeom prst="rect">
+            <a:avLst/>
+          </a:prstGeom>
+          <a:noFill/>
+        </p:spPr>
+        <p:txBody>
+          <a:bodyPr wrap="square" rtlCol="0">
+            <a:spAutoFit/>
+          </a:bodyPr>
+          <a:lstStyle/>
+          <a:p>
+            <a:r>
+              <a:rPr lang="en-SG" sz="1100" b="1" dirty="0">
+                <a:solidFill>
+                  <a:schemeClr val="accent6">
+                    <a:lumMod val="75000"/>
+                  </a:schemeClr>
+                </a:solidFill>
+              </a:rPr>
+              <a:t>Data Subscribe (Fan and valve moto control request )</a:t>
+            </a:r>
+          </a:p>
+        </p:txBody>
+      </p:sp>
+      <p:cxnSp>
+        <p:nvCxnSpPr>
+          <p:cNvPr id="111" name="Straight Arrow Connector 110">
+            <a:extLst>
+              <a:ext uri="{FF2B5EF4-FFF2-40B4-BE49-F238E27FC236}">
+                <a16:creationId xmlns:a16="http://schemas.microsoft.com/office/drawing/2014/main" id="{531F89FB-8564-A336-DA3E-8674C92321B1}"/>
+              </a:ext>
+            </a:extLst>
+          </p:cNvPr>
+          <p:cNvCxnSpPr>
+            <a:stCxn id="93" idx="2"/>
+          </p:cNvCxnSpPr>
+          <p:nvPr/>
+        </p:nvCxnSpPr>
+        <p:spPr>
+          <a:xfrm flipH="1">
+            <a:off x="8576682" y="1454135"/>
+            <a:ext cx="1" cy="133465"/>
+          </a:xfrm>
+          <a:prstGeom prst="straightConnector1">
+            <a:avLst/>
+          </a:prstGeom>
+          <a:ln>
+            <a:headEnd type="triangle"/>
+            <a:tailEnd type="triangle"/>
+          </a:ln>
+        </p:spPr>
+        <p:style>
+          <a:lnRef idx="2">
+            <a:schemeClr val="accent1"/>
+          </a:lnRef>
+          <a:fillRef idx="0">
+            <a:schemeClr val="accent1"/>
+          </a:fillRef>
+          <a:effectRef idx="1">
+            <a:schemeClr val="accent1"/>
+          </a:effectRef>
+          <a:fontRef idx="minor">
+            <a:schemeClr val="tx1"/>
+          </a:fontRef>
+        </p:style>
+      </p:cxnSp>
+      <p:pic>
+        <p:nvPicPr>
+          <p:cNvPr id="113" name="Picture 112">
+            <a:extLst>
+              <a:ext uri="{FF2B5EF4-FFF2-40B4-BE49-F238E27FC236}">
+                <a16:creationId xmlns:a16="http://schemas.microsoft.com/office/drawing/2014/main" id="{2EF8C326-1111-88D4-0239-256EB8B7F894}"/>
+              </a:ext>
+            </a:extLst>
+          </p:cNvPr>
+          <p:cNvPicPr>
+            <a:picLocks noChangeAspect="1"/>
+          </p:cNvPicPr>
+          <p:nvPr/>
+        </p:nvPicPr>
+        <p:blipFill>
+          <a:blip r:embed="rId10">
+            <a:extLst>
+              <a:ext uri="{28A0092B-C50C-407E-A947-70E740481C1C}">
+                <a14:useLocalDpi xmlns:a14="http://schemas.microsoft.com/office/drawing/2010/main" val="0"/>
+              </a:ext>
+            </a:extLst>
+          </a:blip>
+          <a:stretch>
+            <a:fillRect/>
+          </a:stretch>
+        </p:blipFill>
+        <p:spPr>
+          <a:xfrm>
+            <a:off x="9690974" y="1358450"/>
+            <a:ext cx="1114477" cy="1768627"/>
+          </a:xfrm>
+          <a:prstGeom prst="rect">
+            <a:avLst/>
+          </a:prstGeom>
+          <a:ln w="9525">
+            <a:solidFill>
+              <a:schemeClr val="tx1"/>
+            </a:solidFill>
+          </a:ln>
+        </p:spPr>
+      </p:pic>
+      <p:sp>
+        <p:nvSpPr>
+          <p:cNvPr id="114" name="Rectangle 113">
+            <a:extLst>
+              <a:ext uri="{FF2B5EF4-FFF2-40B4-BE49-F238E27FC236}">
+                <a16:creationId xmlns:a16="http://schemas.microsoft.com/office/drawing/2014/main" id="{61ABEA43-1B13-4EFD-A074-E00CE4C34EC6}"/>
+              </a:ext>
+            </a:extLst>
+          </p:cNvPr>
+          <p:cNvSpPr/>
+          <p:nvPr/>
+        </p:nvSpPr>
+        <p:spPr>
+          <a:xfrm>
+            <a:off x="9095485" y="1951153"/>
+            <a:ext cx="965256" cy="340962"/>
+          </a:xfrm>
+          <a:prstGeom prst="rect">
+            <a:avLst/>
+          </a:prstGeom>
+          <a:solidFill>
+            <a:schemeClr val="accent2"/>
+          </a:solidFill>
+        </p:spPr>
+        <p:style>
+          <a:lnRef idx="2">
+            <a:schemeClr val="accent1">
+              <a:shade val="50000"/>
+            </a:schemeClr>
+          </a:lnRef>
+          <a:fillRef idx="1">
+            <a:schemeClr val="accent1"/>
+          </a:fillRef>
+          <a:effectRef idx="0">
+            <a:schemeClr val="accent1"/>
+          </a:effectRef>
+          <a:fontRef idx="minor">
+            <a:schemeClr val="lt1"/>
+          </a:fontRef>
+        </p:style>
+        <p:txBody>
+          <a:bodyPr rtlCol="0" anchor="ctr"/>
+          <a:lstStyle/>
+          <a:p>
+            <a:r>
+              <a:rPr lang="en-SG" sz="1050" b="1" dirty="0"/>
+              <a:t>MQTT Client</a:t>
+            </a:r>
+          </a:p>
+        </p:txBody>
+      </p:sp>
+      <p:cxnSp>
+        <p:nvCxnSpPr>
+          <p:cNvPr id="115" name="Connector: Elbow 114">
+            <a:extLst>
+              <a:ext uri="{FF2B5EF4-FFF2-40B4-BE49-F238E27FC236}">
+                <a16:creationId xmlns:a16="http://schemas.microsoft.com/office/drawing/2014/main" id="{5A90B30B-4C4A-D794-E9F8-E6707404A193}"/>
+              </a:ext>
+            </a:extLst>
+          </p:cNvPr>
+          <p:cNvCxnSpPr>
+            <a:cxnSpLocks/>
+            <a:stCxn id="92" idx="3"/>
+            <a:endCxn id="114" idx="0"/>
+          </p:cNvCxnSpPr>
+          <p:nvPr/>
+        </p:nvCxnSpPr>
+        <p:spPr>
+          <a:xfrm>
+            <a:off x="8892818" y="1728108"/>
+            <a:ext cx="685295" cy="223045"/>
+          </a:xfrm>
+          <a:prstGeom prst="bentConnector2">
+            <a:avLst/>
+          </a:prstGeom>
+          <a:ln>
+            <a:solidFill>
+              <a:schemeClr val="accent6">
+                <a:lumMod val="75000"/>
+              </a:schemeClr>
+            </a:solidFill>
+            <a:prstDash val="sysDash"/>
+            <a:tailEnd type="triangle"/>
+          </a:ln>
+        </p:spPr>
+        <p:style>
+          <a:lnRef idx="2">
+            <a:schemeClr val="accent6"/>
+          </a:lnRef>
+          <a:fillRef idx="0">
+            <a:schemeClr val="accent6"/>
+          </a:fillRef>
+          <a:effectRef idx="1">
+            <a:schemeClr val="accent6"/>
+          </a:effectRef>
+          <a:fontRef idx="minor">
+            <a:schemeClr val="tx1"/>
+          </a:fontRef>
+        </p:style>
+      </p:cxnSp>
+      <p:sp>
+        <p:nvSpPr>
+          <p:cNvPr id="119" name="TextBox 118">
+            <a:extLst>
+              <a:ext uri="{FF2B5EF4-FFF2-40B4-BE49-F238E27FC236}">
+                <a16:creationId xmlns:a16="http://schemas.microsoft.com/office/drawing/2014/main" id="{F47D2997-F313-076C-EB39-8ED5CDE82A49}"/>
+              </a:ext>
+            </a:extLst>
+          </p:cNvPr>
+          <p:cNvSpPr txBox="1"/>
+          <p:nvPr/>
+        </p:nvSpPr>
+        <p:spPr>
+          <a:xfrm>
+            <a:off x="9742000" y="809633"/>
+            <a:ext cx="1254807" cy="523220"/>
+          </a:xfrm>
+          <a:prstGeom prst="rect">
+            <a:avLst/>
+          </a:prstGeom>
+          <a:noFill/>
+        </p:spPr>
+        <p:txBody>
+          <a:bodyPr wrap="square" rtlCol="0">
+            <a:spAutoFit/>
+          </a:bodyPr>
+          <a:lstStyle/>
+          <a:p>
+            <a:r>
+              <a:rPr lang="en-SG" sz="1400" b="1" dirty="0">
+                <a:solidFill>
+                  <a:schemeClr val="accent2">
+                    <a:lumMod val="50000"/>
+                  </a:schemeClr>
+                </a:solidFill>
+              </a:rPr>
+              <a:t>Drone State Monitor HMI</a:t>
+            </a:r>
+          </a:p>
+        </p:txBody>
+      </p:sp>
+      <p:sp>
+        <p:nvSpPr>
+          <p:cNvPr id="120" name="Rectangle 119">
+            <a:extLst>
+              <a:ext uri="{FF2B5EF4-FFF2-40B4-BE49-F238E27FC236}">
+                <a16:creationId xmlns:a16="http://schemas.microsoft.com/office/drawing/2014/main" id="{F00080B1-57FE-3EF4-943B-EFB50200C31E}"/>
+              </a:ext>
+            </a:extLst>
+          </p:cNvPr>
+          <p:cNvSpPr/>
+          <p:nvPr/>
+        </p:nvSpPr>
+        <p:spPr>
+          <a:xfrm>
+            <a:off x="8435239" y="3772801"/>
+            <a:ext cx="965256" cy="340962"/>
+          </a:xfrm>
+          <a:prstGeom prst="rect">
+            <a:avLst/>
+          </a:prstGeom>
+          <a:solidFill>
+            <a:schemeClr val="accent2"/>
+          </a:solidFill>
+        </p:spPr>
+        <p:style>
+          <a:lnRef idx="2">
+            <a:schemeClr val="accent1">
+              <a:shade val="50000"/>
+            </a:schemeClr>
+          </a:lnRef>
+          <a:fillRef idx="1">
+            <a:schemeClr val="accent1"/>
+          </a:fillRef>
+          <a:effectRef idx="0">
+            <a:schemeClr val="accent1"/>
+          </a:effectRef>
+          <a:fontRef idx="minor">
+            <a:schemeClr val="lt1"/>
+          </a:fontRef>
+        </p:style>
+        <p:txBody>
+          <a:bodyPr rtlCol="0" anchor="ctr"/>
+          <a:lstStyle/>
+          <a:p>
+            <a:r>
+              <a:rPr lang="en-SG" sz="1050" b="1" dirty="0"/>
+              <a:t>MQTT Client</a:t>
+            </a:r>
+          </a:p>
+        </p:txBody>
+      </p:sp>
+      <p:cxnSp>
+        <p:nvCxnSpPr>
+          <p:cNvPr id="122" name="Straight Arrow Connector 121">
+            <a:extLst>
+              <a:ext uri="{FF2B5EF4-FFF2-40B4-BE49-F238E27FC236}">
+                <a16:creationId xmlns:a16="http://schemas.microsoft.com/office/drawing/2014/main" id="{59CD34D5-0DFF-0E85-0BE0-3E3477BA54E0}"/>
+              </a:ext>
+            </a:extLst>
+          </p:cNvPr>
+          <p:cNvCxnSpPr/>
+          <p:nvPr/>
+        </p:nvCxnSpPr>
+        <p:spPr>
+          <a:xfrm>
+            <a:off x="8576682" y="1915755"/>
+            <a:ext cx="0" cy="1833968"/>
+          </a:xfrm>
+          <a:prstGeom prst="straightConnector1">
+            <a:avLst/>
+          </a:prstGeom>
+          <a:ln>
+            <a:solidFill>
+              <a:schemeClr val="accent6">
+                <a:lumMod val="75000"/>
+              </a:schemeClr>
+            </a:solidFill>
+            <a:prstDash val="sysDash"/>
+            <a:tailEnd type="triangle"/>
+          </a:ln>
+        </p:spPr>
+        <p:style>
+          <a:lnRef idx="2">
+            <a:schemeClr val="accent1"/>
+          </a:lnRef>
+          <a:fillRef idx="0">
+            <a:schemeClr val="accent1"/>
+          </a:fillRef>
+          <a:effectRef idx="1">
+            <a:schemeClr val="accent1"/>
+          </a:effectRef>
+          <a:fontRef idx="minor">
+            <a:schemeClr val="tx1"/>
+          </a:fontRef>
+        </p:style>
+      </p:cxnSp>
+      <p:cxnSp>
+        <p:nvCxnSpPr>
+          <p:cNvPr id="123" name="Straight Arrow Connector 122">
+            <a:extLst>
+              <a:ext uri="{FF2B5EF4-FFF2-40B4-BE49-F238E27FC236}">
+                <a16:creationId xmlns:a16="http://schemas.microsoft.com/office/drawing/2014/main" id="{E319561A-7CF9-9856-960B-3F40F2DA7024}"/>
+              </a:ext>
+            </a:extLst>
+          </p:cNvPr>
+          <p:cNvCxnSpPr>
+            <a:cxnSpLocks/>
+          </p:cNvCxnSpPr>
+          <p:nvPr/>
+        </p:nvCxnSpPr>
+        <p:spPr>
+          <a:xfrm flipV="1">
+            <a:off x="8799075" y="1876796"/>
+            <a:ext cx="0" cy="1872927"/>
+          </a:xfrm>
+          <a:prstGeom prst="straightConnector1">
+            <a:avLst/>
+          </a:prstGeom>
+          <a:ln>
+            <a:solidFill>
+              <a:schemeClr val="accent2">
+                <a:lumMod val="75000"/>
+              </a:schemeClr>
+            </a:solidFill>
+            <a:prstDash val="sysDash"/>
+            <a:tailEnd type="triangle"/>
+          </a:ln>
+        </p:spPr>
+        <p:style>
+          <a:lnRef idx="2">
+            <a:schemeClr val="dk1"/>
+          </a:lnRef>
+          <a:fillRef idx="0">
+            <a:schemeClr val="dk1"/>
+          </a:fillRef>
+          <a:effectRef idx="1">
+            <a:schemeClr val="dk1"/>
+          </a:effectRef>
+          <a:fontRef idx="minor">
+            <a:schemeClr val="tx1"/>
+          </a:fontRef>
+        </p:style>
+      </p:cxnSp>
+      <p:sp>
+        <p:nvSpPr>
+          <p:cNvPr id="132" name="TextBox 131">
+            <a:extLst>
+              <a:ext uri="{FF2B5EF4-FFF2-40B4-BE49-F238E27FC236}">
+                <a16:creationId xmlns:a16="http://schemas.microsoft.com/office/drawing/2014/main" id="{84911D7E-8171-FF64-1FB7-46C9EADFA4AF}"/>
+              </a:ext>
+            </a:extLst>
+          </p:cNvPr>
+          <p:cNvSpPr txBox="1"/>
+          <p:nvPr/>
+        </p:nvSpPr>
+        <p:spPr>
+          <a:xfrm>
+            <a:off x="8974494" y="3293628"/>
+            <a:ext cx="2215570" cy="307777"/>
+          </a:xfrm>
+          <a:prstGeom prst="rect">
+            <a:avLst/>
+          </a:prstGeom>
+          <a:noFill/>
+        </p:spPr>
+        <p:txBody>
+          <a:bodyPr wrap="square" rtlCol="0">
+            <a:spAutoFit/>
+          </a:bodyPr>
+          <a:lstStyle/>
+          <a:p>
+            <a:r>
+              <a:rPr lang="en-US" sz="1400" b="1" dirty="0"/>
+              <a:t>Level3 OT Data Center</a:t>
+            </a:r>
+            <a:endParaRPr lang="en-SG" sz="1400" b="1" dirty="0"/>
+          </a:p>
+        </p:txBody>
+      </p:sp>
+      <p:sp>
+        <p:nvSpPr>
+          <p:cNvPr id="134" name="TextBox 133">
+            <a:extLst>
+              <a:ext uri="{FF2B5EF4-FFF2-40B4-BE49-F238E27FC236}">
+                <a16:creationId xmlns:a16="http://schemas.microsoft.com/office/drawing/2014/main" id="{7F91118A-0A8E-8363-4D3B-D7A0B626CAD1}"/>
+              </a:ext>
+            </a:extLst>
+          </p:cNvPr>
+          <p:cNvSpPr txBox="1"/>
+          <p:nvPr/>
+        </p:nvSpPr>
+        <p:spPr>
+          <a:xfrm>
+            <a:off x="9419959" y="3588258"/>
+            <a:ext cx="2130657" cy="461665"/>
+          </a:xfrm>
+          <a:prstGeom prst="rect">
+            <a:avLst/>
+          </a:prstGeom>
+          <a:noFill/>
+        </p:spPr>
+        <p:txBody>
+          <a:bodyPr wrap="square" rtlCol="0">
+            <a:spAutoFit/>
+          </a:bodyPr>
+          <a:lstStyle/>
+          <a:p>
+            <a:r>
+              <a:rPr lang="en-SG" sz="1200" b="1" dirty="0"/>
+              <a:t>Factory Environment Monitor Dashboard </a:t>
+            </a:r>
+          </a:p>
+        </p:txBody>
+      </p:sp>
+      <p:cxnSp>
+        <p:nvCxnSpPr>
+          <p:cNvPr id="136" name="Straight Arrow Connector 135">
+            <a:extLst>
+              <a:ext uri="{FF2B5EF4-FFF2-40B4-BE49-F238E27FC236}">
+                <a16:creationId xmlns:a16="http://schemas.microsoft.com/office/drawing/2014/main" id="{5F4CB6EC-3BB3-C9CE-4BB0-7C66CC110353}"/>
+              </a:ext>
+            </a:extLst>
+          </p:cNvPr>
+          <p:cNvCxnSpPr>
+            <a:cxnSpLocks/>
+          </p:cNvCxnSpPr>
+          <p:nvPr/>
+        </p:nvCxnSpPr>
+        <p:spPr>
+          <a:xfrm flipV="1">
+            <a:off x="4663006" y="643506"/>
+            <a:ext cx="620306" cy="0"/>
+          </a:xfrm>
+          <a:prstGeom prst="straightConnector1">
+            <a:avLst/>
+          </a:prstGeom>
+          <a:ln>
+            <a:solidFill>
+              <a:schemeClr val="accent6">
+                <a:lumMod val="75000"/>
+              </a:schemeClr>
+            </a:solidFill>
+            <a:prstDash val="sysDash"/>
+            <a:tailEnd type="triangle"/>
+          </a:ln>
+        </p:spPr>
+        <p:style>
+          <a:lnRef idx="2">
+            <a:schemeClr val="accent1"/>
+          </a:lnRef>
+          <a:fillRef idx="0">
+            <a:schemeClr val="accent1"/>
+          </a:fillRef>
+          <a:effectRef idx="1">
+            <a:schemeClr val="accent1"/>
+          </a:effectRef>
+          <a:fontRef idx="minor">
+            <a:schemeClr val="tx1"/>
+          </a:fontRef>
+        </p:style>
+      </p:cxnSp>
+      <p:sp>
+        <p:nvSpPr>
+          <p:cNvPr id="143" name="TextBox 142">
+            <a:extLst>
+              <a:ext uri="{FF2B5EF4-FFF2-40B4-BE49-F238E27FC236}">
+                <a16:creationId xmlns:a16="http://schemas.microsoft.com/office/drawing/2014/main" id="{FF26E35C-F07C-D71E-9EE1-21F5BA435C29}"/>
+              </a:ext>
+            </a:extLst>
+          </p:cNvPr>
+          <p:cNvSpPr txBox="1"/>
+          <p:nvPr/>
+        </p:nvSpPr>
+        <p:spPr>
+          <a:xfrm>
+            <a:off x="5330009" y="497912"/>
+            <a:ext cx="2125740" cy="261610"/>
+          </a:xfrm>
+          <a:prstGeom prst="rect">
+            <a:avLst/>
+          </a:prstGeom>
+          <a:noFill/>
+        </p:spPr>
+        <p:txBody>
+          <a:bodyPr wrap="square" rtlCol="0">
+            <a:spAutoFit/>
+          </a:bodyPr>
+          <a:lstStyle/>
+          <a:p>
+            <a:r>
+              <a:rPr lang="en-SG" sz="1100" b="1" dirty="0">
+                <a:solidFill>
+                  <a:schemeClr val="accent6">
+                    <a:lumMod val="75000"/>
+                  </a:schemeClr>
+                </a:solidFill>
+              </a:rPr>
+              <a:t>MQTT Data Subscribe Request</a:t>
+            </a:r>
+          </a:p>
+        </p:txBody>
+      </p:sp>
+      <p:cxnSp>
+        <p:nvCxnSpPr>
+          <p:cNvPr id="145" name="Straight Arrow Connector 144">
+            <a:extLst>
+              <a:ext uri="{FF2B5EF4-FFF2-40B4-BE49-F238E27FC236}">
+                <a16:creationId xmlns:a16="http://schemas.microsoft.com/office/drawing/2014/main" id="{A1D14FC2-D575-B83B-3310-6F877724A0F1}"/>
+              </a:ext>
+            </a:extLst>
+          </p:cNvPr>
+          <p:cNvCxnSpPr>
+            <a:cxnSpLocks/>
+          </p:cNvCxnSpPr>
+          <p:nvPr/>
+        </p:nvCxnSpPr>
+        <p:spPr>
+          <a:xfrm>
+            <a:off x="4677832" y="859864"/>
+            <a:ext cx="605480" cy="0"/>
+          </a:xfrm>
+          <a:prstGeom prst="straightConnector1">
+            <a:avLst/>
+          </a:prstGeom>
+          <a:ln>
+            <a:solidFill>
+              <a:schemeClr val="accent2">
+                <a:lumMod val="75000"/>
+              </a:schemeClr>
+            </a:solidFill>
+            <a:prstDash val="sysDash"/>
+            <a:tailEnd type="triangle"/>
+          </a:ln>
+        </p:spPr>
+        <p:style>
+          <a:lnRef idx="2">
+            <a:schemeClr val="dk1"/>
+          </a:lnRef>
+          <a:fillRef idx="0">
+            <a:schemeClr val="dk1"/>
+          </a:fillRef>
+          <a:effectRef idx="1">
+            <a:schemeClr val="dk1"/>
+          </a:effectRef>
+          <a:fontRef idx="minor">
+            <a:schemeClr val="tx1"/>
+          </a:fontRef>
+        </p:style>
+      </p:cxnSp>
+      <p:sp>
+        <p:nvSpPr>
+          <p:cNvPr id="152" name="TextBox 151">
+            <a:extLst>
+              <a:ext uri="{FF2B5EF4-FFF2-40B4-BE49-F238E27FC236}">
+                <a16:creationId xmlns:a16="http://schemas.microsoft.com/office/drawing/2014/main" id="{19BA9486-9630-D344-1BE6-3CA911C992FC}"/>
+              </a:ext>
+            </a:extLst>
+          </p:cNvPr>
+          <p:cNvSpPr txBox="1"/>
+          <p:nvPr/>
+        </p:nvSpPr>
+        <p:spPr>
+          <a:xfrm>
+            <a:off x="5337689" y="718641"/>
+            <a:ext cx="2125740" cy="261610"/>
+          </a:xfrm>
+          <a:prstGeom prst="rect">
+            <a:avLst/>
+          </a:prstGeom>
+          <a:noFill/>
+        </p:spPr>
+        <p:txBody>
+          <a:bodyPr wrap="square" rtlCol="0">
+            <a:spAutoFit/>
+          </a:bodyPr>
+          <a:lstStyle/>
+          <a:p>
+            <a:r>
+              <a:rPr lang="en-SG" sz="1100" b="1" dirty="0">
+                <a:solidFill>
+                  <a:schemeClr val="accent2">
+                    <a:lumMod val="50000"/>
+                  </a:schemeClr>
+                </a:solidFill>
+              </a:rPr>
+              <a:t>MQTT Data Publish Request</a:t>
+            </a:r>
+          </a:p>
+        </p:txBody>
+      </p:sp>
+      <p:sp>
+        <p:nvSpPr>
+          <p:cNvPr id="2" name="Rectangle 1">
+            <a:extLst>
+              <a:ext uri="{FF2B5EF4-FFF2-40B4-BE49-F238E27FC236}">
+                <a16:creationId xmlns:a16="http://schemas.microsoft.com/office/drawing/2014/main" id="{0503D145-A7A6-19DE-CBAD-F0264A76DE70}"/>
+              </a:ext>
+            </a:extLst>
+          </p:cNvPr>
+          <p:cNvSpPr/>
+          <p:nvPr/>
+        </p:nvSpPr>
+        <p:spPr>
+          <a:xfrm>
+            <a:off x="6519118" y="4294667"/>
+            <a:ext cx="965256" cy="340962"/>
+          </a:xfrm>
+          <a:prstGeom prst="rect">
+            <a:avLst/>
+          </a:prstGeom>
+          <a:solidFill>
+            <a:schemeClr val="accent2"/>
+          </a:solidFill>
+        </p:spPr>
+        <p:style>
+          <a:lnRef idx="2">
+            <a:schemeClr val="accent1">
+              <a:shade val="50000"/>
+            </a:schemeClr>
+          </a:lnRef>
+          <a:fillRef idx="1">
+            <a:schemeClr val="accent1"/>
+          </a:fillRef>
+          <a:effectRef idx="0">
+            <a:schemeClr val="accent1"/>
+          </a:effectRef>
+          <a:fontRef idx="minor">
+            <a:schemeClr val="lt1"/>
+          </a:fontRef>
+        </p:style>
+        <p:txBody>
+          <a:bodyPr rtlCol="0" anchor="ctr"/>
+          <a:lstStyle/>
+          <a:p>
+            <a:r>
+              <a:rPr lang="en-SG" sz="1050" b="1" dirty="0"/>
+              <a:t>MQTT Broker</a:t>
+            </a:r>
+          </a:p>
+        </p:txBody>
+      </p:sp>
+      <p:cxnSp>
+        <p:nvCxnSpPr>
+          <p:cNvPr id="11" name="Connector: Elbow 10">
+            <a:extLst>
+              <a:ext uri="{FF2B5EF4-FFF2-40B4-BE49-F238E27FC236}">
+                <a16:creationId xmlns:a16="http://schemas.microsoft.com/office/drawing/2014/main" id="{4ED4F42A-0BEE-8BF1-BA0B-EF2804695581}"/>
+              </a:ext>
+            </a:extLst>
+          </p:cNvPr>
+          <p:cNvCxnSpPr>
+            <a:cxnSpLocks/>
+            <a:endCxn id="81" idx="1"/>
+          </p:cNvCxnSpPr>
+          <p:nvPr/>
+        </p:nvCxnSpPr>
+        <p:spPr>
+          <a:xfrm rot="5400000" flipH="1" flipV="1">
+            <a:off x="5988932" y="4335955"/>
+            <a:ext cx="830203" cy="210638"/>
+          </a:xfrm>
+          <a:prstGeom prst="bentConnector2">
+            <a:avLst/>
+          </a:prstGeom>
+        </p:spPr>
+        <p:style>
+          <a:lnRef idx="2">
+            <a:schemeClr val="dk1"/>
+          </a:lnRef>
+          <a:fillRef idx="0">
+            <a:schemeClr val="dk1"/>
+          </a:fillRef>
+          <a:effectRef idx="1">
+            <a:schemeClr val="dk1"/>
+          </a:effectRef>
+          <a:fontRef idx="minor">
+            <a:schemeClr val="tx1"/>
+          </a:fontRef>
+        </p:style>
+      </p:cxnSp>
+      <p:cxnSp>
+        <p:nvCxnSpPr>
+          <p:cNvPr id="16" name="Connector: Elbow 15">
+            <a:extLst>
+              <a:ext uri="{FF2B5EF4-FFF2-40B4-BE49-F238E27FC236}">
+                <a16:creationId xmlns:a16="http://schemas.microsoft.com/office/drawing/2014/main" id="{560443A5-3904-604F-97A6-3E8435033BFF}"/>
+              </a:ext>
+            </a:extLst>
+          </p:cNvPr>
+          <p:cNvCxnSpPr>
+            <a:cxnSpLocks/>
+            <a:stCxn id="120" idx="1"/>
+            <a:endCxn id="2" idx="3"/>
+          </p:cNvCxnSpPr>
+          <p:nvPr/>
+        </p:nvCxnSpPr>
+        <p:spPr>
+          <a:xfrm rot="10800000" flipV="1">
+            <a:off x="7484375" y="3943282"/>
+            <a:ext cx="950865" cy="521866"/>
+          </a:xfrm>
+          <a:prstGeom prst="bentConnector3">
+            <a:avLst>
+              <a:gd name="adj1" fmla="val 36537"/>
+            </a:avLst>
+          </a:prstGeom>
+          <a:ln>
+            <a:solidFill>
+              <a:schemeClr val="accent2">
+                <a:lumMod val="75000"/>
+              </a:schemeClr>
+            </a:solidFill>
+            <a:prstDash val="sysDash"/>
+            <a:tailEnd type="triangle"/>
+          </a:ln>
+        </p:spPr>
+        <p:style>
+          <a:lnRef idx="2">
+            <a:schemeClr val="dk1"/>
+          </a:lnRef>
+          <a:fillRef idx="0">
+            <a:schemeClr val="dk1"/>
+          </a:fillRef>
+          <a:effectRef idx="1">
+            <a:schemeClr val="dk1"/>
+          </a:effectRef>
+          <a:fontRef idx="minor">
+            <a:schemeClr val="tx1"/>
+          </a:fontRef>
+        </p:style>
+      </p:cxnSp>
+      <p:sp>
+        <p:nvSpPr>
+          <p:cNvPr id="21" name="TextBox 20">
+            <a:extLst>
+              <a:ext uri="{FF2B5EF4-FFF2-40B4-BE49-F238E27FC236}">
+                <a16:creationId xmlns:a16="http://schemas.microsoft.com/office/drawing/2014/main" id="{C9385657-537C-6196-4B7C-14E3DBFF65FF}"/>
+              </a:ext>
+            </a:extLst>
+          </p:cNvPr>
+          <p:cNvSpPr txBox="1"/>
+          <p:nvPr/>
+        </p:nvSpPr>
+        <p:spPr>
+          <a:xfrm>
+            <a:off x="7141680" y="4697408"/>
+            <a:ext cx="1349727" cy="600164"/>
+          </a:xfrm>
+          <a:prstGeom prst="rect">
+            <a:avLst/>
+          </a:prstGeom>
+          <a:noFill/>
+        </p:spPr>
+        <p:txBody>
+          <a:bodyPr wrap="square" rtlCol="0">
+            <a:spAutoFit/>
+          </a:bodyPr>
+          <a:lstStyle/>
+          <a:p>
+            <a:r>
+              <a:rPr lang="en-SG" sz="1100" b="1" dirty="0">
+                <a:solidFill>
+                  <a:schemeClr val="accent2">
+                    <a:lumMod val="50000"/>
+                  </a:schemeClr>
+                </a:solidFill>
+              </a:rPr>
+              <a:t>Data Publish ( Direct Overwrite control</a:t>
+            </a:r>
+            <a:endParaRPr lang="en-SG" sz="1100" b="1" dirty="0">
+              <a:solidFill>
+                <a:schemeClr val="accent6">
+                  <a:lumMod val="50000"/>
+                </a:schemeClr>
+              </a:solidFill>
+            </a:endParaRPr>
+          </a:p>
+        </p:txBody>
+      </p:sp>
+    </p:spTree>
+    <p:extLst>
+      <p:ext uri="{BB962C8B-B14F-4D97-AF65-F5344CB8AC3E}">
+        <p14:creationId xmlns:p14="http://schemas.microsoft.com/office/powerpoint/2010/main" val="1693198638"/>
       </p:ext>
     </p:extLst>
   </p:cSld>
@@ -5950,4 +9256,319 @@
     </a:ext>
   </a:extLst>
 </a:theme>
+</file>
+
+<file path=ppt/theme/theme2.xml><?xml version="1.0" encoding="utf-8"?>
+<a:theme xmlns:a="http://schemas.openxmlformats.org/drawingml/2006/main" name="Office Theme">
+  <a:themeElements>
+    <a:clrScheme name="Office">
+      <a:dk1>
+        <a:sysClr val="windowText" lastClr="000000"/>
+      </a:dk1>
+      <a:lt1>
+        <a:sysClr val="window" lastClr="FFFFFF"/>
+      </a:lt1>
+      <a:dk2>
+        <a:srgbClr val="0E2841"/>
+      </a:dk2>
+      <a:lt2>
+        <a:srgbClr val="E8E8E8"/>
+      </a:lt2>
+      <a:accent1>
+        <a:srgbClr val="156082"/>
+      </a:accent1>
+      <a:accent2>
+        <a:srgbClr val="E97132"/>
+      </a:accent2>
+      <a:accent3>
+        <a:srgbClr val="196B24"/>
+      </a:accent3>
+      <a:accent4>
+        <a:srgbClr val="0F9ED5"/>
+      </a:accent4>
+      <a:accent5>
+        <a:srgbClr val="A02B93"/>
+      </a:accent5>
+      <a:accent6>
+        <a:srgbClr val="4EA72E"/>
+      </a:accent6>
+      <a:hlink>
+        <a:srgbClr val="467886"/>
+      </a:hlink>
+      <a:folHlink>
+        <a:srgbClr val="96607D"/>
+      </a:folHlink>
+    </a:clrScheme>
+    <a:fontScheme name="Office">
+      <a:majorFont>
+        <a:latin typeface="Aptos Display" panose="02110004020202020204"/>
+        <a:ea typeface=""/>
+        <a:cs typeface=""/>
+        <a:font script="Jpan" typeface="游ゴシック Light"/>
+        <a:font script="Hang" typeface="맑은 고딕"/>
+        <a:font script="Hans" typeface="等线 Light"/>
+        <a:font script="Hant" typeface="新細明體"/>
+        <a:font script="Arab" typeface="Times New Roman"/>
+        <a:font script="Hebr" typeface="Times New Roman"/>
+        <a:font script="Thai" typeface="Angsana New"/>
+        <a:font script="Ethi" typeface="Nyala"/>
+        <a:font script="Beng" typeface="Vrinda"/>
+        <a:font script="Gujr" typeface="Shruti"/>
+        <a:font script="Khmr" typeface="MoolBoran"/>
+        <a:font script="Knda" typeface="Tunga"/>
+        <a:font script="Guru" typeface="Raavi"/>
+        <a:font script="Cans" typeface="Euphemia"/>
+        <a:font script="Cher" typeface="Plantagenet Cherokee"/>
+        <a:font script="Yiii" typeface="Microsoft Yi Baiti"/>
+        <a:font script="Tibt" typeface="Microsoft Himalaya"/>
+        <a:font script="Thaa" typeface="MV Boli"/>
+        <a:font script="Deva" typeface="Mangal"/>
+        <a:font script="Telu" typeface="Gautami"/>
+        <a:font script="Taml" typeface="Latha"/>
+        <a:font script="Syrc" typeface="Estrangelo Edessa"/>
+        <a:font script="Orya" typeface="Kalinga"/>
+        <a:font script="Mlym" typeface="Kartika"/>
+        <a:font script="Laoo" typeface="DokChampa"/>
+        <a:font script="Sinh" typeface="Iskoola Pota"/>
+        <a:font script="Mong" typeface="Mongolian Baiti"/>
+        <a:font script="Viet" typeface="Times New Roman"/>
+        <a:font script="Uigh" typeface="Microsoft Uighur"/>
+        <a:font script="Geor" typeface="Sylfaen"/>
+        <a:font script="Armn" typeface="Arial"/>
+        <a:font script="Bugi" typeface="Leelawadee UI"/>
+        <a:font script="Bopo" typeface="Microsoft JhengHei"/>
+        <a:font script="Java" typeface="Javanese Text"/>
+        <a:font script="Lisu" typeface="Segoe UI"/>
+        <a:font script="Mymr" typeface="Myanmar Text"/>
+        <a:font script="Nkoo" typeface="Ebrima"/>
+        <a:font script="Olck" typeface="Nirmala UI"/>
+        <a:font script="Osma" typeface="Ebrima"/>
+        <a:font script="Phag" typeface="Phagspa"/>
+        <a:font script="Syrn" typeface="Estrangelo Edessa"/>
+        <a:font script="Syrj" typeface="Estrangelo Edessa"/>
+        <a:font script="Syre" typeface="Estrangelo Edessa"/>
+        <a:font script="Sora" typeface="Nirmala UI"/>
+        <a:font script="Tale" typeface="Microsoft Tai Le"/>
+        <a:font script="Talu" typeface="Microsoft New Tai Lue"/>
+        <a:font script="Tfng" typeface="Ebrima"/>
+      </a:majorFont>
+      <a:minorFont>
+        <a:latin typeface="Aptos" panose="02110004020202020204"/>
+        <a:ea typeface=""/>
+        <a:cs typeface=""/>
+        <a:font script="Jpan" typeface="游ゴシック"/>
+        <a:font script="Hang" typeface="맑은 고딕"/>
+        <a:font script="Hans" typeface="等线"/>
+        <a:font script="Hant" typeface="新細明體"/>
+        <a:font script="Arab" typeface="Arial"/>
+        <a:font script="Hebr" typeface="Arial"/>
+        <a:font script="Thai" typeface="Cordia New"/>
+        <a:font script="Ethi" typeface="Nyala"/>
+        <a:font script="Beng" typeface="Vrinda"/>
+        <a:font script="Gujr" typeface="Shruti"/>
+        <a:font script="Khmr" typeface="DaunPenh"/>
+        <a:font script="Knda" typeface="Tunga"/>
+        <a:font script="Guru" typeface="Raavi"/>
+        <a:font script="Cans" typeface="Euphemia"/>
+        <a:font script="Cher" typeface="Plantagenet Cherokee"/>
+        <a:font script="Yiii" typeface="Microsoft Yi Baiti"/>
+        <a:font script="Tibt" typeface="Microsoft Himalaya"/>
+        <a:font script="Thaa" typeface="MV Boli"/>
+        <a:font script="Deva" typeface="Mangal"/>
+        <a:font script="Telu" typeface="Gautami"/>
+        <a:font script="Taml" typeface="Latha"/>
+        <a:font script="Syrc" typeface="Estrangelo Edessa"/>
+        <a:font script="Orya" typeface="Kalinga"/>
+        <a:font script="Mlym" typeface="Kartika"/>
+        <a:font script="Laoo" typeface="DokChampa"/>
+        <a:font script="Sinh" typeface="Iskoola Pota"/>
+        <a:font script="Mong" typeface="Mongolian Baiti"/>
+        <a:font script="Viet" typeface="Arial"/>
+        <a:font script="Uigh" typeface="Microsoft Uighur"/>
+        <a:font script="Geor" typeface="Sylfaen"/>
+        <a:font script="Armn" typeface="Arial"/>
+        <a:font script="Bugi" typeface="Leelawadee UI"/>
+        <a:font script="Bopo" typeface="Microsoft JhengHei"/>
+        <a:font script="Java" typeface="Javanese Text"/>
+        <a:font script="Lisu" typeface="Segoe UI"/>
+        <a:font script="Mymr" typeface="Myanmar Text"/>
+        <a:font script="Nkoo" typeface="Ebrima"/>
+        <a:font script="Olck" typeface="Nirmala UI"/>
+        <a:font script="Osma" typeface="Ebrima"/>
+        <a:font script="Phag" typeface="Phagspa"/>
+        <a:font script="Syrn" typeface="Estrangelo Edessa"/>
+        <a:font script="Syrj" typeface="Estrangelo Edessa"/>
+        <a:font script="Syre" typeface="Estrangelo Edessa"/>
+        <a:font script="Sora" typeface="Nirmala UI"/>
+        <a:font script="Tale" typeface="Microsoft Tai Le"/>
+        <a:font script="Talu" typeface="Microsoft New Tai Lue"/>
+        <a:font script="Tfng" typeface="Ebrima"/>
+      </a:minorFont>
+    </a:fontScheme>
+    <a:fmtScheme name="Office">
+      <a:fillStyleLst>
+        <a:solidFill>
+          <a:schemeClr val="phClr"/>
+        </a:solidFill>
+        <a:gradFill rotWithShape="1">
+          <a:gsLst>
+            <a:gs pos="0">
+              <a:schemeClr val="phClr">
+                <a:lumMod val="110000"/>
+                <a:satMod val="105000"/>
+                <a:tint val="67000"/>
+              </a:schemeClr>
+            </a:gs>
+            <a:gs pos="50000">
+              <a:schemeClr val="phClr">
+                <a:lumMod val="105000"/>
+                <a:satMod val="103000"/>
+                <a:tint val="73000"/>
+              </a:schemeClr>
+            </a:gs>
+            <a:gs pos="100000">
+              <a:schemeClr val="phClr">
+                <a:lumMod val="105000"/>
+                <a:satMod val="109000"/>
+                <a:tint val="81000"/>
+              </a:schemeClr>
+            </a:gs>
+          </a:gsLst>
+          <a:lin ang="5400000" scaled="0"/>
+        </a:gradFill>
+        <a:gradFill rotWithShape="1">
+          <a:gsLst>
+            <a:gs pos="0">
+              <a:schemeClr val="phClr">
+                <a:satMod val="103000"/>
+                <a:lumMod val="102000"/>
+                <a:tint val="94000"/>
+              </a:schemeClr>
+            </a:gs>
+            <a:gs pos="50000">
+              <a:schemeClr val="phClr">
+                <a:satMod val="110000"/>
+                <a:lumMod val="100000"/>
+                <a:shade val="100000"/>
+              </a:schemeClr>
+            </a:gs>
+            <a:gs pos="100000">
+              <a:schemeClr val="phClr">
+                <a:lumMod val="99000"/>
+                <a:satMod val="120000"/>
+                <a:shade val="78000"/>
+              </a:schemeClr>
+            </a:gs>
+          </a:gsLst>
+          <a:lin ang="5400000" scaled="0"/>
+        </a:gradFill>
+      </a:fillStyleLst>
+      <a:lnStyleLst>
+        <a:ln w="12700" cap="flat" cmpd="sng" algn="ctr">
+          <a:solidFill>
+            <a:schemeClr val="phClr"/>
+          </a:solidFill>
+          <a:prstDash val="solid"/>
+          <a:miter lim="800000"/>
+        </a:ln>
+        <a:ln w="19050" cap="flat" cmpd="sng" algn="ctr">
+          <a:solidFill>
+            <a:schemeClr val="phClr"/>
+          </a:solidFill>
+          <a:prstDash val="solid"/>
+          <a:miter lim="800000"/>
+        </a:ln>
+        <a:ln w="25400" cap="flat" cmpd="sng" algn="ctr">
+          <a:solidFill>
+            <a:schemeClr val="phClr"/>
+          </a:solidFill>
+          <a:prstDash val="solid"/>
+          <a:miter lim="800000"/>
+        </a:ln>
+      </a:lnStyleLst>
+      <a:effectStyleLst>
+        <a:effectStyle>
+          <a:effectLst/>
+        </a:effectStyle>
+        <a:effectStyle>
+          <a:effectLst/>
+        </a:effectStyle>
+        <a:effectStyle>
+          <a:effectLst>
+            <a:outerShdw blurRad="57150" dist="19050" dir="5400000" algn="ctr" rotWithShape="0">
+              <a:srgbClr val="000000">
+                <a:alpha val="63000"/>
+              </a:srgbClr>
+            </a:outerShdw>
+          </a:effectLst>
+        </a:effectStyle>
+      </a:effectStyleLst>
+      <a:bgFillStyleLst>
+        <a:solidFill>
+          <a:schemeClr val="phClr"/>
+        </a:solidFill>
+        <a:solidFill>
+          <a:schemeClr val="phClr">
+            <a:tint val="95000"/>
+            <a:satMod val="170000"/>
+          </a:schemeClr>
+        </a:solidFill>
+        <a:gradFill rotWithShape="1">
+          <a:gsLst>
+            <a:gs pos="0">
+              <a:schemeClr val="phClr">
+                <a:tint val="93000"/>
+                <a:satMod val="150000"/>
+                <a:shade val="98000"/>
+                <a:lumMod val="102000"/>
+              </a:schemeClr>
+            </a:gs>
+            <a:gs pos="50000">
+              <a:schemeClr val="phClr">
+                <a:tint val="98000"/>
+                <a:satMod val="130000"/>
+                <a:shade val="90000"/>
+                <a:lumMod val="103000"/>
+              </a:schemeClr>
+            </a:gs>
+            <a:gs pos="100000">
+              <a:schemeClr val="phClr">
+                <a:shade val="63000"/>
+                <a:satMod val="120000"/>
+              </a:schemeClr>
+            </a:gs>
+          </a:gsLst>
+          <a:lin ang="5400000" scaled="0"/>
+        </a:gradFill>
+      </a:bgFillStyleLst>
+    </a:fmtScheme>
+  </a:themeElements>
+  <a:objectDefaults>
+    <a:lnDef>
+      <a:spPr/>
+      <a:bodyPr/>
+      <a:lstStyle/>
+      <a:style>
+        <a:lnRef idx="2">
+          <a:schemeClr val="accent1"/>
+        </a:lnRef>
+        <a:fillRef idx="0">
+          <a:schemeClr val="accent1"/>
+        </a:fillRef>
+        <a:effectRef idx="1">
+          <a:schemeClr val="accent1"/>
+        </a:effectRef>
+        <a:fontRef idx="minor">
+          <a:schemeClr val="tx1"/>
+        </a:fontRef>
+      </a:style>
+    </a:lnDef>
+  </a:objectDefaults>
+  <a:extraClrSchemeLst/>
+  <a:extLst>
+    <a:ext uri="{05A4C25C-085E-4340-85A3-A5531E510DB2}">
+      <thm15:themeFamily xmlns:thm15="http://schemas.microsoft.com/office/thememl/2012/main" name="Office Theme" id="{2E142A2C-CD16-42D6-873A-C26D2A0506FA}" vid="{1BDDFF52-6CD6-40A5-AB3C-68EB2F1E4D0A}"/>
+    </a:ext>
+  </a:extLst>
+</a:theme>
 </file>
</xml_diff>

<commit_message>
Update the title image.
</commit_message>
<xml_diff>
--- a/MQTT_RTU_Simulator/doc/designDoc.pptx
+++ b/MQTT_RTU_Simulator/doc/designDoc.pptx
@@ -9,7 +9,7 @@
   </p:notesMasterIdLst>
   <p:sldIdLst>
     <p:sldId id="256" r:id="rId2"/>
-    <p:sldId id="257" r:id="rId3"/>
+    <p:sldId id="260" r:id="rId3"/>
     <p:sldId id="259" r:id="rId4"/>
   </p:sldIdLst>
   <p:sldSz cx="12192000" cy="6858000"/>
@@ -199,7 +199,7 @@
           <a:p>
             <a:fld id="{8AE52297-66E0-4839-ACCC-742E4BD155E6}" type="datetimeFigureOut">
               <a:rPr lang="en-SG" smtClean="0"/>
-              <a:t>5/6/2026</a:t>
+              <a:t>6/6/2026</a:t>
             </a:fld>
             <a:endParaRPr lang="en-SG"/>
           </a:p>
@@ -700,7 +700,7 @@
           <a:p>
             <a:fld id="{605C4233-9FD4-48E0-99C1-555DE8AF0C0C}" type="datetimeFigureOut">
               <a:rPr lang="en-SG" smtClean="0"/>
-              <a:t>5/6/2026</a:t>
+              <a:t>6/6/2026</a:t>
             </a:fld>
             <a:endParaRPr lang="en-SG"/>
           </a:p>
@@ -900,7 +900,7 @@
           <a:p>
             <a:fld id="{605C4233-9FD4-48E0-99C1-555DE8AF0C0C}" type="datetimeFigureOut">
               <a:rPr lang="en-SG" smtClean="0"/>
-              <a:t>5/6/2026</a:t>
+              <a:t>6/6/2026</a:t>
             </a:fld>
             <a:endParaRPr lang="en-SG"/>
           </a:p>
@@ -1110,7 +1110,7 @@
           <a:p>
             <a:fld id="{605C4233-9FD4-48E0-99C1-555DE8AF0C0C}" type="datetimeFigureOut">
               <a:rPr lang="en-SG" smtClean="0"/>
-              <a:t>5/6/2026</a:t>
+              <a:t>6/6/2026</a:t>
             </a:fld>
             <a:endParaRPr lang="en-SG"/>
           </a:p>
@@ -1310,7 +1310,7 @@
           <a:p>
             <a:fld id="{605C4233-9FD4-48E0-99C1-555DE8AF0C0C}" type="datetimeFigureOut">
               <a:rPr lang="en-SG" smtClean="0"/>
-              <a:t>5/6/2026</a:t>
+              <a:t>6/6/2026</a:t>
             </a:fld>
             <a:endParaRPr lang="en-SG"/>
           </a:p>
@@ -1586,7 +1586,7 @@
           <a:p>
             <a:fld id="{605C4233-9FD4-48E0-99C1-555DE8AF0C0C}" type="datetimeFigureOut">
               <a:rPr lang="en-SG" smtClean="0"/>
-              <a:t>5/6/2026</a:t>
+              <a:t>6/6/2026</a:t>
             </a:fld>
             <a:endParaRPr lang="en-SG"/>
           </a:p>
@@ -1854,7 +1854,7 @@
           <a:p>
             <a:fld id="{605C4233-9FD4-48E0-99C1-555DE8AF0C0C}" type="datetimeFigureOut">
               <a:rPr lang="en-SG" smtClean="0"/>
-              <a:t>5/6/2026</a:t>
+              <a:t>6/6/2026</a:t>
             </a:fld>
             <a:endParaRPr lang="en-SG"/>
           </a:p>
@@ -2269,7 +2269,7 @@
           <a:p>
             <a:fld id="{605C4233-9FD4-48E0-99C1-555DE8AF0C0C}" type="datetimeFigureOut">
               <a:rPr lang="en-SG" smtClean="0"/>
-              <a:t>5/6/2026</a:t>
+              <a:t>6/6/2026</a:t>
             </a:fld>
             <a:endParaRPr lang="en-SG"/>
           </a:p>
@@ -2411,7 +2411,7 @@
           <a:p>
             <a:fld id="{605C4233-9FD4-48E0-99C1-555DE8AF0C0C}" type="datetimeFigureOut">
               <a:rPr lang="en-SG" smtClean="0"/>
-              <a:t>5/6/2026</a:t>
+              <a:t>6/6/2026</a:t>
             </a:fld>
             <a:endParaRPr lang="en-SG"/>
           </a:p>
@@ -2524,7 +2524,7 @@
           <a:p>
             <a:fld id="{605C4233-9FD4-48E0-99C1-555DE8AF0C0C}" type="datetimeFigureOut">
               <a:rPr lang="en-SG" smtClean="0"/>
-              <a:t>5/6/2026</a:t>
+              <a:t>6/6/2026</a:t>
             </a:fld>
             <a:endParaRPr lang="en-SG"/>
           </a:p>
@@ -2837,7 +2837,7 @@
           <a:p>
             <a:fld id="{605C4233-9FD4-48E0-99C1-555DE8AF0C0C}" type="datetimeFigureOut">
               <a:rPr lang="en-SG" smtClean="0"/>
-              <a:t>5/6/2026</a:t>
+              <a:t>6/6/2026</a:t>
             </a:fld>
             <a:endParaRPr lang="en-SG"/>
           </a:p>
@@ -3126,7 +3126,7 @@
           <a:p>
             <a:fld id="{605C4233-9FD4-48E0-99C1-555DE8AF0C0C}" type="datetimeFigureOut">
               <a:rPr lang="en-SG" smtClean="0"/>
-              <a:t>5/6/2026</a:t>
+              <a:t>6/6/2026</a:t>
             </a:fld>
             <a:endParaRPr lang="en-SG"/>
           </a:p>
@@ -3369,7 +3369,7 @@
           <a:p>
             <a:fld id="{605C4233-9FD4-48E0-99C1-555DE8AF0C0C}" type="datetimeFigureOut">
               <a:rPr lang="en-SG" smtClean="0"/>
-              <a:t>5/6/2026</a:t>
+              <a:t>6/6/2026</a:t>
             </a:fld>
             <a:endParaRPr lang="en-SG"/>
           </a:p>
@@ -6067,10 +6067,549 @@
           <a:chExt cx="0" cy="0"/>
         </a:xfrm>
       </p:grpSpPr>
+      <p:pic>
+        <p:nvPicPr>
+          <p:cNvPr id="5" name="Picture 4">
+            <a:extLst>
+              <a:ext uri="{FF2B5EF4-FFF2-40B4-BE49-F238E27FC236}">
+                <a16:creationId xmlns:a16="http://schemas.microsoft.com/office/drawing/2014/main" id="{37738C25-E052-0257-A869-D1C328F24447}"/>
+              </a:ext>
+            </a:extLst>
+          </p:cNvPr>
+          <p:cNvPicPr>
+            <a:picLocks noChangeAspect="1"/>
+          </p:cNvPicPr>
+          <p:nvPr/>
+        </p:nvPicPr>
+        <p:blipFill>
+          <a:blip r:embed="rId2"/>
+          <a:stretch>
+            <a:fillRect/>
+          </a:stretch>
+        </p:blipFill>
+        <p:spPr>
+          <a:xfrm>
+            <a:off x="4259019" y="2556491"/>
+            <a:ext cx="7180952" cy="3266667"/>
+          </a:xfrm>
+          <a:prstGeom prst="rect">
+            <a:avLst/>
+          </a:prstGeom>
+          <a:ln w="6350">
+            <a:solidFill>
+              <a:schemeClr val="tx1"/>
+            </a:solidFill>
+          </a:ln>
+        </p:spPr>
+      </p:pic>
+      <p:pic>
+        <p:nvPicPr>
+          <p:cNvPr id="7" name="Picture 6">
+            <a:extLst>
+              <a:ext uri="{FF2B5EF4-FFF2-40B4-BE49-F238E27FC236}">
+                <a16:creationId xmlns:a16="http://schemas.microsoft.com/office/drawing/2014/main" id="{FCE6DC9E-8184-4CFD-2F81-EDD204392605}"/>
+              </a:ext>
+            </a:extLst>
+          </p:cNvPr>
+          <p:cNvPicPr>
+            <a:picLocks noChangeAspect="1"/>
+          </p:cNvPicPr>
+          <p:nvPr/>
+        </p:nvPicPr>
+        <p:blipFill>
+          <a:blip r:embed="rId3"/>
+          <a:stretch>
+            <a:fillRect/>
+          </a:stretch>
+        </p:blipFill>
+        <p:spPr>
+          <a:xfrm>
+            <a:off x="586304" y="1305822"/>
+            <a:ext cx="3022382" cy="1840699"/>
+          </a:xfrm>
+          <a:prstGeom prst="rect">
+            <a:avLst/>
+          </a:prstGeom>
+        </p:spPr>
+      </p:pic>
+      <p:pic>
+        <p:nvPicPr>
+          <p:cNvPr id="9" name="Picture 8">
+            <a:extLst>
+              <a:ext uri="{FF2B5EF4-FFF2-40B4-BE49-F238E27FC236}">
+                <a16:creationId xmlns:a16="http://schemas.microsoft.com/office/drawing/2014/main" id="{19A4F57C-D367-A6CC-BAC5-95C99A650F02}"/>
+              </a:ext>
+            </a:extLst>
+          </p:cNvPr>
+          <p:cNvPicPr>
+            <a:picLocks noChangeAspect="1"/>
+          </p:cNvPicPr>
+          <p:nvPr/>
+        </p:nvPicPr>
+        <p:blipFill>
+          <a:blip r:embed="rId4"/>
+          <a:stretch>
+            <a:fillRect/>
+          </a:stretch>
+        </p:blipFill>
+        <p:spPr>
+          <a:xfrm>
+            <a:off x="333057" y="4681599"/>
+            <a:ext cx="3432119" cy="975686"/>
+          </a:xfrm>
+          <a:prstGeom prst="rect">
+            <a:avLst/>
+          </a:prstGeom>
+        </p:spPr>
+      </p:pic>
+      <p:cxnSp>
+        <p:nvCxnSpPr>
+          <p:cNvPr id="13" name="Connector: Elbow 12">
+            <a:extLst>
+              <a:ext uri="{FF2B5EF4-FFF2-40B4-BE49-F238E27FC236}">
+                <a16:creationId xmlns:a16="http://schemas.microsoft.com/office/drawing/2014/main" id="{AC0C289C-6E33-295A-FD87-9A804E6102EA}"/>
+              </a:ext>
+            </a:extLst>
+          </p:cNvPr>
+          <p:cNvCxnSpPr>
+            <a:cxnSpLocks/>
+          </p:cNvCxnSpPr>
+          <p:nvPr/>
+        </p:nvCxnSpPr>
+        <p:spPr>
+          <a:xfrm flipV="1">
+            <a:off x="1204856" y="3429000"/>
+            <a:ext cx="3506993" cy="1637852"/>
+          </a:xfrm>
+          <a:prstGeom prst="bentConnector3">
+            <a:avLst>
+              <a:gd name="adj1" fmla="val 307"/>
+            </a:avLst>
+          </a:prstGeom>
+          <a:ln>
+            <a:solidFill>
+              <a:srgbClr val="FF0000"/>
+            </a:solidFill>
+            <a:tailEnd type="triangle"/>
+          </a:ln>
+        </p:spPr>
+        <p:style>
+          <a:lnRef idx="2">
+            <a:schemeClr val="accent1"/>
+          </a:lnRef>
+          <a:fillRef idx="0">
+            <a:schemeClr val="accent1"/>
+          </a:fillRef>
+          <a:effectRef idx="1">
+            <a:schemeClr val="accent1"/>
+          </a:effectRef>
+          <a:fontRef idx="minor">
+            <a:schemeClr val="tx1"/>
+          </a:fontRef>
+        </p:style>
+      </p:cxnSp>
+      <p:cxnSp>
+        <p:nvCxnSpPr>
+          <p:cNvPr id="16" name="Connector: Elbow 15">
+            <a:extLst>
+              <a:ext uri="{FF2B5EF4-FFF2-40B4-BE49-F238E27FC236}">
+                <a16:creationId xmlns:a16="http://schemas.microsoft.com/office/drawing/2014/main" id="{78A17C32-136B-9AD9-C7AE-4105FB275BC6}"/>
+              </a:ext>
+            </a:extLst>
+          </p:cNvPr>
+          <p:cNvCxnSpPr>
+            <a:cxnSpLocks/>
+          </p:cNvCxnSpPr>
+          <p:nvPr/>
+        </p:nvCxnSpPr>
+        <p:spPr>
+          <a:xfrm flipV="1">
+            <a:off x="1871831" y="3609990"/>
+            <a:ext cx="2765144" cy="1454548"/>
+          </a:xfrm>
+          <a:prstGeom prst="bentConnector3">
+            <a:avLst>
+              <a:gd name="adj1" fmla="val 591"/>
+            </a:avLst>
+          </a:prstGeom>
+          <a:ln>
+            <a:solidFill>
+              <a:srgbClr val="FF0000"/>
+            </a:solidFill>
+            <a:tailEnd type="triangle"/>
+          </a:ln>
+        </p:spPr>
+        <p:style>
+          <a:lnRef idx="2">
+            <a:schemeClr val="accent1"/>
+          </a:lnRef>
+          <a:fillRef idx="0">
+            <a:schemeClr val="accent1"/>
+          </a:fillRef>
+          <a:effectRef idx="1">
+            <a:schemeClr val="accent1"/>
+          </a:effectRef>
+          <a:fontRef idx="minor">
+            <a:schemeClr val="tx1"/>
+          </a:fontRef>
+        </p:style>
+      </p:cxnSp>
+      <p:cxnSp>
+        <p:nvCxnSpPr>
+          <p:cNvPr id="22" name="Connector: Elbow 21">
+            <a:extLst>
+              <a:ext uri="{FF2B5EF4-FFF2-40B4-BE49-F238E27FC236}">
+                <a16:creationId xmlns:a16="http://schemas.microsoft.com/office/drawing/2014/main" id="{0FB93432-4827-7C4B-941C-32860D14A8ED}"/>
+              </a:ext>
+            </a:extLst>
+          </p:cNvPr>
+          <p:cNvCxnSpPr>
+            <a:cxnSpLocks/>
+          </p:cNvCxnSpPr>
+          <p:nvPr/>
+        </p:nvCxnSpPr>
+        <p:spPr>
+          <a:xfrm flipV="1">
+            <a:off x="2508898" y="3772821"/>
+            <a:ext cx="2127648" cy="1291717"/>
+          </a:xfrm>
+          <a:prstGeom prst="bentConnector3">
+            <a:avLst>
+              <a:gd name="adj1" fmla="val 956"/>
+            </a:avLst>
+          </a:prstGeom>
+          <a:ln>
+            <a:solidFill>
+              <a:srgbClr val="FF0000"/>
+            </a:solidFill>
+            <a:tailEnd type="triangle"/>
+          </a:ln>
+        </p:spPr>
+        <p:style>
+          <a:lnRef idx="2">
+            <a:schemeClr val="accent1"/>
+          </a:lnRef>
+          <a:fillRef idx="0">
+            <a:schemeClr val="accent1"/>
+          </a:fillRef>
+          <a:effectRef idx="1">
+            <a:schemeClr val="accent1"/>
+          </a:effectRef>
+          <a:fontRef idx="minor">
+            <a:schemeClr val="tx1"/>
+          </a:fontRef>
+        </p:style>
+      </p:cxnSp>
+      <p:cxnSp>
+        <p:nvCxnSpPr>
+          <p:cNvPr id="29" name="Connector: Elbow 28">
+            <a:extLst>
+              <a:ext uri="{FF2B5EF4-FFF2-40B4-BE49-F238E27FC236}">
+                <a16:creationId xmlns:a16="http://schemas.microsoft.com/office/drawing/2014/main" id="{B8181D89-EE42-D538-8F0D-A1CA061A3891}"/>
+              </a:ext>
+            </a:extLst>
+          </p:cNvPr>
+          <p:cNvCxnSpPr>
+            <a:cxnSpLocks/>
+          </p:cNvCxnSpPr>
+          <p:nvPr/>
+        </p:nvCxnSpPr>
+        <p:spPr>
+          <a:xfrm flipV="1">
+            <a:off x="2958352" y="3974708"/>
+            <a:ext cx="1592133" cy="1089830"/>
+          </a:xfrm>
+          <a:prstGeom prst="bentConnector3">
+            <a:avLst>
+              <a:gd name="adj1" fmla="val 1351"/>
+            </a:avLst>
+          </a:prstGeom>
+          <a:ln>
+            <a:solidFill>
+              <a:srgbClr val="FF0000"/>
+            </a:solidFill>
+            <a:tailEnd type="triangle"/>
+          </a:ln>
+        </p:spPr>
+        <p:style>
+          <a:lnRef idx="2">
+            <a:schemeClr val="accent1"/>
+          </a:lnRef>
+          <a:fillRef idx="0">
+            <a:schemeClr val="accent1"/>
+          </a:fillRef>
+          <a:effectRef idx="1">
+            <a:schemeClr val="accent1"/>
+          </a:effectRef>
+          <a:fontRef idx="minor">
+            <a:schemeClr val="tx1"/>
+          </a:fontRef>
+        </p:style>
+      </p:cxnSp>
+      <p:cxnSp>
+        <p:nvCxnSpPr>
+          <p:cNvPr id="33" name="Connector: Elbow 32">
+            <a:extLst>
+              <a:ext uri="{FF2B5EF4-FFF2-40B4-BE49-F238E27FC236}">
+                <a16:creationId xmlns:a16="http://schemas.microsoft.com/office/drawing/2014/main" id="{AE661110-EC32-0846-D5ED-AF5BD54D33FC}"/>
+              </a:ext>
+            </a:extLst>
+          </p:cNvPr>
+          <p:cNvCxnSpPr>
+            <a:cxnSpLocks/>
+          </p:cNvCxnSpPr>
+          <p:nvPr/>
+        </p:nvCxnSpPr>
+        <p:spPr>
+          <a:xfrm flipV="1">
+            <a:off x="3560307" y="4137539"/>
+            <a:ext cx="1076239" cy="926999"/>
+          </a:xfrm>
+          <a:prstGeom prst="bentConnector3">
+            <a:avLst>
+              <a:gd name="adj1" fmla="val 4020"/>
+            </a:avLst>
+          </a:prstGeom>
+          <a:ln>
+            <a:solidFill>
+              <a:srgbClr val="FF0000"/>
+            </a:solidFill>
+            <a:tailEnd type="triangle"/>
+          </a:ln>
+        </p:spPr>
+        <p:style>
+          <a:lnRef idx="2">
+            <a:schemeClr val="accent1"/>
+          </a:lnRef>
+          <a:fillRef idx="0">
+            <a:schemeClr val="accent1"/>
+          </a:fillRef>
+          <a:effectRef idx="1">
+            <a:schemeClr val="accent1"/>
+          </a:effectRef>
+          <a:fontRef idx="minor">
+            <a:schemeClr val="tx1"/>
+          </a:fontRef>
+        </p:style>
+      </p:cxnSp>
+      <p:cxnSp>
+        <p:nvCxnSpPr>
+          <p:cNvPr id="37" name="Connector: Elbow 36">
+            <a:extLst>
+              <a:ext uri="{FF2B5EF4-FFF2-40B4-BE49-F238E27FC236}">
+                <a16:creationId xmlns:a16="http://schemas.microsoft.com/office/drawing/2014/main" id="{249107FD-D0D5-F0D2-4B03-5D47AF4F8AFD}"/>
+              </a:ext>
+            </a:extLst>
+          </p:cNvPr>
+          <p:cNvCxnSpPr>
+            <a:cxnSpLocks/>
+          </p:cNvCxnSpPr>
+          <p:nvPr/>
+        </p:nvCxnSpPr>
+        <p:spPr>
+          <a:xfrm>
+            <a:off x="1678193" y="2669366"/>
+            <a:ext cx="3130475" cy="254041"/>
+          </a:xfrm>
+          <a:prstGeom prst="bentConnector3">
+            <a:avLst>
+              <a:gd name="adj1" fmla="val -515"/>
+            </a:avLst>
+          </a:prstGeom>
+          <a:ln>
+            <a:solidFill>
+              <a:srgbClr val="FF0000"/>
+            </a:solidFill>
+            <a:tailEnd type="triangle"/>
+          </a:ln>
+        </p:spPr>
+        <p:style>
+          <a:lnRef idx="2">
+            <a:schemeClr val="accent1"/>
+          </a:lnRef>
+          <a:fillRef idx="0">
+            <a:schemeClr val="accent1"/>
+          </a:fillRef>
+          <a:effectRef idx="1">
+            <a:schemeClr val="accent1"/>
+          </a:effectRef>
+          <a:fontRef idx="minor">
+            <a:schemeClr val="tx1"/>
+          </a:fontRef>
+        </p:style>
+      </p:cxnSp>
+      <p:cxnSp>
+        <p:nvCxnSpPr>
+          <p:cNvPr id="43" name="Connector: Elbow 42">
+            <a:extLst>
+              <a:ext uri="{FF2B5EF4-FFF2-40B4-BE49-F238E27FC236}">
+                <a16:creationId xmlns:a16="http://schemas.microsoft.com/office/drawing/2014/main" id="{127B6D4F-0DA4-CEEF-56A2-8E1C35F73EF8}"/>
+              </a:ext>
+            </a:extLst>
+          </p:cNvPr>
+          <p:cNvCxnSpPr>
+            <a:cxnSpLocks/>
+          </p:cNvCxnSpPr>
+          <p:nvPr/>
+        </p:nvCxnSpPr>
+        <p:spPr>
+          <a:xfrm>
+            <a:off x="2700169" y="2667052"/>
+            <a:ext cx="2108499" cy="447003"/>
+          </a:xfrm>
+          <a:prstGeom prst="bentConnector3">
+            <a:avLst>
+              <a:gd name="adj1" fmla="val -1020"/>
+            </a:avLst>
+          </a:prstGeom>
+          <a:ln>
+            <a:solidFill>
+              <a:srgbClr val="FF0000"/>
+            </a:solidFill>
+            <a:tailEnd type="triangle"/>
+          </a:ln>
+        </p:spPr>
+        <p:style>
+          <a:lnRef idx="2">
+            <a:schemeClr val="accent1"/>
+          </a:lnRef>
+          <a:fillRef idx="0">
+            <a:schemeClr val="accent1"/>
+          </a:fillRef>
+          <a:effectRef idx="1">
+            <a:schemeClr val="accent1"/>
+          </a:effectRef>
+          <a:fontRef idx="minor">
+            <a:schemeClr val="tx1"/>
+          </a:fontRef>
+        </p:style>
+      </p:cxnSp>
+      <p:pic>
+        <p:nvPicPr>
+          <p:cNvPr id="48" name="Picture 47">
+            <a:extLst>
+              <a:ext uri="{FF2B5EF4-FFF2-40B4-BE49-F238E27FC236}">
+                <a16:creationId xmlns:a16="http://schemas.microsoft.com/office/drawing/2014/main" id="{74D4D41A-BC46-B1BC-A1DB-A4993A13B715}"/>
+              </a:ext>
+            </a:extLst>
+          </p:cNvPr>
+          <p:cNvPicPr>
+            <a:picLocks noChangeAspect="1"/>
+          </p:cNvPicPr>
+          <p:nvPr/>
+        </p:nvPicPr>
+        <p:blipFill>
+          <a:blip r:embed="rId5"/>
+          <a:stretch>
+            <a:fillRect/>
+          </a:stretch>
+        </p:blipFill>
+        <p:spPr>
+          <a:xfrm>
+            <a:off x="6624668" y="373941"/>
+            <a:ext cx="4981028" cy="1863762"/>
+          </a:xfrm>
+          <a:prstGeom prst="rect">
+            <a:avLst/>
+          </a:prstGeom>
+        </p:spPr>
+      </p:pic>
+      <p:cxnSp>
+        <p:nvCxnSpPr>
+          <p:cNvPr id="49" name="Connector: Elbow 48">
+            <a:extLst>
+              <a:ext uri="{FF2B5EF4-FFF2-40B4-BE49-F238E27FC236}">
+                <a16:creationId xmlns:a16="http://schemas.microsoft.com/office/drawing/2014/main" id="{16193D10-1706-C832-B215-C9E374587B84}"/>
+              </a:ext>
+            </a:extLst>
+          </p:cNvPr>
+          <p:cNvCxnSpPr>
+            <a:cxnSpLocks/>
+          </p:cNvCxnSpPr>
+          <p:nvPr/>
+        </p:nvCxnSpPr>
+        <p:spPr>
+          <a:xfrm rot="10800000" flipV="1">
+            <a:off x="5567333" y="1790700"/>
+            <a:ext cx="3083608" cy="1501140"/>
+          </a:xfrm>
+          <a:prstGeom prst="bentConnector3">
+            <a:avLst>
+              <a:gd name="adj1" fmla="val 112"/>
+            </a:avLst>
+          </a:prstGeom>
+          <a:ln>
+            <a:solidFill>
+              <a:srgbClr val="FF0000"/>
+            </a:solidFill>
+            <a:tailEnd type="triangle"/>
+          </a:ln>
+        </p:spPr>
+        <p:style>
+          <a:lnRef idx="2">
+            <a:schemeClr val="accent1"/>
+          </a:lnRef>
+          <a:fillRef idx="0">
+            <a:schemeClr val="accent1"/>
+          </a:fillRef>
+          <a:effectRef idx="1">
+            <a:schemeClr val="accent1"/>
+          </a:effectRef>
+          <a:fontRef idx="minor">
+            <a:schemeClr val="tx1"/>
+          </a:fontRef>
+        </p:style>
+      </p:cxnSp>
+      <p:cxnSp>
+        <p:nvCxnSpPr>
+          <p:cNvPr id="55" name="Connector: Elbow 54">
+            <a:extLst>
+              <a:ext uri="{FF2B5EF4-FFF2-40B4-BE49-F238E27FC236}">
+                <a16:creationId xmlns:a16="http://schemas.microsoft.com/office/drawing/2014/main" id="{8A673DD9-2D19-8CD6-2D8F-A8574626C632}"/>
+              </a:ext>
+            </a:extLst>
+          </p:cNvPr>
+          <p:cNvCxnSpPr>
+            <a:cxnSpLocks/>
+          </p:cNvCxnSpPr>
+          <p:nvPr/>
+        </p:nvCxnSpPr>
+        <p:spPr>
+          <a:xfrm rot="10800000" flipV="1">
+            <a:off x="6013526" y="2065466"/>
+            <a:ext cx="4845939" cy="2194562"/>
+          </a:xfrm>
+          <a:prstGeom prst="bentConnector3">
+            <a:avLst>
+              <a:gd name="adj1" fmla="val 940"/>
+            </a:avLst>
+          </a:prstGeom>
+          <a:ln>
+            <a:solidFill>
+              <a:srgbClr val="FF0000"/>
+            </a:solidFill>
+            <a:tailEnd type="triangle"/>
+          </a:ln>
+        </p:spPr>
+        <p:style>
+          <a:lnRef idx="2">
+            <a:schemeClr val="accent1"/>
+          </a:lnRef>
+          <a:fillRef idx="0">
+            <a:schemeClr val="accent1"/>
+          </a:fillRef>
+          <a:effectRef idx="1">
+            <a:schemeClr val="accent1"/>
+          </a:effectRef>
+          <a:fontRef idx="minor">
+            <a:schemeClr val="tx1"/>
+          </a:fontRef>
+        </p:style>
+      </p:cxnSp>
     </p:spTree>
     <p:extLst>
       <p:ext uri="{BB962C8B-B14F-4D97-AF65-F5344CB8AC3E}">
-        <p14:creationId xmlns:p14="http://schemas.microsoft.com/office/powerpoint/2010/main" val="4116987690"/>
+        <p14:creationId xmlns:p14="http://schemas.microsoft.com/office/powerpoint/2010/main" val="975340296"/>
       </p:ext>
     </p:extLst>
   </p:cSld>
@@ -6111,7 +6650,7 @@
         </p:nvSpPr>
         <p:spPr>
           <a:xfrm>
-            <a:off x="4530382" y="1304591"/>
+            <a:off x="4530382" y="2228135"/>
             <a:ext cx="2111994" cy="842526"/>
           </a:xfrm>
           <a:prstGeom prst="rect">
@@ -6163,7 +6702,7 @@
         </p:nvSpPr>
         <p:spPr>
           <a:xfrm>
-            <a:off x="8178872" y="3614553"/>
+            <a:off x="8178872" y="4538097"/>
             <a:ext cx="2931492" cy="1846356"/>
           </a:xfrm>
           <a:prstGeom prst="rect">
@@ -6215,7 +6754,7 @@
         </p:nvSpPr>
         <p:spPr>
           <a:xfrm>
-            <a:off x="4543840" y="2419754"/>
+            <a:off x="4543840" y="3343298"/>
             <a:ext cx="2489871" cy="2995813"/>
           </a:xfrm>
           <a:prstGeom prst="rect">
@@ -6267,7 +6806,7 @@
         </p:nvSpPr>
         <p:spPr>
           <a:xfrm>
-            <a:off x="548582" y="851571"/>
+            <a:off x="548582" y="1775115"/>
             <a:ext cx="3413179" cy="4609338"/>
           </a:xfrm>
           <a:prstGeom prst="rect">
@@ -6319,7 +6858,7 @@
         </p:nvSpPr>
         <p:spPr>
           <a:xfrm>
-            <a:off x="583270" y="850523"/>
+            <a:off x="583270" y="1774067"/>
             <a:ext cx="3060849" cy="307777"/>
           </a:xfrm>
           <a:prstGeom prst="rect">
@@ -6372,7 +6911,7 @@
         </p:nvSpPr>
         <p:spPr>
           <a:xfrm>
-            <a:off x="4530381" y="2511947"/>
+            <a:off x="4530381" y="3435491"/>
             <a:ext cx="2732878" cy="523220"/>
           </a:xfrm>
           <a:prstGeom prst="rect">
@@ -6420,7 +6959,7 @@
         </p:nvSpPr>
         <p:spPr>
           <a:xfrm>
-            <a:off x="4355376" y="955243"/>
+            <a:off x="4355376" y="1878787"/>
             <a:ext cx="2884604" cy="307777"/>
           </a:xfrm>
           <a:prstGeom prst="rect">
@@ -6456,7 +6995,7 @@
         </p:nvSpPr>
         <p:spPr>
           <a:xfrm>
-            <a:off x="5219105" y="3292531"/>
+            <a:off x="5219105" y="4216075"/>
             <a:ext cx="1494965" cy="295727"/>
           </a:xfrm>
           <a:prstGeom prst="rect">
@@ -6528,7 +7067,7 @@
         </p:blipFill>
         <p:spPr>
           <a:xfrm>
-            <a:off x="5415143" y="3874018"/>
+            <a:off x="5415143" y="4797562"/>
             <a:ext cx="762864" cy="663898"/>
           </a:xfrm>
           <a:prstGeom prst="rect">
@@ -6557,7 +7096,7 @@
         </p:nvCxnSpPr>
         <p:spPr>
           <a:xfrm>
-            <a:off x="5796575" y="3580043"/>
+            <a:off x="5796575" y="4503587"/>
             <a:ext cx="0" cy="245081"/>
           </a:xfrm>
           <a:prstGeom prst="straightConnector1">
@@ -6597,7 +7136,7 @@
         </p:nvSpPr>
         <p:spPr>
           <a:xfrm>
-            <a:off x="508106" y="458841"/>
+            <a:off x="508106" y="1382385"/>
             <a:ext cx="3211175" cy="307777"/>
           </a:xfrm>
           <a:prstGeom prst="rect">
@@ -6633,7 +7172,7 @@
         </p:nvSpPr>
         <p:spPr>
           <a:xfrm>
-            <a:off x="4733726" y="3852704"/>
+            <a:off x="4733726" y="4776248"/>
             <a:ext cx="875441" cy="646331"/>
           </a:xfrm>
           <a:prstGeom prst="rect">
@@ -6681,7 +7220,7 @@
         </p:nvSpPr>
         <p:spPr>
           <a:xfrm>
-            <a:off x="8178871" y="821977"/>
+            <a:off x="8178871" y="1745521"/>
             <a:ext cx="2884605" cy="2362589"/>
           </a:xfrm>
           <a:prstGeom prst="rect">
@@ -6733,7 +7272,7 @@
         </p:nvSpPr>
         <p:spPr>
           <a:xfrm>
-            <a:off x="8211674" y="476259"/>
+            <a:off x="8211674" y="1399803"/>
             <a:ext cx="3211175" cy="307777"/>
           </a:xfrm>
           <a:prstGeom prst="rect">
@@ -6769,7 +7308,7 @@
         </p:nvSpPr>
         <p:spPr>
           <a:xfrm>
-            <a:off x="8211674" y="913468"/>
+            <a:off x="8211674" y="1837012"/>
             <a:ext cx="2732878" cy="307777"/>
           </a:xfrm>
           <a:prstGeom prst="rect">
@@ -6818,7 +7357,7 @@
         </p:blipFill>
         <p:spPr>
           <a:xfrm>
-            <a:off x="8394788" y="4041852"/>
+            <a:off x="8394788" y="4965396"/>
             <a:ext cx="2602019" cy="1235491"/>
           </a:xfrm>
           <a:prstGeom prst="rect">
@@ -6840,7 +7379,7 @@
         </p:nvSpPr>
         <p:spPr>
           <a:xfrm>
-            <a:off x="5247599" y="4856375"/>
+            <a:off x="5247599" y="5779919"/>
             <a:ext cx="1573581" cy="295727"/>
           </a:xfrm>
           <a:prstGeom prst="rect">
@@ -6912,7 +7451,7 @@
         </p:blipFill>
         <p:spPr>
           <a:xfrm>
-            <a:off x="659875" y="1193579"/>
+            <a:off x="659875" y="2117123"/>
             <a:ext cx="3195221" cy="1645539"/>
           </a:xfrm>
           <a:prstGeom prst="rect">
@@ -6947,7 +7486,7 @@
         </p:blipFill>
         <p:spPr>
           <a:xfrm>
-            <a:off x="671388" y="3184566"/>
+            <a:off x="671388" y="4108110"/>
             <a:ext cx="1378905" cy="807385"/>
           </a:xfrm>
           <a:prstGeom prst="rect">
@@ -6982,7 +7521,7 @@
         </p:blipFill>
         <p:spPr>
           <a:xfrm>
-            <a:off x="668422" y="4509865"/>
+            <a:off x="668422" y="5433409"/>
             <a:ext cx="1368021" cy="778550"/>
           </a:xfrm>
           <a:prstGeom prst="rect">
@@ -7017,7 +7556,7 @@
         </p:blipFill>
         <p:spPr>
           <a:xfrm>
-            <a:off x="2253086" y="3174801"/>
+            <a:off x="2253086" y="4098345"/>
             <a:ext cx="1295102" cy="810484"/>
           </a:xfrm>
           <a:prstGeom prst="rect">
@@ -7052,7 +7591,7 @@
         </p:blipFill>
         <p:spPr>
           <a:xfrm>
-            <a:off x="2239235" y="4537731"/>
+            <a:off x="2239235" y="5461275"/>
             <a:ext cx="1260611" cy="777199"/>
           </a:xfrm>
           <a:prstGeom prst="rect">
@@ -7079,7 +7618,7 @@
         </p:nvSpPr>
         <p:spPr>
           <a:xfrm>
-            <a:off x="3604731" y="1587600"/>
+            <a:off x="3604731" y="2511144"/>
             <a:ext cx="965256" cy="340962"/>
           </a:xfrm>
           <a:prstGeom prst="rect">
@@ -7130,7 +7669,7 @@
         </p:nvSpPr>
         <p:spPr>
           <a:xfrm>
-            <a:off x="631531" y="2869214"/>
+            <a:off x="631531" y="3792758"/>
             <a:ext cx="2947966" cy="307777"/>
           </a:xfrm>
           <a:prstGeom prst="rect">
@@ -7176,7 +7715,7 @@
         </p:nvCxnSpPr>
         <p:spPr>
           <a:xfrm rot="5400000" flipH="1" flipV="1">
-            <a:off x="2304298" y="2564037"/>
+            <a:off x="2304298" y="3487581"/>
             <a:ext cx="484457" cy="2371372"/>
           </a:xfrm>
           <a:prstGeom prst="bentConnector4">
@@ -7215,7 +7754,7 @@
         </p:nvSpPr>
         <p:spPr>
           <a:xfrm>
-            <a:off x="3732213" y="3227914"/>
+            <a:off x="3732213" y="4151458"/>
             <a:ext cx="1183100" cy="559160"/>
           </a:xfrm>
           <a:prstGeom prst="rect">
@@ -7269,7 +7808,7 @@
         </p:nvCxnSpPr>
         <p:spPr>
           <a:xfrm>
-            <a:off x="2900637" y="3985285"/>
+            <a:off x="2900637" y="4908829"/>
             <a:ext cx="0" cy="180054"/>
           </a:xfrm>
           <a:prstGeom prst="line">
@@ -7309,7 +7848,7 @@
         </p:nvCxnSpPr>
         <p:spPr>
           <a:xfrm rot="16200000" flipH="1">
-            <a:off x="2333626" y="3528672"/>
+            <a:off x="2333626" y="4452216"/>
             <a:ext cx="395820" cy="2358206"/>
           </a:xfrm>
           <a:prstGeom prst="bentConnector4">
@@ -7348,7 +7887,7 @@
         </p:nvSpPr>
         <p:spPr>
           <a:xfrm>
-            <a:off x="3710639" y="4626105"/>
+            <a:off x="3710639" y="5549649"/>
             <a:ext cx="1183100" cy="559160"/>
           </a:xfrm>
           <a:prstGeom prst="rect">
@@ -7403,7 +7942,7 @@
         </p:nvCxnSpPr>
         <p:spPr>
           <a:xfrm>
-            <a:off x="2869540" y="4329811"/>
+            <a:off x="2869540" y="5253355"/>
             <a:ext cx="1" cy="207920"/>
           </a:xfrm>
           <a:prstGeom prst="line">
@@ -7441,7 +7980,7 @@
         </p:nvCxnSpPr>
         <p:spPr>
           <a:xfrm>
-            <a:off x="5780178" y="4527070"/>
+            <a:off x="5780178" y="5450614"/>
             <a:ext cx="0" cy="329305"/>
           </a:xfrm>
           <a:prstGeom prst="straightConnector1">
@@ -7484,7 +8023,7 @@
         </p:nvCxnSpPr>
         <p:spPr>
           <a:xfrm>
-            <a:off x="4915313" y="3429000"/>
+            <a:off x="4915313" y="4352544"/>
             <a:ext cx="303792" cy="0"/>
           </a:xfrm>
           <a:prstGeom prst="straightConnector1">
@@ -7526,7 +8065,7 @@
         </p:nvCxnSpPr>
         <p:spPr>
           <a:xfrm flipH="1" flipV="1">
-            <a:off x="4872774" y="4982870"/>
+            <a:off x="4872774" y="5906414"/>
             <a:ext cx="353860" cy="0"/>
           </a:xfrm>
           <a:prstGeom prst="straightConnector1">
@@ -7566,7 +8105,7 @@
         </p:nvSpPr>
         <p:spPr>
           <a:xfrm>
-            <a:off x="4627293" y="1293661"/>
+            <a:off x="4627293" y="2217205"/>
             <a:ext cx="1741925" cy="307777"/>
           </a:xfrm>
           <a:prstGeom prst="rect">
@@ -7607,7 +8146,7 @@
         </p:nvSpPr>
         <p:spPr>
           <a:xfrm>
-            <a:off x="6509352" y="3855691"/>
+            <a:off x="6509352" y="4779235"/>
             <a:ext cx="965256" cy="340962"/>
           </a:xfrm>
           <a:prstGeom prst="rect">
@@ -7660,7 +8199,7 @@
         </p:nvCxnSpPr>
         <p:spPr>
           <a:xfrm>
-            <a:off x="6566585" y="3594022"/>
+            <a:off x="6566585" y="4517566"/>
             <a:ext cx="0" cy="258682"/>
           </a:xfrm>
           <a:prstGeom prst="line">
@@ -7698,7 +8237,7 @@
         </p:nvCxnSpPr>
         <p:spPr>
           <a:xfrm>
-            <a:off x="6632678" y="4626105"/>
+            <a:off x="6632678" y="5549649"/>
             <a:ext cx="0" cy="230270"/>
           </a:xfrm>
           <a:prstGeom prst="line">
@@ -7734,7 +8273,7 @@
         </p:nvSpPr>
         <p:spPr>
           <a:xfrm>
-            <a:off x="7896759" y="1587600"/>
+            <a:off x="7896759" y="2511144"/>
             <a:ext cx="996059" cy="281016"/>
           </a:xfrm>
           <a:prstGeom prst="rect">
@@ -7793,7 +8332,7 @@
         </p:blipFill>
         <p:spPr>
           <a:xfrm>
-            <a:off x="8266051" y="913468"/>
+            <a:off x="8266051" y="1837012"/>
             <a:ext cx="621263" cy="540667"/>
           </a:xfrm>
           <a:prstGeom prst="rect">
@@ -7820,7 +8359,7 @@
         </p:nvSpPr>
         <p:spPr>
           <a:xfrm>
-            <a:off x="8982531" y="870413"/>
+            <a:off x="8982531" y="1793957"/>
             <a:ext cx="801928" cy="646331"/>
           </a:xfrm>
           <a:prstGeom prst="rect">
@@ -7859,7 +8398,7 @@
         </p:nvCxnSpPr>
         <p:spPr>
           <a:xfrm flipV="1">
-            <a:off x="4569987" y="1728108"/>
+            <a:off x="4569987" y="2651652"/>
             <a:ext cx="3326772" cy="0"/>
           </a:xfrm>
           <a:prstGeom prst="straightConnector1">
@@ -7904,7 +8443,7 @@
         </p:nvSpPr>
         <p:spPr>
           <a:xfrm>
-            <a:off x="4664451" y="1712759"/>
+            <a:off x="4664451" y="2636303"/>
             <a:ext cx="2130235" cy="261610"/>
           </a:xfrm>
           <a:prstGeom prst="rect">
@@ -7955,7 +8494,7 @@
         </p:nvCxnSpPr>
         <p:spPr>
           <a:xfrm rot="5400000" flipH="1" flipV="1">
-            <a:off x="6509149" y="2597675"/>
+            <a:off x="6509149" y="3521219"/>
             <a:ext cx="2141721" cy="633500"/>
           </a:xfrm>
           <a:prstGeom prst="bentConnector3">
@@ -8002,7 +8541,7 @@
         </p:nvSpPr>
         <p:spPr>
           <a:xfrm>
-            <a:off x="6682734" y="2935383"/>
+            <a:off x="6682734" y="3858927"/>
             <a:ext cx="1133810" cy="600164"/>
           </a:xfrm>
           <a:prstGeom prst="rect">
@@ -8055,7 +8594,7 @@
         </p:nvCxnSpPr>
         <p:spPr>
           <a:xfrm rot="5400000">
-            <a:off x="6599961" y="2604096"/>
+            <a:off x="6599961" y="3527640"/>
             <a:ext cx="2296723" cy="547428"/>
           </a:xfrm>
           <a:prstGeom prst="bentConnector2">
@@ -8100,7 +8639,7 @@
         </p:nvSpPr>
         <p:spPr>
           <a:xfrm>
-            <a:off x="7379947" y="2034495"/>
+            <a:off x="7379947" y="2958039"/>
             <a:ext cx="1259347" cy="769441"/>
           </a:xfrm>
           <a:prstGeom prst="rect">
@@ -8143,7 +8682,7 @@
         </p:nvCxnSpPr>
         <p:spPr>
           <a:xfrm flipH="1">
-            <a:off x="8576682" y="1454135"/>
+            <a:off x="8576682" y="2377679"/>
             <a:ext cx="1" cy="133465"/>
           </a:xfrm>
           <a:prstGeom prst="straightConnector1">
@@ -8197,7 +8736,7 @@
         </p:blipFill>
         <p:spPr>
           <a:xfrm>
-            <a:off x="9690974" y="1358450"/>
+            <a:off x="9690974" y="2281994"/>
             <a:ext cx="1114477" cy="1768627"/>
           </a:xfrm>
           <a:prstGeom prst="rect">
@@ -8224,7 +8763,7 @@
         </p:nvSpPr>
         <p:spPr>
           <a:xfrm>
-            <a:off x="9095485" y="1951153"/>
+            <a:off x="9095485" y="2874697"/>
             <a:ext cx="965256" cy="340962"/>
           </a:xfrm>
           <a:prstGeom prst="rect">
@@ -8279,7 +8818,7 @@
         </p:nvCxnSpPr>
         <p:spPr>
           <a:xfrm>
-            <a:off x="8892818" y="1728108"/>
+            <a:off x="8892818" y="2651652"/>
             <a:ext cx="685295" cy="223045"/>
           </a:xfrm>
           <a:prstGeom prst="bentConnector2">
@@ -8324,7 +8863,7 @@
         </p:nvSpPr>
         <p:spPr>
           <a:xfrm>
-            <a:off x="9742000" y="809633"/>
+            <a:off x="9742000" y="1733177"/>
             <a:ext cx="1254807" cy="523220"/>
           </a:xfrm>
           <a:prstGeom prst="rect">
@@ -8365,7 +8904,7 @@
         </p:nvSpPr>
         <p:spPr>
           <a:xfrm>
-            <a:off x="8435239" y="3772801"/>
+            <a:off x="8435239" y="4696345"/>
             <a:ext cx="965256" cy="340962"/>
           </a:xfrm>
           <a:prstGeom prst="rect">
@@ -8416,7 +8955,7 @@
         </p:nvCxnSpPr>
         <p:spPr>
           <a:xfrm>
-            <a:off x="8576682" y="1915755"/>
+            <a:off x="8576682" y="2839299"/>
             <a:ext cx="0" cy="1833968"/>
           </a:xfrm>
           <a:prstGeom prst="straightConnector1">
@@ -8463,7 +9002,7 @@
         </p:nvCxnSpPr>
         <p:spPr>
           <a:xfrm flipV="1">
-            <a:off x="8799075" y="1876796"/>
+            <a:off x="8799075" y="2800340"/>
             <a:ext cx="0" cy="1872927"/>
           </a:xfrm>
           <a:prstGeom prst="straightConnector1">
@@ -8508,7 +9047,7 @@
         </p:nvSpPr>
         <p:spPr>
           <a:xfrm>
-            <a:off x="8974494" y="3293628"/>
+            <a:off x="8974494" y="4217172"/>
             <a:ext cx="2215570" cy="307777"/>
           </a:xfrm>
           <a:prstGeom prst="rect">
@@ -8544,7 +9083,7 @@
         </p:nvSpPr>
         <p:spPr>
           <a:xfrm>
-            <a:off x="9419959" y="3588258"/>
+            <a:off x="9419959" y="4511802"/>
             <a:ext cx="2130657" cy="461665"/>
           </a:xfrm>
           <a:prstGeom prst="rect">
@@ -8581,7 +9120,7 @@
         </p:nvCxnSpPr>
         <p:spPr>
           <a:xfrm flipV="1">
-            <a:off x="4663006" y="643506"/>
+            <a:off x="4663006" y="1567050"/>
             <a:ext cx="620306" cy="0"/>
           </a:xfrm>
           <a:prstGeom prst="straightConnector1">
@@ -8626,7 +9165,7 @@
         </p:nvSpPr>
         <p:spPr>
           <a:xfrm>
-            <a:off x="5330009" y="497912"/>
+            <a:off x="5330009" y="1421456"/>
             <a:ext cx="2125740" cy="261610"/>
           </a:xfrm>
           <a:prstGeom prst="rect">
@@ -8669,7 +9208,7 @@
         </p:nvCxnSpPr>
         <p:spPr>
           <a:xfrm>
-            <a:off x="4677832" y="859864"/>
+            <a:off x="4677832" y="1783408"/>
             <a:ext cx="605480" cy="0"/>
           </a:xfrm>
           <a:prstGeom prst="straightConnector1">
@@ -8714,7 +9253,7 @@
         </p:nvSpPr>
         <p:spPr>
           <a:xfrm>
-            <a:off x="5337689" y="718641"/>
+            <a:off x="5337689" y="1642185"/>
             <a:ext cx="2125740" cy="261610"/>
           </a:xfrm>
           <a:prstGeom prst="rect">
@@ -8755,7 +9294,7 @@
         </p:nvSpPr>
         <p:spPr>
           <a:xfrm>
-            <a:off x="6519118" y="4294667"/>
+            <a:off x="6519118" y="5218211"/>
             <a:ext cx="965256" cy="340962"/>
           </a:xfrm>
           <a:prstGeom prst="rect">
@@ -8809,7 +9348,7 @@
         </p:nvCxnSpPr>
         <p:spPr>
           <a:xfrm rot="5400000" flipH="1" flipV="1">
-            <a:off x="5988932" y="4335955"/>
+            <a:off x="5988932" y="5259499"/>
             <a:ext cx="830203" cy="210638"/>
           </a:xfrm>
           <a:prstGeom prst="bentConnector2">
@@ -8849,7 +9388,7 @@
         </p:nvCxnSpPr>
         <p:spPr>
           <a:xfrm rot="10800000" flipV="1">
-            <a:off x="7484375" y="3943282"/>
+            <a:off x="7484375" y="4866826"/>
             <a:ext cx="950865" cy="521866"/>
           </a:xfrm>
           <a:prstGeom prst="bentConnector3">
@@ -8896,7 +9435,7 @@
         </p:nvSpPr>
         <p:spPr>
           <a:xfrm>
-            <a:off x="7141680" y="4697408"/>
+            <a:off x="7141680" y="5620952"/>
             <a:ext cx="1349727" cy="600164"/>
           </a:xfrm>
           <a:prstGeom prst="rect">
@@ -8927,6 +9466,56 @@
                 </a:schemeClr>
               </a:solidFill>
             </a:endParaRPr>
+          </a:p>
+        </p:txBody>
+      </p:sp>
+      <p:sp>
+        <p:nvSpPr>
+          <p:cNvPr id="6" name="TextBox 5">
+            <a:extLst>
+              <a:ext uri="{FF2B5EF4-FFF2-40B4-BE49-F238E27FC236}">
+                <a16:creationId xmlns:a16="http://schemas.microsoft.com/office/drawing/2014/main" id="{4BCBE11D-52C4-DBF1-0423-DCE2EF202234}"/>
+              </a:ext>
+            </a:extLst>
+          </p:cNvPr>
+          <p:cNvSpPr txBox="1"/>
+          <p:nvPr/>
+        </p:nvSpPr>
+        <p:spPr>
+          <a:xfrm>
+            <a:off x="489416" y="735860"/>
+            <a:ext cx="10632433" cy="461665"/>
+          </a:xfrm>
+          <a:prstGeom prst="rect">
+            <a:avLst/>
+          </a:prstGeom>
+          <a:noFill/>
+          <a:ln w="19050">
+            <a:solidFill>
+              <a:schemeClr val="tx1"/>
+            </a:solidFill>
+            <a:prstDash val="sysDash"/>
+          </a:ln>
+        </p:spPr>
+        <p:txBody>
+          <a:bodyPr wrap="square" rtlCol="0">
+            <a:spAutoFit/>
+          </a:bodyPr>
+          <a:lstStyle/>
+          <a:p>
+            <a:r>
+              <a:rPr lang="en-US" sz="2400" b="1" dirty="0"/>
+              <a:t> Python RTU/</a:t>
+            </a:r>
+            <a:r>
+              <a:rPr lang="en-US" sz="2400" b="1" dirty="0" err="1"/>
+              <a:t>IIoT</a:t>
+            </a:r>
+            <a:r>
+              <a:rPr lang="en-US" sz="2400" b="1" dirty="0"/>
+              <a:t> Simulator with IEC-20922 MQTT Communication Protocol</a:t>
+            </a:r>
+            <a:endParaRPr lang="en-SG" sz="2400" b="1" dirty="0"/>
           </a:p>
         </p:txBody>
       </p:sp>

</xml_diff>